<commit_message>
docs: clarify Model2 editing scope and dataset limitations
</commit_message>
<xml_diff>
--- a/rapor/final_2026/deliverables/CS395_Presentation_EfeHan_Keles_29September2026.pptx
+++ b/rapor/final_2026/deliverables/CS395_Presentation_EfeHan_Keles_29September2026.pptx
@@ -2,24 +2,24 @@
 <file path=ppt/presentation.xml><?xml version="1.0" encoding="utf-8"?>
 <p:presentation xmlns:p="http://schemas.openxmlformats.org/presentationml/2006/main">
   <p:sldMasterIdLst>
-    <p:sldMasterId xmlns:r="http://schemas.openxmlformats.org/officeDocument/2006/relationships" id="2147483648" r:id="Rcf4777bfce87440a"/>
+    <p:sldMasterId xmlns:r="http://schemas.openxmlformats.org/officeDocument/2006/relationships" id="2147483648" r:id="R7a2f37c4097f482f"/>
   </p:sldMasterIdLst>
   <p:notesMasterIdLst>
-    <p:notesMasterId xmlns:r="http://schemas.openxmlformats.org/officeDocument/2006/relationships" r:id="R9bdebd3deb614dd0"/>
+    <p:notesMasterId xmlns:r="http://schemas.openxmlformats.org/officeDocument/2006/relationships" r:id="Rda752303644a4470"/>
   </p:notesMasterIdLst>
   <p:sldIdLst>
-    <p:sldId xmlns:r="http://schemas.openxmlformats.org/officeDocument/2006/relationships" id="256" r:id="R7bc50f241e354b8a"/>
-    <p:sldId xmlns:r="http://schemas.openxmlformats.org/officeDocument/2006/relationships" id="257" r:id="R4528cd3163034ce9"/>
-    <p:sldId xmlns:r="http://schemas.openxmlformats.org/officeDocument/2006/relationships" id="258" r:id="Rbe0601bee4b94e6d"/>
-    <p:sldId xmlns:r="http://schemas.openxmlformats.org/officeDocument/2006/relationships" id="259" r:id="R56122c1d9c8d4e2f"/>
-    <p:sldId xmlns:r="http://schemas.openxmlformats.org/officeDocument/2006/relationships" id="260" r:id="R20df306d82134be4"/>
-    <p:sldId xmlns:r="http://schemas.openxmlformats.org/officeDocument/2006/relationships" id="261" r:id="Ree755ef148fc4e63"/>
-    <p:sldId xmlns:r="http://schemas.openxmlformats.org/officeDocument/2006/relationships" id="262" r:id="R49ceba6906ff4b7e"/>
-    <p:sldId xmlns:r="http://schemas.openxmlformats.org/officeDocument/2006/relationships" id="263" r:id="R77603d899a6e43a3"/>
-    <p:sldId xmlns:r="http://schemas.openxmlformats.org/officeDocument/2006/relationships" id="264" r:id="R1891951c44ab43a1"/>
-    <p:sldId xmlns:r="http://schemas.openxmlformats.org/officeDocument/2006/relationships" id="265" r:id="R6df9b0bed3224c8b"/>
-    <p:sldId xmlns:r="http://schemas.openxmlformats.org/officeDocument/2006/relationships" id="266" r:id="Rd80e366274d84ff5"/>
-    <p:sldId xmlns:r="http://schemas.openxmlformats.org/officeDocument/2006/relationships" id="267" r:id="R7f47aa0508ac4f09"/>
+    <p:sldId xmlns:r="http://schemas.openxmlformats.org/officeDocument/2006/relationships" id="256" r:id="R96336b47d96c45b0"/>
+    <p:sldId xmlns:r="http://schemas.openxmlformats.org/officeDocument/2006/relationships" id="257" r:id="R7de0d6b2fdbc48dd"/>
+    <p:sldId xmlns:r="http://schemas.openxmlformats.org/officeDocument/2006/relationships" id="258" r:id="R624ccb093e9a49f6"/>
+    <p:sldId xmlns:r="http://schemas.openxmlformats.org/officeDocument/2006/relationships" id="259" r:id="R1daac745951f4ebf"/>
+    <p:sldId xmlns:r="http://schemas.openxmlformats.org/officeDocument/2006/relationships" id="260" r:id="Re44f5b3e7e2c474a"/>
+    <p:sldId xmlns:r="http://schemas.openxmlformats.org/officeDocument/2006/relationships" id="261" r:id="R4af992e66385495a"/>
+    <p:sldId xmlns:r="http://schemas.openxmlformats.org/officeDocument/2006/relationships" id="262" r:id="Rc43c903c60f24f7a"/>
+    <p:sldId xmlns:r="http://schemas.openxmlformats.org/officeDocument/2006/relationships" id="263" r:id="Rfcb5affcd94e4441"/>
+    <p:sldId xmlns:r="http://schemas.openxmlformats.org/officeDocument/2006/relationships" id="264" r:id="R6a51f5d66b754c94"/>
+    <p:sldId xmlns:r="http://schemas.openxmlformats.org/officeDocument/2006/relationships" id="265" r:id="Rda47178a76a14348"/>
+    <p:sldId xmlns:r="http://schemas.openxmlformats.org/officeDocument/2006/relationships" id="266" r:id="Rb0933235d226480b"/>
+    <p:sldId xmlns:r="http://schemas.openxmlformats.org/officeDocument/2006/relationships" id="267" r:id="Rfe33e3ee624f4e32"/>
   </p:sldIdLst>
   <p:sldSz cx="12192000" cy="6858000"/>
   <p:notesSz cx="6858000" cy="9144000"/>
@@ -1483,7 +1483,7 @@
           </a:p>
           <a:p xmlns:a="http://schemas.openxmlformats.org/drawingml/2006/main">
             <a:r>
-              <a:t>Model2 explores a different question: where an AI edit might be located. It needs masks that show the true edited region, as well as authentic images for false-alarm checks. In a small pilot, moving edits reduced performance. Training on two placements helped the new placement, but harmed the original placement and highlighted more authentic image area incorrectly. The pilot used only sixteen previously used images and one editor. I rejected that candidate and kept Model2 experimental. It needs more independent images and editors before a useful reliability claim is possible.</a:t>
+              <a:t>Model2 asks where an AI edit is located. We found datasets, but source overlap and unclear masks prevented building a broad, validated training set. In our Stable Diffusion pilot, asking for a local edit also changed pixels outside the selected region. We therefore pasted only the generated region into the original and kept comparison controls. This gave us sixteen controlled examples from one editor, not broad coverage. Later training helped a new edit placement but harmed the original placement and increased false markings on real images. I rejected that candidate. These data and evaluation limits kept Model2 experimental.</a:t>
             </a:r>
           </a:p>
           <a:p xmlns:a="http://schemas.openxmlformats.org/drawingml/2006/main">
@@ -1493,7 +1493,7 @@
           </a:p>
           <a:p xmlns:a="http://schemas.openxmlformats.org/drawingml/2006/main">
             <a:r>
-              <a:t>Sources and optional detail (not spoken): Keleş (2026), E132–E135 and evidence/e135_location_learning.json. Optional Q&amp;A: original-placement pixel AUC .74 to .70; new-placement .57 to .64; authentic false area 17.11% to 25.74%. Moving edits also changes content, so this does not isolate location as the sole cause.</a:t>
+              <a:t>Sources and optional detail (not spoken): Keleş (2026), E105/E109/E117, E122/E127 and E129–E135. Optional Q&amp;A: 506/512 CocoGlide originals overlap protected ancestry; not proof of historical weight contamination. DiffSeg30k: 201 partial, 224 full-positive and 87 empty masks. E127: 11 accepted of 16 attempts, mean 99.9417% outside pixels changed and outside MAE 9.79/255; pixel change is not semantic change. Exact composites preserve outside pixels but introduce possible seam cues. E129 later passed all 16 engineering checks. E135 original/new-placement AUC .74→.70 / .57→.64; authentic false area 17.11%→25.74%. No ChatGPT pixel experiment or universal impossibility claim.</a:t>
             </a:r>
           </a:p>
         </p:txBody>
@@ -1561,7 +1561,7 @@
   </p:cSld>
   <p:clrMap bg1="lt1" tx1="dk1" bg2="lt2" tx2="dk2" accent1="accent1" accent2="accent2" accent3="accent3" accent4="accent4" accent5="accent5" accent6="accent6" hlink="hlink" folHlink="folHlink"/>
   <p:sldLayoutIdLst>
-    <p:sldLayoutId xmlns:r="http://schemas.openxmlformats.org/officeDocument/2006/relationships" id="2147483649" r:id="R79012f2a7b294ac2"/>
+    <p:sldLayoutId xmlns:r="http://schemas.openxmlformats.org/officeDocument/2006/relationships" id="2147483649" r:id="Ra0e38f0d1bb44cb1"/>
   </p:sldLayoutIdLst>
   <p:txStyles>
     <p:titleStyle>
@@ -2337,7 +2337,7 @@
           <p:cNvPr id="9" name="">
             <a:extLst xmlns:a="http://schemas.openxmlformats.org/drawingml/2006/main">
               <a:ext uri="{FF2B5EF4-FFF2-40B4-BE49-F238E27FC236}">
-                <a16:creationId xmlns:a16="http://schemas.microsoft.com/office/drawing/2014/main" id="{A2D750DC-0F10-44D7-859C-DC2397190A48}"/>
+                <a16:creationId xmlns:a16="http://schemas.microsoft.com/office/drawing/2014/main" id="{235EAF9B-FF6F-497B-B17D-2E2617796B87}"/>
               </a:ext>
             </a:extLst>
           </p:cNvPr>
@@ -2394,7 +2394,7 @@
           <p:cNvPr id="2" name="">
             <a:extLst xmlns:a="http://schemas.openxmlformats.org/drawingml/2006/main">
               <a:ext uri="{FF2B5EF4-FFF2-40B4-BE49-F238E27FC236}">
-                <a16:creationId xmlns:a16="http://schemas.microsoft.com/office/drawing/2014/main" id="{CBFD8580-12D9-4472-95F6-D447820D80AF}"/>
+                <a16:creationId xmlns:a16="http://schemas.microsoft.com/office/drawing/2014/main" id="{183E9280-11CB-4961-9AAF-BE65A0FB4869}"/>
               </a:ext>
             </a:extLst>
           </p:cNvPr>
@@ -2451,7 +2451,7 @@
           <p:cNvPr id="3" name="">
             <a:extLst xmlns:a="http://schemas.openxmlformats.org/drawingml/2006/main">
               <a:ext uri="{FF2B5EF4-FFF2-40B4-BE49-F238E27FC236}">
-                <a16:creationId xmlns:a16="http://schemas.microsoft.com/office/drawing/2014/main" id="{4525BB14-94CB-4C88-BC30-6386CD5A2508}"/>
+                <a16:creationId xmlns:a16="http://schemas.microsoft.com/office/drawing/2014/main" id="{22827097-1E0C-4D5F-AB56-239205620919}"/>
               </a:ext>
             </a:extLst>
           </p:cNvPr>
@@ -2508,7 +2508,7 @@
           <p:cNvPr id="4" name="">
             <a:extLst xmlns:a="http://schemas.openxmlformats.org/drawingml/2006/main">
               <a:ext uri="{FF2B5EF4-FFF2-40B4-BE49-F238E27FC236}">
-                <a16:creationId xmlns:a16="http://schemas.microsoft.com/office/drawing/2014/main" id="{2BDEC81B-3217-4D79-AFC5-A4CA52E169EC}"/>
+                <a16:creationId xmlns:a16="http://schemas.microsoft.com/office/drawing/2014/main" id="{7D30B8DB-15AB-4B34-95D1-532E17C6D04C}"/>
               </a:ext>
             </a:extLst>
           </p:cNvPr>
@@ -2565,7 +2565,7 @@
           <p:cNvPr id="5" name="">
             <a:extLst xmlns:a="http://schemas.openxmlformats.org/drawingml/2006/main">
               <a:ext uri="{FF2B5EF4-FFF2-40B4-BE49-F238E27FC236}">
-                <a16:creationId xmlns:a16="http://schemas.microsoft.com/office/drawing/2014/main" id="{0497AA6B-428E-411C-98A1-3A6224216C4D}"/>
+                <a16:creationId xmlns:a16="http://schemas.microsoft.com/office/drawing/2014/main" id="{FF6C0B09-1B52-4AAF-A095-D38043CECB1A}"/>
               </a:ext>
             </a:extLst>
           </p:cNvPr>
@@ -2645,7 +2645,7 @@
           <p:cNvPr id="6" name="">
             <a:extLst xmlns:a="http://schemas.openxmlformats.org/drawingml/2006/main">
               <a:ext uri="{FF2B5EF4-FFF2-40B4-BE49-F238E27FC236}">
-                <a16:creationId xmlns:a16="http://schemas.microsoft.com/office/drawing/2014/main" id="{F40B4FA8-73CC-4DB0-B884-EE5B5F0186C8}"/>
+                <a16:creationId xmlns:a16="http://schemas.microsoft.com/office/drawing/2014/main" id="{0A1B8247-A1B3-49F6-9262-D2DBEE91E7B5}"/>
               </a:ext>
             </a:extLst>
           </p:cNvPr>
@@ -2725,7 +2725,7 @@
           <p:cNvPr id="7" name="">
             <a:extLst xmlns:a="http://schemas.openxmlformats.org/drawingml/2006/main">
               <a:ext uri="{FF2B5EF4-FFF2-40B4-BE49-F238E27FC236}">
-                <a16:creationId xmlns:a16="http://schemas.microsoft.com/office/drawing/2014/main" id="{54022495-5DB4-4A41-BD8E-93F6BFC5386A}"/>
+                <a16:creationId xmlns:a16="http://schemas.microsoft.com/office/drawing/2014/main" id="{00474F51-976A-4D76-88DA-D106AE19E0F0}"/>
               </a:ext>
             </a:extLst>
           </p:cNvPr>
@@ -2805,7 +2805,7 @@
           <p:cNvPr id="8" name="">
             <a:extLst xmlns:a="http://schemas.openxmlformats.org/drawingml/2006/main">
               <a:ext uri="{FF2B5EF4-FFF2-40B4-BE49-F238E27FC236}">
-                <a16:creationId xmlns:a16="http://schemas.microsoft.com/office/drawing/2014/main" id="{B0679695-0A1A-447D-A449-72F70E540156}"/>
+                <a16:creationId xmlns:a16="http://schemas.microsoft.com/office/drawing/2014/main" id="{B00B6E7E-6A6B-45DC-B9AA-9836AB333642}"/>
               </a:ext>
             </a:extLst>
           </p:cNvPr>
@@ -2860,7 +2860,7 @@
     </p:spTree>
     <p:extLst>
       <p:ext uri="{BB962C8B-B14F-4D97-AF65-F5344CB8AC3E}">
-        <p14:creationId xmlns:p14="http://schemas.microsoft.com/office/powerpoint/2010/main" val="1005170562"/>
+        <p14:creationId xmlns:p14="http://schemas.microsoft.com/office/powerpoint/2010/main" val="1297110807"/>
       </p:ext>
     </p:extLst>
   </p:cSld>
@@ -2891,7 +2891,7 @@
           <p:cNvPr id="8" name="">
             <a:extLst xmlns:a="http://schemas.openxmlformats.org/drawingml/2006/main">
               <a:ext uri="{FF2B5EF4-FFF2-40B4-BE49-F238E27FC236}">
-                <a16:creationId xmlns:a16="http://schemas.microsoft.com/office/drawing/2014/main" id="{59E24D5A-599C-4E39-B875-9717A420FBBC}"/>
+                <a16:creationId xmlns:a16="http://schemas.microsoft.com/office/drawing/2014/main" id="{BF5F9CB1-3CD2-410F-A75F-B19AC462FFEF}"/>
               </a:ext>
             </a:extLst>
           </p:cNvPr>
@@ -2948,7 +2948,7 @@
           <p:cNvPr id="2" name="">
             <a:extLst xmlns:a="http://schemas.openxmlformats.org/drawingml/2006/main">
               <a:ext uri="{FF2B5EF4-FFF2-40B4-BE49-F238E27FC236}">
-                <a16:creationId xmlns:a16="http://schemas.microsoft.com/office/drawing/2014/main" id="{F86735E3-421F-4BDA-96D3-FB28E1F1E99E}"/>
+                <a16:creationId xmlns:a16="http://schemas.microsoft.com/office/drawing/2014/main" id="{2821365A-C6D6-4EF9-BA98-87AD84307C9B}"/>
               </a:ext>
             </a:extLst>
           </p:cNvPr>
@@ -3005,7 +3005,7 @@
           <p:cNvPr id="3" name="">
             <a:extLst xmlns:a="http://schemas.openxmlformats.org/drawingml/2006/main">
               <a:ext uri="{FF2B5EF4-FFF2-40B4-BE49-F238E27FC236}">
-                <a16:creationId xmlns:a16="http://schemas.microsoft.com/office/drawing/2014/main" id="{98C57498-1AB0-4776-9B4E-D34825417AE3}"/>
+                <a16:creationId xmlns:a16="http://schemas.microsoft.com/office/drawing/2014/main" id="{1CB344C8-AE5E-4FA9-9CDA-8E6C3E3DB5B6}"/>
               </a:ext>
             </a:extLst>
           </p:cNvPr>
@@ -3062,7 +3062,7 @@
           <p:cNvPr id="4" name="">
             <a:extLst xmlns:a="http://schemas.openxmlformats.org/drawingml/2006/main">
               <a:ext uri="{FF2B5EF4-FFF2-40B4-BE49-F238E27FC236}">
-                <a16:creationId xmlns:a16="http://schemas.microsoft.com/office/drawing/2014/main" id="{FABCAE7F-2290-4711-B66B-74B0AFA04309}"/>
+                <a16:creationId xmlns:a16="http://schemas.microsoft.com/office/drawing/2014/main" id="{575BEE01-8E95-4845-A3AF-755A5456328A}"/>
               </a:ext>
             </a:extLst>
           </p:cNvPr>
@@ -3119,7 +3119,7 @@
           <p:cNvPr id="5" name="">
             <a:extLst xmlns:a="http://schemas.openxmlformats.org/drawingml/2006/main">
               <a:ext uri="{FF2B5EF4-FFF2-40B4-BE49-F238E27FC236}">
-                <a16:creationId xmlns:a16="http://schemas.microsoft.com/office/drawing/2014/main" id="{67C65F94-222B-4E1D-9A7D-9CBF745AF71C}"/>
+                <a16:creationId xmlns:a16="http://schemas.microsoft.com/office/drawing/2014/main" id="{643B599B-6C85-4DDF-ABFC-15E79C91ACBF}"/>
               </a:ext>
             </a:extLst>
           </p:cNvPr>
@@ -3422,7 +3422,7 @@
           <p:cNvPr id="7" name="">
             <a:extLst xmlns:a="http://schemas.openxmlformats.org/drawingml/2006/main">
               <a:ext uri="{FF2B5EF4-FFF2-40B4-BE49-F238E27FC236}">
-                <a16:creationId xmlns:a16="http://schemas.microsoft.com/office/drawing/2014/main" id="{6BCF29A3-53B1-45D7-B8AA-181CC6E32C42}"/>
+                <a16:creationId xmlns:a16="http://schemas.microsoft.com/office/drawing/2014/main" id="{F2BA54A9-58AC-4653-84D3-C796DE3D2329}"/>
               </a:ext>
             </a:extLst>
           </p:cNvPr>
@@ -3477,7 +3477,7 @@
     </p:spTree>
     <p:extLst>
       <p:ext uri="{BB962C8B-B14F-4D97-AF65-F5344CB8AC3E}">
-        <p14:creationId xmlns:p14="http://schemas.microsoft.com/office/powerpoint/2010/main" val="1839937920"/>
+        <p14:creationId xmlns:p14="http://schemas.microsoft.com/office/powerpoint/2010/main" val="86200445"/>
       </p:ext>
     </p:extLst>
   </p:cSld>
@@ -3508,7 +3508,7 @@
           <p:cNvPr id="12" name="">
             <a:extLst xmlns:a="http://schemas.openxmlformats.org/drawingml/2006/main">
               <a:ext uri="{FF2B5EF4-FFF2-40B4-BE49-F238E27FC236}">
-                <a16:creationId xmlns:a16="http://schemas.microsoft.com/office/drawing/2014/main" id="{234DDD83-B025-468C-80E8-C8DE65E08344}"/>
+                <a16:creationId xmlns:a16="http://schemas.microsoft.com/office/drawing/2014/main" id="{F883EF35-F089-468D-B8D2-0099AB34DBE4}"/>
               </a:ext>
             </a:extLst>
           </p:cNvPr>
@@ -3565,7 +3565,7 @@
           <p:cNvPr id="2" name="">
             <a:extLst xmlns:a="http://schemas.openxmlformats.org/drawingml/2006/main">
               <a:ext uri="{FF2B5EF4-FFF2-40B4-BE49-F238E27FC236}">
-                <a16:creationId xmlns:a16="http://schemas.microsoft.com/office/drawing/2014/main" id="{AD1ABC8F-5116-4181-A73F-7DF9F8E2D9E9}"/>
+                <a16:creationId xmlns:a16="http://schemas.microsoft.com/office/drawing/2014/main" id="{D0FEBEF4-95B9-446E-B6E1-442ED304024A}"/>
               </a:ext>
             </a:extLst>
           </p:cNvPr>
@@ -3622,7 +3622,7 @@
           <p:cNvPr id="3" name="">
             <a:extLst xmlns:a="http://schemas.openxmlformats.org/drawingml/2006/main">
               <a:ext uri="{FF2B5EF4-FFF2-40B4-BE49-F238E27FC236}">
-                <a16:creationId xmlns:a16="http://schemas.microsoft.com/office/drawing/2014/main" id="{18B29054-C39C-478E-AF07-63EA62AF8FB6}"/>
+                <a16:creationId xmlns:a16="http://schemas.microsoft.com/office/drawing/2014/main" id="{A2D81C22-765C-4BD4-BD2C-426676008017}"/>
               </a:ext>
             </a:extLst>
           </p:cNvPr>
@@ -3679,7 +3679,7 @@
           <p:cNvPr id="4" name="">
             <a:extLst xmlns:a="http://schemas.openxmlformats.org/drawingml/2006/main">
               <a:ext uri="{FF2B5EF4-FFF2-40B4-BE49-F238E27FC236}">
-                <a16:creationId xmlns:a16="http://schemas.microsoft.com/office/drawing/2014/main" id="{DA30813A-D94A-4AB4-A271-B41FF339CB47}"/>
+                <a16:creationId xmlns:a16="http://schemas.microsoft.com/office/drawing/2014/main" id="{A9B185AB-8C0D-4FE3-9531-3C1EEC5F880A}"/>
               </a:ext>
             </a:extLst>
           </p:cNvPr>
@@ -3736,7 +3736,7 @@
           <p:cNvPr id="5" name="">
             <a:extLst xmlns:a="http://schemas.openxmlformats.org/drawingml/2006/main">
               <a:ext uri="{FF2B5EF4-FFF2-40B4-BE49-F238E27FC236}">
-                <a16:creationId xmlns:a16="http://schemas.microsoft.com/office/drawing/2014/main" id="{14808BB6-2A53-4DB0-BD36-3DFD6C3648B1}"/>
+                <a16:creationId xmlns:a16="http://schemas.microsoft.com/office/drawing/2014/main" id="{513B178E-E54F-4BB7-B720-90DF218B15B6}"/>
               </a:ext>
             </a:extLst>
           </p:cNvPr>
@@ -3793,7 +3793,7 @@
           <p:cNvPr id="6" name="">
             <a:extLst xmlns:a="http://schemas.openxmlformats.org/drawingml/2006/main">
               <a:ext uri="{FF2B5EF4-FFF2-40B4-BE49-F238E27FC236}">
-                <a16:creationId xmlns:a16="http://schemas.microsoft.com/office/drawing/2014/main" id="{A3E03570-1FA3-4796-9E84-4ECFB5DF801D}"/>
+                <a16:creationId xmlns:a16="http://schemas.microsoft.com/office/drawing/2014/main" id="{9C196858-6DD1-4DF5-8F37-82CF9215DE38}"/>
               </a:ext>
             </a:extLst>
           </p:cNvPr>
@@ -3850,7 +3850,7 @@
           <p:cNvPr id="7" name="">
             <a:extLst xmlns:a="http://schemas.openxmlformats.org/drawingml/2006/main">
               <a:ext uri="{FF2B5EF4-FFF2-40B4-BE49-F238E27FC236}">
-                <a16:creationId xmlns:a16="http://schemas.microsoft.com/office/drawing/2014/main" id="{BB4D4BD7-65CD-4D98-9BEB-F32929ED0084}"/>
+                <a16:creationId xmlns:a16="http://schemas.microsoft.com/office/drawing/2014/main" id="{571A1B62-15B8-41CB-A4F6-F5FEEA589181}"/>
               </a:ext>
             </a:extLst>
           </p:cNvPr>
@@ -3907,7 +3907,7 @@
           <p:cNvPr id="8" name="">
             <a:extLst xmlns:a="http://schemas.openxmlformats.org/drawingml/2006/main">
               <a:ext uri="{FF2B5EF4-FFF2-40B4-BE49-F238E27FC236}">
-                <a16:creationId xmlns:a16="http://schemas.microsoft.com/office/drawing/2014/main" id="{B43531F1-3E2C-49ED-A23B-84820C852165}"/>
+                <a16:creationId xmlns:a16="http://schemas.microsoft.com/office/drawing/2014/main" id="{C4B064DC-00C2-459C-8AEB-0CD7213889F1}"/>
               </a:ext>
             </a:extLst>
           </p:cNvPr>
@@ -3964,7 +3964,7 @@
           <p:cNvPr id="9" name="">
             <a:extLst xmlns:a="http://schemas.openxmlformats.org/drawingml/2006/main">
               <a:ext uri="{FF2B5EF4-FFF2-40B4-BE49-F238E27FC236}">
-                <a16:creationId xmlns:a16="http://schemas.microsoft.com/office/drawing/2014/main" id="{5B800C55-D84F-48E6-9799-405C0AF03DE1}"/>
+                <a16:creationId xmlns:a16="http://schemas.microsoft.com/office/drawing/2014/main" id="{684BF5C1-1881-4814-A4AE-292AF9C90DB2}"/>
               </a:ext>
             </a:extLst>
           </p:cNvPr>
@@ -4021,7 +4021,7 @@
           <p:cNvPr id="10" name="">
             <a:extLst xmlns:a="http://schemas.openxmlformats.org/drawingml/2006/main">
               <a:ext uri="{FF2B5EF4-FFF2-40B4-BE49-F238E27FC236}">
-                <a16:creationId xmlns:a16="http://schemas.microsoft.com/office/drawing/2014/main" id="{2AD5AC2E-E668-4FB3-B854-2DEE674CE505}"/>
+                <a16:creationId xmlns:a16="http://schemas.microsoft.com/office/drawing/2014/main" id="{FD273CA2-91A5-4003-ADF2-6F0815DA676F}"/>
               </a:ext>
             </a:extLst>
           </p:cNvPr>
@@ -4078,7 +4078,7 @@
           <p:cNvPr id="11" name="">
             <a:extLst xmlns:a="http://schemas.openxmlformats.org/drawingml/2006/main">
               <a:ext uri="{FF2B5EF4-FFF2-40B4-BE49-F238E27FC236}">
-                <a16:creationId xmlns:a16="http://schemas.microsoft.com/office/drawing/2014/main" id="{48961912-0EC3-421D-B153-CE696A9D2F1E}"/>
+                <a16:creationId xmlns:a16="http://schemas.microsoft.com/office/drawing/2014/main" id="{5A0630DC-3258-4921-8A9B-F48F17655FB1}"/>
               </a:ext>
             </a:extLst>
           </p:cNvPr>
@@ -4133,7 +4133,7 @@
     </p:spTree>
     <p:extLst>
       <p:ext uri="{BB962C8B-B14F-4D97-AF65-F5344CB8AC3E}">
-        <p14:creationId xmlns:p14="http://schemas.microsoft.com/office/powerpoint/2010/main" val="1673912773"/>
+        <p14:creationId xmlns:p14="http://schemas.microsoft.com/office/powerpoint/2010/main" val="2109881724"/>
       </p:ext>
     </p:extLst>
   </p:cSld>
@@ -4164,7 +4164,7 @@
           <p:cNvPr id="12" name="">
             <a:extLst xmlns:a="http://schemas.openxmlformats.org/drawingml/2006/main">
               <a:ext uri="{FF2B5EF4-FFF2-40B4-BE49-F238E27FC236}">
-                <a16:creationId xmlns:a16="http://schemas.microsoft.com/office/drawing/2014/main" id="{90C41E32-0BA5-4918-84EE-DEE84E302293}"/>
+                <a16:creationId xmlns:a16="http://schemas.microsoft.com/office/drawing/2014/main" id="{76E0F845-826B-4787-9FED-638A2EB33C8B}"/>
               </a:ext>
             </a:extLst>
           </p:cNvPr>
@@ -4221,7 +4221,7 @@
           <p:cNvPr id="2" name="">
             <a:extLst xmlns:a="http://schemas.openxmlformats.org/drawingml/2006/main">
               <a:ext uri="{FF2B5EF4-FFF2-40B4-BE49-F238E27FC236}">
-                <a16:creationId xmlns:a16="http://schemas.microsoft.com/office/drawing/2014/main" id="{F59263B7-5E57-4C4F-92AD-F4D637B772C2}"/>
+                <a16:creationId xmlns:a16="http://schemas.microsoft.com/office/drawing/2014/main" id="{325C2629-9C42-4FFD-9BA1-CF2F734F4536}"/>
               </a:ext>
             </a:extLst>
           </p:cNvPr>
@@ -4278,7 +4278,7 @@
           <p:cNvPr id="3" name="">
             <a:extLst xmlns:a="http://schemas.openxmlformats.org/drawingml/2006/main">
               <a:ext uri="{FF2B5EF4-FFF2-40B4-BE49-F238E27FC236}">
-                <a16:creationId xmlns:a16="http://schemas.microsoft.com/office/drawing/2014/main" id="{F1EACEFE-F46B-4BE7-9F40-BA76BAE9D66F}"/>
+                <a16:creationId xmlns:a16="http://schemas.microsoft.com/office/drawing/2014/main" id="{8831E254-4F48-4AFF-B944-5D8F35C58775}"/>
               </a:ext>
             </a:extLst>
           </p:cNvPr>
@@ -4335,7 +4335,7 @@
           <p:cNvPr id="4" name="">
             <a:extLst xmlns:a="http://schemas.openxmlformats.org/drawingml/2006/main">
               <a:ext uri="{FF2B5EF4-FFF2-40B4-BE49-F238E27FC236}">
-                <a16:creationId xmlns:a16="http://schemas.microsoft.com/office/drawing/2014/main" id="{1B52FEDC-5F27-4F59-A085-69867530FC33}"/>
+                <a16:creationId xmlns:a16="http://schemas.microsoft.com/office/drawing/2014/main" id="{42008862-3A04-49A6-A0C1-ACE553D5AC63}"/>
               </a:ext>
             </a:extLst>
           </p:cNvPr>
@@ -4392,7 +4392,7 @@
           <p:cNvPr id="5" name="">
             <a:extLst xmlns:a="http://schemas.openxmlformats.org/drawingml/2006/main">
               <a:ext uri="{FF2B5EF4-FFF2-40B4-BE49-F238E27FC236}">
-                <a16:creationId xmlns:a16="http://schemas.microsoft.com/office/drawing/2014/main" id="{2FE35823-4700-4F6C-B11A-7C8D216D5C45}"/>
+                <a16:creationId xmlns:a16="http://schemas.microsoft.com/office/drawing/2014/main" id="{9C4F5E6B-960F-4B89-92B5-F3E921E1997C}"/>
               </a:ext>
             </a:extLst>
           </p:cNvPr>
@@ -4449,7 +4449,7 @@
           <p:cNvPr id="6" name="">
             <a:extLst xmlns:a="http://schemas.openxmlformats.org/drawingml/2006/main">
               <a:ext uri="{FF2B5EF4-FFF2-40B4-BE49-F238E27FC236}">
-                <a16:creationId xmlns:a16="http://schemas.microsoft.com/office/drawing/2014/main" id="{7F037127-032A-4678-8516-E17E5C25E4B1}"/>
+                <a16:creationId xmlns:a16="http://schemas.microsoft.com/office/drawing/2014/main" id="{368C4C50-E97A-4AA0-B2A6-B3D8692D407A}"/>
               </a:ext>
             </a:extLst>
           </p:cNvPr>
@@ -4506,7 +4506,7 @@
           <p:cNvPr id="7" name="">
             <a:extLst xmlns:a="http://schemas.openxmlformats.org/drawingml/2006/main">
               <a:ext uri="{FF2B5EF4-FFF2-40B4-BE49-F238E27FC236}">
-                <a16:creationId xmlns:a16="http://schemas.microsoft.com/office/drawing/2014/main" id="{F662F7E7-0773-42F7-A194-6D1FF420B45B}"/>
+                <a16:creationId xmlns:a16="http://schemas.microsoft.com/office/drawing/2014/main" id="{47C14471-462F-4D42-BDEA-9E2CA859C2E2}"/>
               </a:ext>
             </a:extLst>
           </p:cNvPr>
@@ -4563,7 +4563,7 @@
           <p:cNvPr id="8" name="">
             <a:extLst xmlns:a="http://schemas.openxmlformats.org/drawingml/2006/main">
               <a:ext uri="{FF2B5EF4-FFF2-40B4-BE49-F238E27FC236}">
-                <a16:creationId xmlns:a16="http://schemas.microsoft.com/office/drawing/2014/main" id="{97C5BBE5-8A29-4EA1-8127-5B787521564A}"/>
+                <a16:creationId xmlns:a16="http://schemas.microsoft.com/office/drawing/2014/main" id="{3484FB69-96CE-43B8-A858-BFA1A2E025EA}"/>
               </a:ext>
             </a:extLst>
           </p:cNvPr>
@@ -4620,7 +4620,7 @@
           <p:cNvPr id="9" name="">
             <a:extLst xmlns:a="http://schemas.openxmlformats.org/drawingml/2006/main">
               <a:ext uri="{FF2B5EF4-FFF2-40B4-BE49-F238E27FC236}">
-                <a16:creationId xmlns:a16="http://schemas.microsoft.com/office/drawing/2014/main" id="{788A3416-36FF-4F93-9E92-35B812B09300}"/>
+                <a16:creationId xmlns:a16="http://schemas.microsoft.com/office/drawing/2014/main" id="{F1AF5A73-D4C5-41A7-8195-2DDE0E216B5B}"/>
               </a:ext>
             </a:extLst>
           </p:cNvPr>
@@ -4677,7 +4677,7 @@
           <p:cNvPr id="10" name="">
             <a:extLst xmlns:a="http://schemas.openxmlformats.org/drawingml/2006/main">
               <a:ext uri="{FF2B5EF4-FFF2-40B4-BE49-F238E27FC236}">
-                <a16:creationId xmlns:a16="http://schemas.microsoft.com/office/drawing/2014/main" id="{30BC56B6-39E3-4405-AA13-D8003333193D}"/>
+                <a16:creationId xmlns:a16="http://schemas.microsoft.com/office/drawing/2014/main" id="{5DB50755-D3B2-41C4-9602-0A4F43ED060F}"/>
               </a:ext>
             </a:extLst>
           </p:cNvPr>
@@ -4734,7 +4734,7 @@
           <p:cNvPr id="11" name="">
             <a:extLst xmlns:a="http://schemas.openxmlformats.org/drawingml/2006/main">
               <a:ext uri="{FF2B5EF4-FFF2-40B4-BE49-F238E27FC236}">
-                <a16:creationId xmlns:a16="http://schemas.microsoft.com/office/drawing/2014/main" id="{545DE699-7332-4159-A12B-4B85176F139E}"/>
+                <a16:creationId xmlns:a16="http://schemas.microsoft.com/office/drawing/2014/main" id="{03031FA4-0A00-4557-B6F8-D2311FA5EB04}"/>
               </a:ext>
             </a:extLst>
           </p:cNvPr>
@@ -4789,7 +4789,7 @@
     </p:spTree>
     <p:extLst>
       <p:ext uri="{BB962C8B-B14F-4D97-AF65-F5344CB8AC3E}">
-        <p14:creationId xmlns:p14="http://schemas.microsoft.com/office/powerpoint/2010/main" val="827387518"/>
+        <p14:creationId xmlns:p14="http://schemas.microsoft.com/office/powerpoint/2010/main" val="2042230017"/>
       </p:ext>
     </p:extLst>
   </p:cSld>
@@ -4820,7 +4820,7 @@
           <p:cNvPr id="7" name="">
             <a:extLst xmlns:a="http://schemas.openxmlformats.org/drawingml/2006/main">
               <a:ext uri="{FF2B5EF4-FFF2-40B4-BE49-F238E27FC236}">
-                <a16:creationId xmlns:a16="http://schemas.microsoft.com/office/drawing/2014/main" id="{C64E4250-577B-4AC8-B4A6-6FF95FE6E335}"/>
+                <a16:creationId xmlns:a16="http://schemas.microsoft.com/office/drawing/2014/main" id="{4A7E2DB6-31EE-4CD6-BDC2-31237BF05E78}"/>
               </a:ext>
             </a:extLst>
           </p:cNvPr>
@@ -4877,7 +4877,7 @@
           <p:cNvPr id="2" name="">
             <a:extLst xmlns:a="http://schemas.openxmlformats.org/drawingml/2006/main">
               <a:ext uri="{FF2B5EF4-FFF2-40B4-BE49-F238E27FC236}">
-                <a16:creationId xmlns:a16="http://schemas.microsoft.com/office/drawing/2014/main" id="{D616C665-FDC7-4FE7-A489-E45DB4975F87}"/>
+                <a16:creationId xmlns:a16="http://schemas.microsoft.com/office/drawing/2014/main" id="{C881F7C9-26C4-4B28-8B13-5BE19A49FDC2}"/>
               </a:ext>
             </a:extLst>
           </p:cNvPr>
@@ -4934,7 +4934,7 @@
           <p:cNvPr id="3" name="">
             <a:extLst xmlns:a="http://schemas.openxmlformats.org/drawingml/2006/main">
               <a:ext uri="{FF2B5EF4-FFF2-40B4-BE49-F238E27FC236}">
-                <a16:creationId xmlns:a16="http://schemas.microsoft.com/office/drawing/2014/main" id="{3C0A8492-9085-43A8-B3EC-DA23DBA5E24F}"/>
+                <a16:creationId xmlns:a16="http://schemas.microsoft.com/office/drawing/2014/main" id="{56B38471-2433-4DFE-97FD-61EDA3979868}"/>
               </a:ext>
             </a:extLst>
           </p:cNvPr>
@@ -4991,7 +4991,7 @@
           <p:cNvPr id="4" name="">
             <a:extLst xmlns:a="http://schemas.openxmlformats.org/drawingml/2006/main">
               <a:ext uri="{FF2B5EF4-FFF2-40B4-BE49-F238E27FC236}">
-                <a16:creationId xmlns:a16="http://schemas.microsoft.com/office/drawing/2014/main" id="{A11223DF-1746-4C41-8429-2F34819BD78C}"/>
+                <a16:creationId xmlns:a16="http://schemas.microsoft.com/office/drawing/2014/main" id="{603E2276-A160-4D0B-82BC-570CE3C5C79E}"/>
               </a:ext>
             </a:extLst>
           </p:cNvPr>
@@ -5048,7 +5048,7 @@
           <p:cNvPr id="5" name="">
             <a:extLst xmlns:a="http://schemas.openxmlformats.org/drawingml/2006/main">
               <a:ext uri="{FF2B5EF4-FFF2-40B4-BE49-F238E27FC236}">
-                <a16:creationId xmlns:a16="http://schemas.microsoft.com/office/drawing/2014/main" id="{0DE4B8BA-0166-4785-B88F-169AF94EC3AC}"/>
+                <a16:creationId xmlns:a16="http://schemas.microsoft.com/office/drawing/2014/main" id="{E56FFC58-545B-46EF-9DC9-9C445D410313}"/>
               </a:ext>
             </a:extLst>
           </p:cNvPr>
@@ -5105,7 +5105,7 @@
           <p:cNvPr id="6" name="">
             <a:extLst xmlns:a="http://schemas.openxmlformats.org/drawingml/2006/main">
               <a:ext uri="{FF2B5EF4-FFF2-40B4-BE49-F238E27FC236}">
-                <a16:creationId xmlns:a16="http://schemas.microsoft.com/office/drawing/2014/main" id="{598CF434-5386-4225-A5DA-5CEBBA005208}"/>
+                <a16:creationId xmlns:a16="http://schemas.microsoft.com/office/drawing/2014/main" id="{7323C1BC-0E71-4554-98E3-0AB63E4734AE}"/>
               </a:ext>
             </a:extLst>
           </p:cNvPr>
@@ -5183,7 +5183,7 @@
     </p:spTree>
     <p:extLst>
       <p:ext uri="{BB962C8B-B14F-4D97-AF65-F5344CB8AC3E}">
-        <p14:creationId xmlns:p14="http://schemas.microsoft.com/office/powerpoint/2010/main" val="517989377"/>
+        <p14:creationId xmlns:p14="http://schemas.microsoft.com/office/powerpoint/2010/main" val="1833625751"/>
       </p:ext>
     </p:extLst>
   </p:cSld>
@@ -5214,7 +5214,7 @@
           <p:cNvPr id="8" name="">
             <a:extLst xmlns:a="http://schemas.openxmlformats.org/drawingml/2006/main">
               <a:ext uri="{FF2B5EF4-FFF2-40B4-BE49-F238E27FC236}">
-                <a16:creationId xmlns:a16="http://schemas.microsoft.com/office/drawing/2014/main" id="{5D095718-75EB-4BFA-8C59-2BBFD4888D73}"/>
+                <a16:creationId xmlns:a16="http://schemas.microsoft.com/office/drawing/2014/main" id="{3827A1C6-BF7C-48E8-A1B4-E5848D316D92}"/>
               </a:ext>
             </a:extLst>
           </p:cNvPr>
@@ -5271,7 +5271,7 @@
           <p:cNvPr id="2" name="">
             <a:extLst xmlns:a="http://schemas.openxmlformats.org/drawingml/2006/main">
               <a:ext uri="{FF2B5EF4-FFF2-40B4-BE49-F238E27FC236}">
-                <a16:creationId xmlns:a16="http://schemas.microsoft.com/office/drawing/2014/main" id="{A9D415D7-CF8D-4630-8491-3EF7FC976C18}"/>
+                <a16:creationId xmlns:a16="http://schemas.microsoft.com/office/drawing/2014/main" id="{FB96AD7C-1A30-40BC-98DA-E38553969D2F}"/>
               </a:ext>
             </a:extLst>
           </p:cNvPr>
@@ -5328,7 +5328,7 @@
           <p:cNvPr id="3" name="">
             <a:extLst xmlns:a="http://schemas.openxmlformats.org/drawingml/2006/main">
               <a:ext uri="{FF2B5EF4-FFF2-40B4-BE49-F238E27FC236}">
-                <a16:creationId xmlns:a16="http://schemas.microsoft.com/office/drawing/2014/main" id="{A19DD18A-C7E9-4091-AEDA-87A54BCF9D23}"/>
+                <a16:creationId xmlns:a16="http://schemas.microsoft.com/office/drawing/2014/main" id="{0A37E177-2B8E-4E7F-B7F2-EFBC1BD0CED1}"/>
               </a:ext>
             </a:extLst>
           </p:cNvPr>
@@ -5385,7 +5385,7 @@
           <p:cNvPr id="4" name="">
             <a:extLst xmlns:a="http://schemas.openxmlformats.org/drawingml/2006/main">
               <a:ext uri="{FF2B5EF4-FFF2-40B4-BE49-F238E27FC236}">
-                <a16:creationId xmlns:a16="http://schemas.microsoft.com/office/drawing/2014/main" id="{64F9CFC2-C16E-4CED-891B-8544C61F52EB}"/>
+                <a16:creationId xmlns:a16="http://schemas.microsoft.com/office/drawing/2014/main" id="{1E239B37-EB86-478A-BE9A-39B408A26957}"/>
               </a:ext>
             </a:extLst>
           </p:cNvPr>
@@ -5442,7 +5442,7 @@
           <p:cNvPr id="5" name="">
             <a:extLst xmlns:a="http://schemas.openxmlformats.org/drawingml/2006/main">
               <a:ext uri="{FF2B5EF4-FFF2-40B4-BE49-F238E27FC236}">
-                <a16:creationId xmlns:a16="http://schemas.microsoft.com/office/drawing/2014/main" id="{3B549449-4C4F-49A8-B3D6-AD3C01B3DC12}"/>
+                <a16:creationId xmlns:a16="http://schemas.microsoft.com/office/drawing/2014/main" id="{62D65B91-ADF5-474C-9DD6-221D12AA17FF}"/>
               </a:ext>
             </a:extLst>
           </p:cNvPr>
@@ -5689,7 +5689,7 @@
           <p:cNvPr id="7" name="">
             <a:extLst xmlns:a="http://schemas.openxmlformats.org/drawingml/2006/main">
               <a:ext uri="{FF2B5EF4-FFF2-40B4-BE49-F238E27FC236}">
-                <a16:creationId xmlns:a16="http://schemas.microsoft.com/office/drawing/2014/main" id="{19A83638-1624-4F98-BE03-9BABB1D04EE0}"/>
+                <a16:creationId xmlns:a16="http://schemas.microsoft.com/office/drawing/2014/main" id="{DCDFC605-5EF9-41D5-80AB-D4D135A5200B}"/>
               </a:ext>
             </a:extLst>
           </p:cNvPr>
@@ -5744,7 +5744,7 @@
     </p:spTree>
     <p:extLst>
       <p:ext uri="{BB962C8B-B14F-4D97-AF65-F5344CB8AC3E}">
-        <p14:creationId xmlns:p14="http://schemas.microsoft.com/office/powerpoint/2010/main" val="2062824894"/>
+        <p14:creationId xmlns:p14="http://schemas.microsoft.com/office/powerpoint/2010/main" val="1277582039"/>
       </p:ext>
     </p:extLst>
   </p:cSld>
@@ -5775,7 +5775,7 @@
           <p:cNvPr id="9" name="">
             <a:extLst xmlns:a="http://schemas.openxmlformats.org/drawingml/2006/main">
               <a:ext uri="{FF2B5EF4-FFF2-40B4-BE49-F238E27FC236}">
-                <a16:creationId xmlns:a16="http://schemas.microsoft.com/office/drawing/2014/main" id="{6BA69FD1-B23C-4D67-95B8-20B873FC6263}"/>
+                <a16:creationId xmlns:a16="http://schemas.microsoft.com/office/drawing/2014/main" id="{114FA131-F500-433E-B0A9-D67E664456CB}"/>
               </a:ext>
             </a:extLst>
           </p:cNvPr>
@@ -5832,7 +5832,7 @@
           <p:cNvPr id="2" name="">
             <a:extLst xmlns:a="http://schemas.openxmlformats.org/drawingml/2006/main">
               <a:ext uri="{FF2B5EF4-FFF2-40B4-BE49-F238E27FC236}">
-                <a16:creationId xmlns:a16="http://schemas.microsoft.com/office/drawing/2014/main" id="{85D17D75-FAF6-4A56-A66C-3A888D62C69B}"/>
+                <a16:creationId xmlns:a16="http://schemas.microsoft.com/office/drawing/2014/main" id="{AF5E6F82-3DFC-455F-BCF8-09A3BF318DEF}"/>
               </a:ext>
             </a:extLst>
           </p:cNvPr>
@@ -5889,7 +5889,7 @@
           <p:cNvPr id="3" name="">
             <a:extLst xmlns:a="http://schemas.openxmlformats.org/drawingml/2006/main">
               <a:ext uri="{FF2B5EF4-FFF2-40B4-BE49-F238E27FC236}">
-                <a16:creationId xmlns:a16="http://schemas.microsoft.com/office/drawing/2014/main" id="{4D66D28B-6E12-4BF8-A1BD-9C39283D4B21}"/>
+                <a16:creationId xmlns:a16="http://schemas.microsoft.com/office/drawing/2014/main" id="{9F7D909C-9A7E-4F62-88A1-3617889A0BA9}"/>
               </a:ext>
             </a:extLst>
           </p:cNvPr>
@@ -5946,7 +5946,7 @@
           <p:cNvPr id="4" name="">
             <a:extLst xmlns:a="http://schemas.openxmlformats.org/drawingml/2006/main">
               <a:ext uri="{FF2B5EF4-FFF2-40B4-BE49-F238E27FC236}">
-                <a16:creationId xmlns:a16="http://schemas.microsoft.com/office/drawing/2014/main" id="{8C415D6D-5CF2-4B92-88A7-65264860F59F}"/>
+                <a16:creationId xmlns:a16="http://schemas.microsoft.com/office/drawing/2014/main" id="{B77FB511-DC56-4071-9779-604E2C9CC6EB}"/>
               </a:ext>
             </a:extLst>
           </p:cNvPr>
@@ -6003,7 +6003,7 @@
           <p:cNvPr id="5" name="">
             <a:extLst xmlns:a="http://schemas.openxmlformats.org/drawingml/2006/main">
               <a:ext uri="{FF2B5EF4-FFF2-40B4-BE49-F238E27FC236}">
-                <a16:creationId xmlns:a16="http://schemas.microsoft.com/office/drawing/2014/main" id="{D5DADCBD-B81B-4A9D-83F9-CA299222F8BD}"/>
+                <a16:creationId xmlns:a16="http://schemas.microsoft.com/office/drawing/2014/main" id="{771E9243-05B8-4C17-9648-31F1FEF01CE6}"/>
               </a:ext>
             </a:extLst>
           </p:cNvPr>
@@ -6060,7 +6060,7 @@
           <p:cNvPr id="6" name="">
             <a:extLst xmlns:a="http://schemas.openxmlformats.org/drawingml/2006/main">
               <a:ext uri="{FF2B5EF4-FFF2-40B4-BE49-F238E27FC236}">
-                <a16:creationId xmlns:a16="http://schemas.microsoft.com/office/drawing/2014/main" id="{C104146D-A6AE-415C-8201-386CB6F3A6F1}"/>
+                <a16:creationId xmlns:a16="http://schemas.microsoft.com/office/drawing/2014/main" id="{8DBE6524-6E83-43D1-800A-A69A52E59F3F}"/>
               </a:ext>
             </a:extLst>
           </p:cNvPr>
@@ -6117,7 +6117,7 @@
           <p:cNvPr id="7" name="">
             <a:extLst xmlns:a="http://schemas.openxmlformats.org/drawingml/2006/main">
               <a:ext uri="{FF2B5EF4-FFF2-40B4-BE49-F238E27FC236}">
-                <a16:creationId xmlns:a16="http://schemas.microsoft.com/office/drawing/2014/main" id="{57FE27CC-9352-4424-A6BC-F5BE6ABA4182}"/>
+                <a16:creationId xmlns:a16="http://schemas.microsoft.com/office/drawing/2014/main" id="{4B018587-6F07-45AD-B2DB-10AAADA0E47E}"/>
               </a:ext>
             </a:extLst>
           </p:cNvPr>
@@ -6174,7 +6174,7 @@
           <p:cNvPr id="8" name="">
             <a:extLst xmlns:a="http://schemas.openxmlformats.org/drawingml/2006/main">
               <a:ext uri="{FF2B5EF4-FFF2-40B4-BE49-F238E27FC236}">
-                <a16:creationId xmlns:a16="http://schemas.microsoft.com/office/drawing/2014/main" id="{B3D4D519-F336-4CDA-A969-C273E981BA41}"/>
+                <a16:creationId xmlns:a16="http://schemas.microsoft.com/office/drawing/2014/main" id="{9B0D38BC-12DA-4155-9ABF-1275E24A2DAF}"/>
               </a:ext>
             </a:extLst>
           </p:cNvPr>
@@ -6252,7 +6252,7 @@
     </p:spTree>
     <p:extLst>
       <p:ext uri="{BB962C8B-B14F-4D97-AF65-F5344CB8AC3E}">
-        <p14:creationId xmlns:p14="http://schemas.microsoft.com/office/powerpoint/2010/main" val="1009177519"/>
+        <p14:creationId xmlns:p14="http://schemas.microsoft.com/office/powerpoint/2010/main" val="2014967985"/>
       </p:ext>
     </p:extLst>
   </p:cSld>
@@ -6283,7 +6283,7 @@
           <p:cNvPr id="8" name="">
             <a:extLst xmlns:a="http://schemas.openxmlformats.org/drawingml/2006/main">
               <a:ext uri="{FF2B5EF4-FFF2-40B4-BE49-F238E27FC236}">
-                <a16:creationId xmlns:a16="http://schemas.microsoft.com/office/drawing/2014/main" id="{1B6DA2DB-B57E-44FC-8459-1123229E10FC}"/>
+                <a16:creationId xmlns:a16="http://schemas.microsoft.com/office/drawing/2014/main" id="{C9620BDF-0FB9-4B94-B4D5-E80311BEBDCC}"/>
               </a:ext>
             </a:extLst>
           </p:cNvPr>
@@ -6340,7 +6340,7 @@
           <p:cNvPr id="2" name="">
             <a:extLst xmlns:a="http://schemas.openxmlformats.org/drawingml/2006/main">
               <a:ext uri="{FF2B5EF4-FFF2-40B4-BE49-F238E27FC236}">
-                <a16:creationId xmlns:a16="http://schemas.microsoft.com/office/drawing/2014/main" id="{ADF5D227-1205-4CD9-B6C7-BD90DC254EED}"/>
+                <a16:creationId xmlns:a16="http://schemas.microsoft.com/office/drawing/2014/main" id="{AE0F2389-077B-442D-A7C3-8704D8A7357C}"/>
               </a:ext>
             </a:extLst>
           </p:cNvPr>
@@ -6397,7 +6397,7 @@
           <p:cNvPr id="3" name="">
             <a:extLst xmlns:a="http://schemas.openxmlformats.org/drawingml/2006/main">
               <a:ext uri="{FF2B5EF4-FFF2-40B4-BE49-F238E27FC236}">
-                <a16:creationId xmlns:a16="http://schemas.microsoft.com/office/drawing/2014/main" id="{775EEED0-2FEB-4EB2-BF67-B0A0B3C71B19}"/>
+                <a16:creationId xmlns:a16="http://schemas.microsoft.com/office/drawing/2014/main" id="{1F3DC100-1FC5-49FC-AC5C-412FBB12F0CD}"/>
               </a:ext>
             </a:extLst>
           </p:cNvPr>
@@ -6454,7 +6454,7 @@
           <p:cNvPr id="4" name="">
             <a:extLst xmlns:a="http://schemas.openxmlformats.org/drawingml/2006/main">
               <a:ext uri="{FF2B5EF4-FFF2-40B4-BE49-F238E27FC236}">
-                <a16:creationId xmlns:a16="http://schemas.microsoft.com/office/drawing/2014/main" id="{188FD948-B106-4B12-9103-5937B35F747A}"/>
+                <a16:creationId xmlns:a16="http://schemas.microsoft.com/office/drawing/2014/main" id="{AB1AAFE3-2AE7-4320-8C76-B24B105BE3F8}"/>
               </a:ext>
             </a:extLst>
           </p:cNvPr>
@@ -6511,7 +6511,7 @@
           <p:cNvPr id="5" name="">
             <a:extLst xmlns:a="http://schemas.openxmlformats.org/drawingml/2006/main">
               <a:ext uri="{FF2B5EF4-FFF2-40B4-BE49-F238E27FC236}">
-                <a16:creationId xmlns:a16="http://schemas.microsoft.com/office/drawing/2014/main" id="{D4C88D42-290E-4E63-AF52-656228D0A075}"/>
+                <a16:creationId xmlns:a16="http://schemas.microsoft.com/office/drawing/2014/main" id="{E46BE2FF-532B-4FE3-B5B3-28F266A0FBD1}"/>
               </a:ext>
             </a:extLst>
           </p:cNvPr>
@@ -6840,7 +6840,7 @@
           <p:cNvPr id="7" name="">
             <a:extLst xmlns:a="http://schemas.openxmlformats.org/drawingml/2006/main">
               <a:ext uri="{FF2B5EF4-FFF2-40B4-BE49-F238E27FC236}">
-                <a16:creationId xmlns:a16="http://schemas.microsoft.com/office/drawing/2014/main" id="{6C017933-1EE7-4B2F-8B8E-0EEFF199E428}"/>
+                <a16:creationId xmlns:a16="http://schemas.microsoft.com/office/drawing/2014/main" id="{3831599D-00D5-4320-9F1C-D434601A1856}"/>
               </a:ext>
             </a:extLst>
           </p:cNvPr>
@@ -6918,7 +6918,7 @@
     </p:spTree>
     <p:extLst>
       <p:ext uri="{BB962C8B-B14F-4D97-AF65-F5344CB8AC3E}">
-        <p14:creationId xmlns:p14="http://schemas.microsoft.com/office/powerpoint/2010/main" val="621451719"/>
+        <p14:creationId xmlns:p14="http://schemas.microsoft.com/office/powerpoint/2010/main" val="1754387128"/>
       </p:ext>
     </p:extLst>
   </p:cSld>
@@ -6949,7 +6949,7 @@
           <p:cNvPr id="8" name="">
             <a:extLst xmlns:a="http://schemas.openxmlformats.org/drawingml/2006/main">
               <a:ext uri="{FF2B5EF4-FFF2-40B4-BE49-F238E27FC236}">
-                <a16:creationId xmlns:a16="http://schemas.microsoft.com/office/drawing/2014/main" id="{BAB82142-5A5F-46A2-8F2C-BF0D87559B92}"/>
+                <a16:creationId xmlns:a16="http://schemas.microsoft.com/office/drawing/2014/main" id="{A3EF87FD-36FB-4F20-A65E-8A9B9D6C9927}"/>
               </a:ext>
             </a:extLst>
           </p:cNvPr>
@@ -7006,7 +7006,7 @@
           <p:cNvPr id="2" name="">
             <a:extLst xmlns:a="http://schemas.openxmlformats.org/drawingml/2006/main">
               <a:ext uri="{FF2B5EF4-FFF2-40B4-BE49-F238E27FC236}">
-                <a16:creationId xmlns:a16="http://schemas.microsoft.com/office/drawing/2014/main" id="{1088BDCB-D024-4F3D-BACE-B04337A0C09E}"/>
+                <a16:creationId xmlns:a16="http://schemas.microsoft.com/office/drawing/2014/main" id="{6A7EB8A3-9B38-4E43-9272-D09AAFAFA33F}"/>
               </a:ext>
             </a:extLst>
           </p:cNvPr>
@@ -7063,7 +7063,7 @@
           <p:cNvPr id="3" name="">
             <a:extLst xmlns:a="http://schemas.openxmlformats.org/drawingml/2006/main">
               <a:ext uri="{FF2B5EF4-FFF2-40B4-BE49-F238E27FC236}">
-                <a16:creationId xmlns:a16="http://schemas.microsoft.com/office/drawing/2014/main" id="{3DD82AAB-1539-4685-9392-7F0E98DB70FA}"/>
+                <a16:creationId xmlns:a16="http://schemas.microsoft.com/office/drawing/2014/main" id="{17A1C1FC-E836-4FB8-84F7-EAA147275D8A}"/>
               </a:ext>
             </a:extLst>
           </p:cNvPr>
@@ -7120,7 +7120,7 @@
           <p:cNvPr id="4" name="">
             <a:extLst xmlns:a="http://schemas.openxmlformats.org/drawingml/2006/main">
               <a:ext uri="{FF2B5EF4-FFF2-40B4-BE49-F238E27FC236}">
-                <a16:creationId xmlns:a16="http://schemas.microsoft.com/office/drawing/2014/main" id="{870F646C-2AA3-49BB-9204-37820FA0C411}"/>
+                <a16:creationId xmlns:a16="http://schemas.microsoft.com/office/drawing/2014/main" id="{774EF4D1-919F-4523-91DD-20EC4E0EE4F6}"/>
               </a:ext>
             </a:extLst>
           </p:cNvPr>
@@ -7184,7 +7184,7 @@
         </p:xfrm>
         <a:graphic xmlns:a="http://schemas.openxmlformats.org/drawingml/2006/main">
           <a:graphicData uri="http://schemas.openxmlformats.org/drawingml/2006/chart">
-            <c:chart xmlns:r="http://schemas.openxmlformats.org/officeDocument/2006/relationships" xmlns:c="http://schemas.openxmlformats.org/drawingml/2006/chart" r:id="Rc4ca69ea70d14cf4"/>
+            <c:chart xmlns:r="http://schemas.openxmlformats.org/officeDocument/2006/relationships" xmlns:c="http://schemas.openxmlformats.org/drawingml/2006/chart" r:id="Rdf260e3c03544a0d"/>
           </a:graphicData>
         </a:graphic>
       </p:graphicFrame>
@@ -7193,7 +7193,7 @@
           <p:cNvPr id="6" name="">
             <a:extLst xmlns:a="http://schemas.openxmlformats.org/drawingml/2006/main">
               <a:ext uri="{FF2B5EF4-FFF2-40B4-BE49-F238E27FC236}">
-                <a16:creationId xmlns:a16="http://schemas.microsoft.com/office/drawing/2014/main" id="{D51D955A-7AB8-4B2F-BF7C-F522347EC1CE}"/>
+                <a16:creationId xmlns:a16="http://schemas.microsoft.com/office/drawing/2014/main" id="{B5F8D5EE-220C-42B2-8466-2307F6DC4BD9}"/>
               </a:ext>
             </a:extLst>
           </p:cNvPr>
@@ -7250,7 +7250,7 @@
           <p:cNvPr id="7" name="">
             <a:extLst xmlns:a="http://schemas.openxmlformats.org/drawingml/2006/main">
               <a:ext uri="{FF2B5EF4-FFF2-40B4-BE49-F238E27FC236}">
-                <a16:creationId xmlns:a16="http://schemas.microsoft.com/office/drawing/2014/main" id="{71CC6966-19A9-4A04-8060-64048164E69F}"/>
+                <a16:creationId xmlns:a16="http://schemas.microsoft.com/office/drawing/2014/main" id="{ADF959E7-0FF3-4C86-A637-7550E008DD6F}"/>
               </a:ext>
             </a:extLst>
           </p:cNvPr>
@@ -7305,7 +7305,7 @@
     </p:spTree>
     <p:extLst>
       <p:ext uri="{BB962C8B-B14F-4D97-AF65-F5344CB8AC3E}">
-        <p14:creationId xmlns:p14="http://schemas.microsoft.com/office/powerpoint/2010/main" val="1036198729"/>
+        <p14:creationId xmlns:p14="http://schemas.microsoft.com/office/powerpoint/2010/main" val="1669234151"/>
       </p:ext>
     </p:extLst>
   </p:cSld>
@@ -7336,7 +7336,7 @@
           <p:cNvPr id="8" name="">
             <a:extLst xmlns:a="http://schemas.openxmlformats.org/drawingml/2006/main">
               <a:ext uri="{FF2B5EF4-FFF2-40B4-BE49-F238E27FC236}">
-                <a16:creationId xmlns:a16="http://schemas.microsoft.com/office/drawing/2014/main" id="{A384BCBB-2CD7-4350-A46B-8083052B7DF9}"/>
+                <a16:creationId xmlns:a16="http://schemas.microsoft.com/office/drawing/2014/main" id="{2300E0D4-D35C-4D57-BE50-714DE20AD2E3}"/>
               </a:ext>
             </a:extLst>
           </p:cNvPr>
@@ -7393,7 +7393,7 @@
           <p:cNvPr id="2" name="">
             <a:extLst xmlns:a="http://schemas.openxmlformats.org/drawingml/2006/main">
               <a:ext uri="{FF2B5EF4-FFF2-40B4-BE49-F238E27FC236}">
-                <a16:creationId xmlns:a16="http://schemas.microsoft.com/office/drawing/2014/main" id="{08ADC8A7-E09B-494B-81D0-26591D18306C}"/>
+                <a16:creationId xmlns:a16="http://schemas.microsoft.com/office/drawing/2014/main" id="{747962A7-7248-4F7B-812D-090E2D992092}"/>
               </a:ext>
             </a:extLst>
           </p:cNvPr>
@@ -7450,7 +7450,7 @@
           <p:cNvPr id="3" name="">
             <a:extLst xmlns:a="http://schemas.openxmlformats.org/drawingml/2006/main">
               <a:ext uri="{FF2B5EF4-FFF2-40B4-BE49-F238E27FC236}">
-                <a16:creationId xmlns:a16="http://schemas.microsoft.com/office/drawing/2014/main" id="{7BE4757A-7D60-4CEF-A0B8-977BD4D53034}"/>
+                <a16:creationId xmlns:a16="http://schemas.microsoft.com/office/drawing/2014/main" id="{4B8B7B2E-DC77-4327-896C-D2BC0356953B}"/>
               </a:ext>
             </a:extLst>
           </p:cNvPr>
@@ -7507,7 +7507,7 @@
           <p:cNvPr id="4" name="">
             <a:extLst xmlns:a="http://schemas.openxmlformats.org/drawingml/2006/main">
               <a:ext uri="{FF2B5EF4-FFF2-40B4-BE49-F238E27FC236}">
-                <a16:creationId xmlns:a16="http://schemas.microsoft.com/office/drawing/2014/main" id="{89F825DB-8941-42C3-8557-C7DF7E020D6F}"/>
+                <a16:creationId xmlns:a16="http://schemas.microsoft.com/office/drawing/2014/main" id="{A98DCC02-8C42-4EF5-A73B-4400C3351C2B}"/>
               </a:ext>
             </a:extLst>
           </p:cNvPr>
@@ -7564,7 +7564,7 @@
           <p:cNvPr id="5" name="">
             <a:extLst xmlns:a="http://schemas.openxmlformats.org/drawingml/2006/main">
               <a:ext uri="{FF2B5EF4-FFF2-40B4-BE49-F238E27FC236}">
-                <a16:creationId xmlns:a16="http://schemas.microsoft.com/office/drawing/2014/main" id="{8C4D9438-0395-4DD4-B5A6-3E172564C729}"/>
+                <a16:creationId xmlns:a16="http://schemas.microsoft.com/office/drawing/2014/main" id="{32EF0442-9358-49EF-A001-0C7B0743CA32}"/>
               </a:ext>
             </a:extLst>
           </p:cNvPr>
@@ -7621,7 +7621,7 @@
           <p:cNvPr id="6" name="">
             <a:extLst xmlns:a="http://schemas.openxmlformats.org/drawingml/2006/main">
               <a:ext uri="{FF2B5EF4-FFF2-40B4-BE49-F238E27FC236}">
-                <a16:creationId xmlns:a16="http://schemas.microsoft.com/office/drawing/2014/main" id="{24732307-2B1A-491C-8D25-A0A9CD857926}"/>
+                <a16:creationId xmlns:a16="http://schemas.microsoft.com/office/drawing/2014/main" id="{1603C6C6-2BAA-4082-9506-598D9BB628F3}"/>
               </a:ext>
             </a:extLst>
           </p:cNvPr>
@@ -7678,7 +7678,7 @@
           <p:cNvPr id="7" name="">
             <a:extLst xmlns:a="http://schemas.openxmlformats.org/drawingml/2006/main">
               <a:ext uri="{FF2B5EF4-FFF2-40B4-BE49-F238E27FC236}">
-                <a16:creationId xmlns:a16="http://schemas.microsoft.com/office/drawing/2014/main" id="{551B8543-65D6-48F2-81BD-915D8D82861F}"/>
+                <a16:creationId xmlns:a16="http://schemas.microsoft.com/office/drawing/2014/main" id="{404A4BF5-2F13-4A6A-8993-DAB393FC2BBF}"/>
               </a:ext>
             </a:extLst>
           </p:cNvPr>
@@ -7733,7 +7733,7 @@
     </p:spTree>
     <p:extLst>
       <p:ext uri="{BB962C8B-B14F-4D97-AF65-F5344CB8AC3E}">
-        <p14:creationId xmlns:p14="http://schemas.microsoft.com/office/powerpoint/2010/main" val="1638388466"/>
+        <p14:creationId xmlns:p14="http://schemas.microsoft.com/office/powerpoint/2010/main" val="170179587"/>
       </p:ext>
     </p:extLst>
   </p:cSld>
@@ -7764,7 +7764,7 @@
           <p:cNvPr id="8" name="">
             <a:extLst xmlns:a="http://schemas.openxmlformats.org/drawingml/2006/main">
               <a:ext uri="{FF2B5EF4-FFF2-40B4-BE49-F238E27FC236}">
-                <a16:creationId xmlns:a16="http://schemas.microsoft.com/office/drawing/2014/main" id="{AFE0755C-A722-4F86-8A1D-0DDF231CE958}"/>
+                <a16:creationId xmlns:a16="http://schemas.microsoft.com/office/drawing/2014/main" id="{C43A69EA-C53D-4E45-A1E0-551B063450C6}"/>
               </a:ext>
             </a:extLst>
           </p:cNvPr>
@@ -7821,7 +7821,7 @@
           <p:cNvPr id="2" name="">
             <a:extLst xmlns:a="http://schemas.openxmlformats.org/drawingml/2006/main">
               <a:ext uri="{FF2B5EF4-FFF2-40B4-BE49-F238E27FC236}">
-                <a16:creationId xmlns:a16="http://schemas.microsoft.com/office/drawing/2014/main" id="{AE9C5930-0F37-48FB-9249-4A3A28009B23}"/>
+                <a16:creationId xmlns:a16="http://schemas.microsoft.com/office/drawing/2014/main" id="{915F335A-D754-4A90-A486-4C611E451E46}"/>
               </a:ext>
             </a:extLst>
           </p:cNvPr>
@@ -7878,7 +7878,7 @@
           <p:cNvPr id="3" name="">
             <a:extLst xmlns:a="http://schemas.openxmlformats.org/drawingml/2006/main">
               <a:ext uri="{FF2B5EF4-FFF2-40B4-BE49-F238E27FC236}">
-                <a16:creationId xmlns:a16="http://schemas.microsoft.com/office/drawing/2014/main" id="{BBC4F01E-4A83-4423-B73F-9902AB9C7298}"/>
+                <a16:creationId xmlns:a16="http://schemas.microsoft.com/office/drawing/2014/main" id="{8E791E69-E6C6-4F2A-BE0C-F69318E6BC64}"/>
               </a:ext>
             </a:extLst>
           </p:cNvPr>
@@ -7935,7 +7935,7 @@
           <p:cNvPr id="4" name="">
             <a:extLst xmlns:a="http://schemas.openxmlformats.org/drawingml/2006/main">
               <a:ext uri="{FF2B5EF4-FFF2-40B4-BE49-F238E27FC236}">
-                <a16:creationId xmlns:a16="http://schemas.microsoft.com/office/drawing/2014/main" id="{298474F3-188C-4725-9140-9BA61F5CD919}"/>
+                <a16:creationId xmlns:a16="http://schemas.microsoft.com/office/drawing/2014/main" id="{8D9EBFB3-4724-4297-A8C4-86F166FBC6FB}"/>
               </a:ext>
             </a:extLst>
           </p:cNvPr>
@@ -7992,7 +7992,7 @@
           <p:cNvPr id="5" name="">
             <a:extLst xmlns:a="http://schemas.openxmlformats.org/drawingml/2006/main">
               <a:ext uri="{FF2B5EF4-FFF2-40B4-BE49-F238E27FC236}">
-                <a16:creationId xmlns:a16="http://schemas.microsoft.com/office/drawing/2014/main" id="{8E3A1D6B-7EFD-49A8-BE47-FBB3DE4952F2}"/>
+                <a16:creationId xmlns:a16="http://schemas.microsoft.com/office/drawing/2014/main" id="{21CA8947-9559-4CC2-9FCB-0B4FE92DB3E3}"/>
               </a:ext>
             </a:extLst>
           </p:cNvPr>
@@ -8295,7 +8295,7 @@
           <p:cNvPr id="7" name="">
             <a:extLst xmlns:a="http://schemas.openxmlformats.org/drawingml/2006/main">
               <a:ext uri="{FF2B5EF4-FFF2-40B4-BE49-F238E27FC236}">
-                <a16:creationId xmlns:a16="http://schemas.microsoft.com/office/drawing/2014/main" id="{65D252CE-C525-45F5-A1D4-07B4F7137F8D}"/>
+                <a16:creationId xmlns:a16="http://schemas.microsoft.com/office/drawing/2014/main" id="{6B827A3F-1121-436C-9390-8053599EC31B}"/>
               </a:ext>
             </a:extLst>
           </p:cNvPr>
@@ -8373,7 +8373,7 @@
     </p:spTree>
     <p:extLst>
       <p:ext uri="{BB962C8B-B14F-4D97-AF65-F5344CB8AC3E}">
-        <p14:creationId xmlns:p14="http://schemas.microsoft.com/office/powerpoint/2010/main" val="1078624311"/>
+        <p14:creationId xmlns:p14="http://schemas.microsoft.com/office/powerpoint/2010/main" val="2108004649"/>
       </p:ext>
     </p:extLst>
   </p:cSld>
@@ -8404,7 +8404,7 @@
           <p:cNvPr id="8" name="">
             <a:extLst xmlns:a="http://schemas.openxmlformats.org/drawingml/2006/main">
               <a:ext uri="{FF2B5EF4-FFF2-40B4-BE49-F238E27FC236}">
-                <a16:creationId xmlns:a16="http://schemas.microsoft.com/office/drawing/2014/main" id="{01DC5EDE-EAF3-4835-8089-B2ADA1DE440C}"/>
+                <a16:creationId xmlns:a16="http://schemas.microsoft.com/office/drawing/2014/main" id="{B1B492BC-72B7-42A3-8E30-88284DD5743A}"/>
               </a:ext>
             </a:extLst>
           </p:cNvPr>
@@ -8461,7 +8461,7 @@
           <p:cNvPr id="2" name="">
             <a:extLst xmlns:a="http://schemas.openxmlformats.org/drawingml/2006/main">
               <a:ext uri="{FF2B5EF4-FFF2-40B4-BE49-F238E27FC236}">
-                <a16:creationId xmlns:a16="http://schemas.microsoft.com/office/drawing/2014/main" id="{E96AA13F-585E-4BAF-BDB2-9CC696EF30F6}"/>
+                <a16:creationId xmlns:a16="http://schemas.microsoft.com/office/drawing/2014/main" id="{4796830C-E25B-4B7D-BF67-8E7E8D28CFB5}"/>
               </a:ext>
             </a:extLst>
           </p:cNvPr>
@@ -8518,7 +8518,7 @@
           <p:cNvPr id="3" name="">
             <a:extLst xmlns:a="http://schemas.openxmlformats.org/drawingml/2006/main">
               <a:ext uri="{FF2B5EF4-FFF2-40B4-BE49-F238E27FC236}">
-                <a16:creationId xmlns:a16="http://schemas.microsoft.com/office/drawing/2014/main" id="{DB46C25F-F13E-4E10-959C-41E1325C559B}"/>
+                <a16:creationId xmlns:a16="http://schemas.microsoft.com/office/drawing/2014/main" id="{79272833-CA79-4025-9EF3-9887D0A70748}"/>
               </a:ext>
             </a:extLst>
           </p:cNvPr>
@@ -8575,7 +8575,7 @@
           <p:cNvPr id="4" name="">
             <a:extLst xmlns:a="http://schemas.openxmlformats.org/drawingml/2006/main">
               <a:ext uri="{FF2B5EF4-FFF2-40B4-BE49-F238E27FC236}">
-                <a16:creationId xmlns:a16="http://schemas.microsoft.com/office/drawing/2014/main" id="{3D28EF03-C3F2-4568-B1B8-47231C4A4E19}"/>
+                <a16:creationId xmlns:a16="http://schemas.microsoft.com/office/drawing/2014/main" id="{BA99CC43-A28C-4584-9833-529105258821}"/>
               </a:ext>
             </a:extLst>
           </p:cNvPr>
@@ -8632,7 +8632,7 @@
           <p:cNvPr id="5" name="">
             <a:extLst xmlns:a="http://schemas.openxmlformats.org/drawingml/2006/main">
               <a:ext uri="{FF2B5EF4-FFF2-40B4-BE49-F238E27FC236}">
-                <a16:creationId xmlns:a16="http://schemas.microsoft.com/office/drawing/2014/main" id="{606ED120-A98B-4D1C-BC20-337C3D9EFD44}"/>
+                <a16:creationId xmlns:a16="http://schemas.microsoft.com/office/drawing/2014/main" id="{C7D39C35-0944-4AA8-9F8A-207F3EB0D08D}"/>
               </a:ext>
             </a:extLst>
           </p:cNvPr>
@@ -8679,7 +8679,7 @@
                 <a:ea typeface="Times New Roman"/>
                 <a:cs typeface="Times New Roman"/>
               </a:rPr>
-              <a:t>Pilot: 16 reused images and one editor</a:t>
+              <a:t>Data: source overlap and unclear edit masks</a:t>
             </a:r>
           </a:p>
         </p:txBody>
@@ -8689,7 +8689,7 @@
           <p:cNvPr id="6" name="">
             <a:extLst xmlns:a="http://schemas.openxmlformats.org/drawingml/2006/main">
               <a:ext uri="{FF2B5EF4-FFF2-40B4-BE49-F238E27FC236}">
-                <a16:creationId xmlns:a16="http://schemas.microsoft.com/office/drawing/2014/main" id="{A3BB938C-F47D-4B8A-ABE3-46347551D047}"/>
+                <a16:creationId xmlns:a16="http://schemas.microsoft.com/office/drawing/2014/main" id="{C3458452-C469-4624-BE7E-44ECD86A98B0}"/>
               </a:ext>
             </a:extLst>
           </p:cNvPr>
@@ -8736,7 +8736,7 @@
                 <a:ea typeface="Times New Roman"/>
                 <a:cs typeface="Times New Roman"/>
               </a:rPr>
-              <a:t>Moving the edits reduced performance.</a:t>
+              <a:t>Local generation also changed background pixels.</a:t>
             </a:r>
           </a:p>
           <a:p xmlns:a="http://schemas.openxmlformats.org/drawingml/2006/main">
@@ -8759,7 +8759,7 @@
                 <a:ea typeface="Times New Roman"/>
                 <a:cs typeface="Times New Roman"/>
               </a:rPr>
-              <a:t>Additional training increased false markings on real images.</a:t>
+              <a:t>Controlled pilot: 16 reused images, one editor.</a:t>
             </a:r>
           </a:p>
         </p:txBody>
@@ -8769,7 +8769,7 @@
           <p:cNvPr id="7" name="">
             <a:extLst xmlns:a="http://schemas.openxmlformats.org/drawingml/2006/main">
               <a:ext uri="{FF2B5EF4-FFF2-40B4-BE49-F238E27FC236}">
-                <a16:creationId xmlns:a16="http://schemas.microsoft.com/office/drawing/2014/main" id="{C4403F83-4643-4400-8430-5F570E0CE44E}"/>
+                <a16:creationId xmlns:a16="http://schemas.microsoft.com/office/drawing/2014/main" id="{B5381D4A-7408-4038-AF6C-C1CA09F56735}"/>
               </a:ext>
             </a:extLst>
           </p:cNvPr>
@@ -8824,7 +8824,7 @@
     </p:spTree>
     <p:extLst>
       <p:ext uri="{BB962C8B-B14F-4D97-AF65-F5344CB8AC3E}">
-        <p14:creationId xmlns:p14="http://schemas.microsoft.com/office/powerpoint/2010/main" val="1831436952"/>
+        <p14:creationId xmlns:p14="http://schemas.microsoft.com/office/powerpoint/2010/main" val="1177094754"/>
       </p:ext>
     </p:extLst>
   </p:cSld>

</xml_diff>

<commit_message>
docs: make Model2 limitations explicit in presentation
</commit_message>
<xml_diff>
--- a/rapor/final_2026/deliverables/CS395_Presentation_EfeHan_Keles_29September2026.pptx
+++ b/rapor/final_2026/deliverables/CS395_Presentation_EfeHan_Keles_29September2026.pptx
@@ -2,24 +2,24 @@
 <file path=ppt/presentation.xml><?xml version="1.0" encoding="utf-8"?>
 <p:presentation xmlns:p="http://schemas.openxmlformats.org/presentationml/2006/main">
   <p:sldMasterIdLst>
-    <p:sldMasterId xmlns:r="http://schemas.openxmlformats.org/officeDocument/2006/relationships" id="2147483648" r:id="R7a2f37c4097f482f"/>
+    <p:sldMasterId xmlns:r="http://schemas.openxmlformats.org/officeDocument/2006/relationships" id="2147483648" r:id="R13b9405a838b4dfd"/>
   </p:sldMasterIdLst>
   <p:notesMasterIdLst>
-    <p:notesMasterId xmlns:r="http://schemas.openxmlformats.org/officeDocument/2006/relationships" r:id="Rda752303644a4470"/>
+    <p:notesMasterId xmlns:r="http://schemas.openxmlformats.org/officeDocument/2006/relationships" r:id="R9c342c8a258a46da"/>
   </p:notesMasterIdLst>
   <p:sldIdLst>
-    <p:sldId xmlns:r="http://schemas.openxmlformats.org/officeDocument/2006/relationships" id="256" r:id="R96336b47d96c45b0"/>
-    <p:sldId xmlns:r="http://schemas.openxmlformats.org/officeDocument/2006/relationships" id="257" r:id="R7de0d6b2fdbc48dd"/>
-    <p:sldId xmlns:r="http://schemas.openxmlformats.org/officeDocument/2006/relationships" id="258" r:id="R624ccb093e9a49f6"/>
-    <p:sldId xmlns:r="http://schemas.openxmlformats.org/officeDocument/2006/relationships" id="259" r:id="R1daac745951f4ebf"/>
-    <p:sldId xmlns:r="http://schemas.openxmlformats.org/officeDocument/2006/relationships" id="260" r:id="Re44f5b3e7e2c474a"/>
-    <p:sldId xmlns:r="http://schemas.openxmlformats.org/officeDocument/2006/relationships" id="261" r:id="R4af992e66385495a"/>
-    <p:sldId xmlns:r="http://schemas.openxmlformats.org/officeDocument/2006/relationships" id="262" r:id="Rc43c903c60f24f7a"/>
-    <p:sldId xmlns:r="http://schemas.openxmlformats.org/officeDocument/2006/relationships" id="263" r:id="Rfcb5affcd94e4441"/>
-    <p:sldId xmlns:r="http://schemas.openxmlformats.org/officeDocument/2006/relationships" id="264" r:id="R6a51f5d66b754c94"/>
-    <p:sldId xmlns:r="http://schemas.openxmlformats.org/officeDocument/2006/relationships" id="265" r:id="Rda47178a76a14348"/>
-    <p:sldId xmlns:r="http://schemas.openxmlformats.org/officeDocument/2006/relationships" id="266" r:id="Rb0933235d226480b"/>
-    <p:sldId xmlns:r="http://schemas.openxmlformats.org/officeDocument/2006/relationships" id="267" r:id="Rfe33e3ee624f4e32"/>
+    <p:sldId xmlns:r="http://schemas.openxmlformats.org/officeDocument/2006/relationships" id="256" r:id="R202c9283cff9488b"/>
+    <p:sldId xmlns:r="http://schemas.openxmlformats.org/officeDocument/2006/relationships" id="257" r:id="R7fddeea60f1a4827"/>
+    <p:sldId xmlns:r="http://schemas.openxmlformats.org/officeDocument/2006/relationships" id="258" r:id="R36575ff8987948fc"/>
+    <p:sldId xmlns:r="http://schemas.openxmlformats.org/officeDocument/2006/relationships" id="259" r:id="R4b47876965dd4194"/>
+    <p:sldId xmlns:r="http://schemas.openxmlformats.org/officeDocument/2006/relationships" id="260" r:id="R0d4be53dc3e04c46"/>
+    <p:sldId xmlns:r="http://schemas.openxmlformats.org/officeDocument/2006/relationships" id="261" r:id="Rdf4dafc1c6fa40ef"/>
+    <p:sldId xmlns:r="http://schemas.openxmlformats.org/officeDocument/2006/relationships" id="262" r:id="Re813d923ef4b4126"/>
+    <p:sldId xmlns:r="http://schemas.openxmlformats.org/officeDocument/2006/relationships" id="263" r:id="R3346a61718e3426c"/>
+    <p:sldId xmlns:r="http://schemas.openxmlformats.org/officeDocument/2006/relationships" id="264" r:id="R2a22c134beea415e"/>
+    <p:sldId xmlns:r="http://schemas.openxmlformats.org/officeDocument/2006/relationships" id="265" r:id="Rec2d94ebfa4749ba"/>
+    <p:sldId xmlns:r="http://schemas.openxmlformats.org/officeDocument/2006/relationships" id="266" r:id="R222dae9074a9490d"/>
+    <p:sldId xmlns:r="http://schemas.openxmlformats.org/officeDocument/2006/relationships" id="267" r:id="R3663e94c5f2a4148"/>
   </p:sldIdLst>
   <p:sldSz cx="12192000" cy="6858000"/>
   <p:notesSz cx="6858000" cy="9144000"/>
@@ -1483,7 +1483,7 @@
           </a:p>
           <a:p xmlns:a="http://schemas.openxmlformats.org/drawingml/2006/main">
             <a:r>
-              <a:t>Model2 asks where an AI edit is located. We found datasets, but source overlap and unclear masks prevented building a broad, validated training set. In our Stable Diffusion pilot, asking for a local edit also changed pixels outside the selected region. We therefore pasted only the generated region into the original and kept comparison controls. This gave us sixteen controlled examples from one editor, not broad coverage. Later training helped a new edit placement but harmed the original placement and increased false markings on real images. I rejected that candidate. These data and evaluation limits kept Model2 experimental.</a:t>
+              <a:t>Model2 tries to locate an AI edit. Our Stable Diffusion pilot showed that a local edit request could also change background pixels. We preserved the original background by pasting only the generated region into it. Suitable training data were another difficulty. We found datasets, but shared source images and unclear masks limited their use. We therefore ran a controlled pilot with sixteen reused images from one editor. Later training improved one edit placement but harmed another and increased false markings on real images. I rejected that candidate. Model2 remains experimental, with limited data and unresolved evaluation problems.</a:t>
             </a:r>
           </a:p>
           <a:p xmlns:a="http://schemas.openxmlformats.org/drawingml/2006/main">
@@ -1561,7 +1561,7 @@
   </p:cSld>
   <p:clrMap bg1="lt1" tx1="dk1" bg2="lt2" tx2="dk2" accent1="accent1" accent2="accent2" accent3="accent3" accent4="accent4" accent5="accent5" accent6="accent6" hlink="hlink" folHlink="folHlink"/>
   <p:sldLayoutIdLst>
-    <p:sldLayoutId xmlns:r="http://schemas.openxmlformats.org/officeDocument/2006/relationships" id="2147483649" r:id="Ra0e38f0d1bb44cb1"/>
+    <p:sldLayoutId xmlns:r="http://schemas.openxmlformats.org/officeDocument/2006/relationships" id="2147483649" r:id="Ra02a671b09914f4b"/>
   </p:sldLayoutIdLst>
   <p:txStyles>
     <p:titleStyle>
@@ -2337,7 +2337,7 @@
           <p:cNvPr id="9" name="">
             <a:extLst xmlns:a="http://schemas.openxmlformats.org/drawingml/2006/main">
               <a:ext uri="{FF2B5EF4-FFF2-40B4-BE49-F238E27FC236}">
-                <a16:creationId xmlns:a16="http://schemas.microsoft.com/office/drawing/2014/main" id="{235EAF9B-FF6F-497B-B17D-2E2617796B87}"/>
+                <a16:creationId xmlns:a16="http://schemas.microsoft.com/office/drawing/2014/main" id="{BB54A679-4E94-4CC4-9466-178758E76673}"/>
               </a:ext>
             </a:extLst>
           </p:cNvPr>
@@ -2394,7 +2394,7 @@
           <p:cNvPr id="2" name="">
             <a:extLst xmlns:a="http://schemas.openxmlformats.org/drawingml/2006/main">
               <a:ext uri="{FF2B5EF4-FFF2-40B4-BE49-F238E27FC236}">
-                <a16:creationId xmlns:a16="http://schemas.microsoft.com/office/drawing/2014/main" id="{183E9280-11CB-4961-9AAF-BE65A0FB4869}"/>
+                <a16:creationId xmlns:a16="http://schemas.microsoft.com/office/drawing/2014/main" id="{EB4D8DFD-5740-4719-A451-33D7C115F541}"/>
               </a:ext>
             </a:extLst>
           </p:cNvPr>
@@ -2451,7 +2451,7 @@
           <p:cNvPr id="3" name="">
             <a:extLst xmlns:a="http://schemas.openxmlformats.org/drawingml/2006/main">
               <a:ext uri="{FF2B5EF4-FFF2-40B4-BE49-F238E27FC236}">
-                <a16:creationId xmlns:a16="http://schemas.microsoft.com/office/drawing/2014/main" id="{22827097-1E0C-4D5F-AB56-239205620919}"/>
+                <a16:creationId xmlns:a16="http://schemas.microsoft.com/office/drawing/2014/main" id="{4D0E7338-85B4-4017-97B8-B337A41DB465}"/>
               </a:ext>
             </a:extLst>
           </p:cNvPr>
@@ -2508,7 +2508,7 @@
           <p:cNvPr id="4" name="">
             <a:extLst xmlns:a="http://schemas.openxmlformats.org/drawingml/2006/main">
               <a:ext uri="{FF2B5EF4-FFF2-40B4-BE49-F238E27FC236}">
-                <a16:creationId xmlns:a16="http://schemas.microsoft.com/office/drawing/2014/main" id="{7D30B8DB-15AB-4B34-95D1-532E17C6D04C}"/>
+                <a16:creationId xmlns:a16="http://schemas.microsoft.com/office/drawing/2014/main" id="{B2E16D4D-B270-4728-A95C-82879441BE8B}"/>
               </a:ext>
             </a:extLst>
           </p:cNvPr>
@@ -2565,7 +2565,7 @@
           <p:cNvPr id="5" name="">
             <a:extLst xmlns:a="http://schemas.openxmlformats.org/drawingml/2006/main">
               <a:ext uri="{FF2B5EF4-FFF2-40B4-BE49-F238E27FC236}">
-                <a16:creationId xmlns:a16="http://schemas.microsoft.com/office/drawing/2014/main" id="{FF6C0B09-1B52-4AAF-A095-D38043CECB1A}"/>
+                <a16:creationId xmlns:a16="http://schemas.microsoft.com/office/drawing/2014/main" id="{A57019B8-1CB6-4B31-93B6-4AD9460E0A60}"/>
               </a:ext>
             </a:extLst>
           </p:cNvPr>
@@ -2645,7 +2645,7 @@
           <p:cNvPr id="6" name="">
             <a:extLst xmlns:a="http://schemas.openxmlformats.org/drawingml/2006/main">
               <a:ext uri="{FF2B5EF4-FFF2-40B4-BE49-F238E27FC236}">
-                <a16:creationId xmlns:a16="http://schemas.microsoft.com/office/drawing/2014/main" id="{0A1B8247-A1B3-49F6-9262-D2DBEE91E7B5}"/>
+                <a16:creationId xmlns:a16="http://schemas.microsoft.com/office/drawing/2014/main" id="{09480DA8-06A1-42A4-BEB7-42E83165BFE9}"/>
               </a:ext>
             </a:extLst>
           </p:cNvPr>
@@ -2725,7 +2725,7 @@
           <p:cNvPr id="7" name="">
             <a:extLst xmlns:a="http://schemas.openxmlformats.org/drawingml/2006/main">
               <a:ext uri="{FF2B5EF4-FFF2-40B4-BE49-F238E27FC236}">
-                <a16:creationId xmlns:a16="http://schemas.microsoft.com/office/drawing/2014/main" id="{00474F51-976A-4D76-88DA-D106AE19E0F0}"/>
+                <a16:creationId xmlns:a16="http://schemas.microsoft.com/office/drawing/2014/main" id="{BB86DE99-CCEC-41C6-A75D-C5329F632E37}"/>
               </a:ext>
             </a:extLst>
           </p:cNvPr>
@@ -2805,7 +2805,7 @@
           <p:cNvPr id="8" name="">
             <a:extLst xmlns:a="http://schemas.openxmlformats.org/drawingml/2006/main">
               <a:ext uri="{FF2B5EF4-FFF2-40B4-BE49-F238E27FC236}">
-                <a16:creationId xmlns:a16="http://schemas.microsoft.com/office/drawing/2014/main" id="{B00B6E7E-6A6B-45DC-B9AA-9836AB333642}"/>
+                <a16:creationId xmlns:a16="http://schemas.microsoft.com/office/drawing/2014/main" id="{F88DC6BA-5BD4-4489-B74E-2732AD6CDDEC}"/>
               </a:ext>
             </a:extLst>
           </p:cNvPr>
@@ -2860,7 +2860,7 @@
     </p:spTree>
     <p:extLst>
       <p:ext uri="{BB962C8B-B14F-4D97-AF65-F5344CB8AC3E}">
-        <p14:creationId xmlns:p14="http://schemas.microsoft.com/office/powerpoint/2010/main" val="1297110807"/>
+        <p14:creationId xmlns:p14="http://schemas.microsoft.com/office/powerpoint/2010/main" val="770658924"/>
       </p:ext>
     </p:extLst>
   </p:cSld>
@@ -2891,7 +2891,7 @@
           <p:cNvPr id="8" name="">
             <a:extLst xmlns:a="http://schemas.openxmlformats.org/drawingml/2006/main">
               <a:ext uri="{FF2B5EF4-FFF2-40B4-BE49-F238E27FC236}">
-                <a16:creationId xmlns:a16="http://schemas.microsoft.com/office/drawing/2014/main" id="{BF5F9CB1-3CD2-410F-A75F-B19AC462FFEF}"/>
+                <a16:creationId xmlns:a16="http://schemas.microsoft.com/office/drawing/2014/main" id="{93FEBFD9-6C68-411A-B48E-3B20E129A832}"/>
               </a:ext>
             </a:extLst>
           </p:cNvPr>
@@ -2948,7 +2948,7 @@
           <p:cNvPr id="2" name="">
             <a:extLst xmlns:a="http://schemas.openxmlformats.org/drawingml/2006/main">
               <a:ext uri="{FF2B5EF4-FFF2-40B4-BE49-F238E27FC236}">
-                <a16:creationId xmlns:a16="http://schemas.microsoft.com/office/drawing/2014/main" id="{2821365A-C6D6-4EF9-BA98-87AD84307C9B}"/>
+                <a16:creationId xmlns:a16="http://schemas.microsoft.com/office/drawing/2014/main" id="{98A6E1C6-0534-4B2F-AA2C-03537FA4CF88}"/>
               </a:ext>
             </a:extLst>
           </p:cNvPr>
@@ -3005,7 +3005,7 @@
           <p:cNvPr id="3" name="">
             <a:extLst xmlns:a="http://schemas.openxmlformats.org/drawingml/2006/main">
               <a:ext uri="{FF2B5EF4-FFF2-40B4-BE49-F238E27FC236}">
-                <a16:creationId xmlns:a16="http://schemas.microsoft.com/office/drawing/2014/main" id="{1CB344C8-AE5E-4FA9-9CDA-8E6C3E3DB5B6}"/>
+                <a16:creationId xmlns:a16="http://schemas.microsoft.com/office/drawing/2014/main" id="{0CFEF41B-2460-49DD-84CE-F775091DB08F}"/>
               </a:ext>
             </a:extLst>
           </p:cNvPr>
@@ -3062,7 +3062,7 @@
           <p:cNvPr id="4" name="">
             <a:extLst xmlns:a="http://schemas.openxmlformats.org/drawingml/2006/main">
               <a:ext uri="{FF2B5EF4-FFF2-40B4-BE49-F238E27FC236}">
-                <a16:creationId xmlns:a16="http://schemas.microsoft.com/office/drawing/2014/main" id="{575BEE01-8E95-4845-A3AF-755A5456328A}"/>
+                <a16:creationId xmlns:a16="http://schemas.microsoft.com/office/drawing/2014/main" id="{2BB4D44B-32B4-41BA-BADD-DB1D1917FF96}"/>
               </a:ext>
             </a:extLst>
           </p:cNvPr>
@@ -3119,7 +3119,7 @@
           <p:cNvPr id="5" name="">
             <a:extLst xmlns:a="http://schemas.openxmlformats.org/drawingml/2006/main">
               <a:ext uri="{FF2B5EF4-FFF2-40B4-BE49-F238E27FC236}">
-                <a16:creationId xmlns:a16="http://schemas.microsoft.com/office/drawing/2014/main" id="{643B599B-6C85-4DDF-ABFC-15E79C91ACBF}"/>
+                <a16:creationId xmlns:a16="http://schemas.microsoft.com/office/drawing/2014/main" id="{3A76B7FA-B3A4-49C2-9FB5-E111A3D8F7E8}"/>
               </a:ext>
             </a:extLst>
           </p:cNvPr>
@@ -3422,7 +3422,7 @@
           <p:cNvPr id="7" name="">
             <a:extLst xmlns:a="http://schemas.openxmlformats.org/drawingml/2006/main">
               <a:ext uri="{FF2B5EF4-FFF2-40B4-BE49-F238E27FC236}">
-                <a16:creationId xmlns:a16="http://schemas.microsoft.com/office/drawing/2014/main" id="{F2BA54A9-58AC-4653-84D3-C796DE3D2329}"/>
+                <a16:creationId xmlns:a16="http://schemas.microsoft.com/office/drawing/2014/main" id="{0B3C4AD8-1E9D-4C4A-9FA5-0E96D73B69BD}"/>
               </a:ext>
             </a:extLst>
           </p:cNvPr>
@@ -3477,7 +3477,7 @@
     </p:spTree>
     <p:extLst>
       <p:ext uri="{BB962C8B-B14F-4D97-AF65-F5344CB8AC3E}">
-        <p14:creationId xmlns:p14="http://schemas.microsoft.com/office/powerpoint/2010/main" val="86200445"/>
+        <p14:creationId xmlns:p14="http://schemas.microsoft.com/office/powerpoint/2010/main" val="386778533"/>
       </p:ext>
     </p:extLst>
   </p:cSld>
@@ -3508,7 +3508,7 @@
           <p:cNvPr id="12" name="">
             <a:extLst xmlns:a="http://schemas.openxmlformats.org/drawingml/2006/main">
               <a:ext uri="{FF2B5EF4-FFF2-40B4-BE49-F238E27FC236}">
-                <a16:creationId xmlns:a16="http://schemas.microsoft.com/office/drawing/2014/main" id="{F883EF35-F089-468D-B8D2-0099AB34DBE4}"/>
+                <a16:creationId xmlns:a16="http://schemas.microsoft.com/office/drawing/2014/main" id="{2A686336-CF75-4517-8D6D-020FE9DAD112}"/>
               </a:ext>
             </a:extLst>
           </p:cNvPr>
@@ -3565,7 +3565,7 @@
           <p:cNvPr id="2" name="">
             <a:extLst xmlns:a="http://schemas.openxmlformats.org/drawingml/2006/main">
               <a:ext uri="{FF2B5EF4-FFF2-40B4-BE49-F238E27FC236}">
-                <a16:creationId xmlns:a16="http://schemas.microsoft.com/office/drawing/2014/main" id="{D0FEBEF4-95B9-446E-B6E1-442ED304024A}"/>
+                <a16:creationId xmlns:a16="http://schemas.microsoft.com/office/drawing/2014/main" id="{473F3B77-4ED6-4E53-B79D-31EA528B1855}"/>
               </a:ext>
             </a:extLst>
           </p:cNvPr>
@@ -3622,7 +3622,7 @@
           <p:cNvPr id="3" name="">
             <a:extLst xmlns:a="http://schemas.openxmlformats.org/drawingml/2006/main">
               <a:ext uri="{FF2B5EF4-FFF2-40B4-BE49-F238E27FC236}">
-                <a16:creationId xmlns:a16="http://schemas.microsoft.com/office/drawing/2014/main" id="{A2D81C22-765C-4BD4-BD2C-426676008017}"/>
+                <a16:creationId xmlns:a16="http://schemas.microsoft.com/office/drawing/2014/main" id="{8795D55E-ED93-4504-B2D3-DE45B09A197B}"/>
               </a:ext>
             </a:extLst>
           </p:cNvPr>
@@ -3679,7 +3679,7 @@
           <p:cNvPr id="4" name="">
             <a:extLst xmlns:a="http://schemas.openxmlformats.org/drawingml/2006/main">
               <a:ext uri="{FF2B5EF4-FFF2-40B4-BE49-F238E27FC236}">
-                <a16:creationId xmlns:a16="http://schemas.microsoft.com/office/drawing/2014/main" id="{A9B185AB-8C0D-4FE3-9531-3C1EEC5F880A}"/>
+                <a16:creationId xmlns:a16="http://schemas.microsoft.com/office/drawing/2014/main" id="{A03F2CD0-2031-43F6-A56C-9D1CF55F29FC}"/>
               </a:ext>
             </a:extLst>
           </p:cNvPr>
@@ -3736,7 +3736,7 @@
           <p:cNvPr id="5" name="">
             <a:extLst xmlns:a="http://schemas.openxmlformats.org/drawingml/2006/main">
               <a:ext uri="{FF2B5EF4-FFF2-40B4-BE49-F238E27FC236}">
-                <a16:creationId xmlns:a16="http://schemas.microsoft.com/office/drawing/2014/main" id="{513B178E-E54F-4BB7-B720-90DF218B15B6}"/>
+                <a16:creationId xmlns:a16="http://schemas.microsoft.com/office/drawing/2014/main" id="{0D69F571-F3BB-4448-8E03-99BC1B99B40D}"/>
               </a:ext>
             </a:extLst>
           </p:cNvPr>
@@ -3793,7 +3793,7 @@
           <p:cNvPr id="6" name="">
             <a:extLst xmlns:a="http://schemas.openxmlformats.org/drawingml/2006/main">
               <a:ext uri="{FF2B5EF4-FFF2-40B4-BE49-F238E27FC236}">
-                <a16:creationId xmlns:a16="http://schemas.microsoft.com/office/drawing/2014/main" id="{9C196858-6DD1-4DF5-8F37-82CF9215DE38}"/>
+                <a16:creationId xmlns:a16="http://schemas.microsoft.com/office/drawing/2014/main" id="{051AC4B1-0957-429A-A6F0-1D3610C819EC}"/>
               </a:ext>
             </a:extLst>
           </p:cNvPr>
@@ -3850,7 +3850,7 @@
           <p:cNvPr id="7" name="">
             <a:extLst xmlns:a="http://schemas.openxmlformats.org/drawingml/2006/main">
               <a:ext uri="{FF2B5EF4-FFF2-40B4-BE49-F238E27FC236}">
-                <a16:creationId xmlns:a16="http://schemas.microsoft.com/office/drawing/2014/main" id="{571A1B62-15B8-41CB-A4F6-F5FEEA589181}"/>
+                <a16:creationId xmlns:a16="http://schemas.microsoft.com/office/drawing/2014/main" id="{17EE9159-72C7-45D8-925D-F4B24DCB8EAD}"/>
               </a:ext>
             </a:extLst>
           </p:cNvPr>
@@ -3907,7 +3907,7 @@
           <p:cNvPr id="8" name="">
             <a:extLst xmlns:a="http://schemas.openxmlformats.org/drawingml/2006/main">
               <a:ext uri="{FF2B5EF4-FFF2-40B4-BE49-F238E27FC236}">
-                <a16:creationId xmlns:a16="http://schemas.microsoft.com/office/drawing/2014/main" id="{C4B064DC-00C2-459C-8AEB-0CD7213889F1}"/>
+                <a16:creationId xmlns:a16="http://schemas.microsoft.com/office/drawing/2014/main" id="{DC920208-D1A0-4908-A3A0-41F566D5B89A}"/>
               </a:ext>
             </a:extLst>
           </p:cNvPr>
@@ -3964,7 +3964,7 @@
           <p:cNvPr id="9" name="">
             <a:extLst xmlns:a="http://schemas.openxmlformats.org/drawingml/2006/main">
               <a:ext uri="{FF2B5EF4-FFF2-40B4-BE49-F238E27FC236}">
-                <a16:creationId xmlns:a16="http://schemas.microsoft.com/office/drawing/2014/main" id="{684BF5C1-1881-4814-A4AE-292AF9C90DB2}"/>
+                <a16:creationId xmlns:a16="http://schemas.microsoft.com/office/drawing/2014/main" id="{B7AC333C-96BD-457E-91F8-F8EE4459A60C}"/>
               </a:ext>
             </a:extLst>
           </p:cNvPr>
@@ -4021,7 +4021,7 @@
           <p:cNvPr id="10" name="">
             <a:extLst xmlns:a="http://schemas.openxmlformats.org/drawingml/2006/main">
               <a:ext uri="{FF2B5EF4-FFF2-40B4-BE49-F238E27FC236}">
-                <a16:creationId xmlns:a16="http://schemas.microsoft.com/office/drawing/2014/main" id="{FD273CA2-91A5-4003-ADF2-6F0815DA676F}"/>
+                <a16:creationId xmlns:a16="http://schemas.microsoft.com/office/drawing/2014/main" id="{C21E6F83-C3FB-4DC1-A84C-5B2F23A62464}"/>
               </a:ext>
             </a:extLst>
           </p:cNvPr>
@@ -4078,7 +4078,7 @@
           <p:cNvPr id="11" name="">
             <a:extLst xmlns:a="http://schemas.openxmlformats.org/drawingml/2006/main">
               <a:ext uri="{FF2B5EF4-FFF2-40B4-BE49-F238E27FC236}">
-                <a16:creationId xmlns:a16="http://schemas.microsoft.com/office/drawing/2014/main" id="{5A0630DC-3258-4921-8A9B-F48F17655FB1}"/>
+                <a16:creationId xmlns:a16="http://schemas.microsoft.com/office/drawing/2014/main" id="{30913D16-C884-45B2-A957-E6FDC82AF117}"/>
               </a:ext>
             </a:extLst>
           </p:cNvPr>
@@ -4133,7 +4133,7 @@
     </p:spTree>
     <p:extLst>
       <p:ext uri="{BB962C8B-B14F-4D97-AF65-F5344CB8AC3E}">
-        <p14:creationId xmlns:p14="http://schemas.microsoft.com/office/powerpoint/2010/main" val="2109881724"/>
+        <p14:creationId xmlns:p14="http://schemas.microsoft.com/office/powerpoint/2010/main" val="705555188"/>
       </p:ext>
     </p:extLst>
   </p:cSld>
@@ -4164,7 +4164,7 @@
           <p:cNvPr id="12" name="">
             <a:extLst xmlns:a="http://schemas.openxmlformats.org/drawingml/2006/main">
               <a:ext uri="{FF2B5EF4-FFF2-40B4-BE49-F238E27FC236}">
-                <a16:creationId xmlns:a16="http://schemas.microsoft.com/office/drawing/2014/main" id="{76E0F845-826B-4787-9FED-638A2EB33C8B}"/>
+                <a16:creationId xmlns:a16="http://schemas.microsoft.com/office/drawing/2014/main" id="{FFA7344B-00AB-407D-9F08-2147550FEC63}"/>
               </a:ext>
             </a:extLst>
           </p:cNvPr>
@@ -4221,7 +4221,7 @@
           <p:cNvPr id="2" name="">
             <a:extLst xmlns:a="http://schemas.openxmlformats.org/drawingml/2006/main">
               <a:ext uri="{FF2B5EF4-FFF2-40B4-BE49-F238E27FC236}">
-                <a16:creationId xmlns:a16="http://schemas.microsoft.com/office/drawing/2014/main" id="{325C2629-9C42-4FFD-9BA1-CF2F734F4536}"/>
+                <a16:creationId xmlns:a16="http://schemas.microsoft.com/office/drawing/2014/main" id="{EB13E689-6C79-4FB4-B1BA-B579E5A7C88B}"/>
               </a:ext>
             </a:extLst>
           </p:cNvPr>
@@ -4278,7 +4278,7 @@
           <p:cNvPr id="3" name="">
             <a:extLst xmlns:a="http://schemas.openxmlformats.org/drawingml/2006/main">
               <a:ext uri="{FF2B5EF4-FFF2-40B4-BE49-F238E27FC236}">
-                <a16:creationId xmlns:a16="http://schemas.microsoft.com/office/drawing/2014/main" id="{8831E254-4F48-4AFF-B944-5D8F35C58775}"/>
+                <a16:creationId xmlns:a16="http://schemas.microsoft.com/office/drawing/2014/main" id="{45496AB7-E76E-4DFF-847A-07435A699099}"/>
               </a:ext>
             </a:extLst>
           </p:cNvPr>
@@ -4335,7 +4335,7 @@
           <p:cNvPr id="4" name="">
             <a:extLst xmlns:a="http://schemas.openxmlformats.org/drawingml/2006/main">
               <a:ext uri="{FF2B5EF4-FFF2-40B4-BE49-F238E27FC236}">
-                <a16:creationId xmlns:a16="http://schemas.microsoft.com/office/drawing/2014/main" id="{42008862-3A04-49A6-A0C1-ACE553D5AC63}"/>
+                <a16:creationId xmlns:a16="http://schemas.microsoft.com/office/drawing/2014/main" id="{3C3D9F0B-C701-4F14-9CA6-FD6148CE9A0C}"/>
               </a:ext>
             </a:extLst>
           </p:cNvPr>
@@ -4392,7 +4392,7 @@
           <p:cNvPr id="5" name="">
             <a:extLst xmlns:a="http://schemas.openxmlformats.org/drawingml/2006/main">
               <a:ext uri="{FF2B5EF4-FFF2-40B4-BE49-F238E27FC236}">
-                <a16:creationId xmlns:a16="http://schemas.microsoft.com/office/drawing/2014/main" id="{9C4F5E6B-960F-4B89-92B5-F3E921E1997C}"/>
+                <a16:creationId xmlns:a16="http://schemas.microsoft.com/office/drawing/2014/main" id="{931B92C6-BD88-4946-81C2-E64F22826D23}"/>
               </a:ext>
             </a:extLst>
           </p:cNvPr>
@@ -4449,7 +4449,7 @@
           <p:cNvPr id="6" name="">
             <a:extLst xmlns:a="http://schemas.openxmlformats.org/drawingml/2006/main">
               <a:ext uri="{FF2B5EF4-FFF2-40B4-BE49-F238E27FC236}">
-                <a16:creationId xmlns:a16="http://schemas.microsoft.com/office/drawing/2014/main" id="{368C4C50-E97A-4AA0-B2A6-B3D8692D407A}"/>
+                <a16:creationId xmlns:a16="http://schemas.microsoft.com/office/drawing/2014/main" id="{B7E97F28-BEE5-477A-BAA7-A529B889BD05}"/>
               </a:ext>
             </a:extLst>
           </p:cNvPr>
@@ -4506,7 +4506,7 @@
           <p:cNvPr id="7" name="">
             <a:extLst xmlns:a="http://schemas.openxmlformats.org/drawingml/2006/main">
               <a:ext uri="{FF2B5EF4-FFF2-40B4-BE49-F238E27FC236}">
-                <a16:creationId xmlns:a16="http://schemas.microsoft.com/office/drawing/2014/main" id="{47C14471-462F-4D42-BDEA-9E2CA859C2E2}"/>
+                <a16:creationId xmlns:a16="http://schemas.microsoft.com/office/drawing/2014/main" id="{CCDB8A4D-40BD-4E0D-B5E4-92B08F888206}"/>
               </a:ext>
             </a:extLst>
           </p:cNvPr>
@@ -4563,7 +4563,7 @@
           <p:cNvPr id="8" name="">
             <a:extLst xmlns:a="http://schemas.openxmlformats.org/drawingml/2006/main">
               <a:ext uri="{FF2B5EF4-FFF2-40B4-BE49-F238E27FC236}">
-                <a16:creationId xmlns:a16="http://schemas.microsoft.com/office/drawing/2014/main" id="{3484FB69-96CE-43B8-A858-BFA1A2E025EA}"/>
+                <a16:creationId xmlns:a16="http://schemas.microsoft.com/office/drawing/2014/main" id="{64A019D4-30BF-456A-BC50-E5EFB615E8E4}"/>
               </a:ext>
             </a:extLst>
           </p:cNvPr>
@@ -4620,7 +4620,7 @@
           <p:cNvPr id="9" name="">
             <a:extLst xmlns:a="http://schemas.openxmlformats.org/drawingml/2006/main">
               <a:ext uri="{FF2B5EF4-FFF2-40B4-BE49-F238E27FC236}">
-                <a16:creationId xmlns:a16="http://schemas.microsoft.com/office/drawing/2014/main" id="{F1AF5A73-D4C5-41A7-8195-2DDE0E216B5B}"/>
+                <a16:creationId xmlns:a16="http://schemas.microsoft.com/office/drawing/2014/main" id="{1F88BCEB-6BCD-479E-A594-BD098ED4B693}"/>
               </a:ext>
             </a:extLst>
           </p:cNvPr>
@@ -4677,7 +4677,7 @@
           <p:cNvPr id="10" name="">
             <a:extLst xmlns:a="http://schemas.openxmlformats.org/drawingml/2006/main">
               <a:ext uri="{FF2B5EF4-FFF2-40B4-BE49-F238E27FC236}">
-                <a16:creationId xmlns:a16="http://schemas.microsoft.com/office/drawing/2014/main" id="{5DB50755-D3B2-41C4-9602-0A4F43ED060F}"/>
+                <a16:creationId xmlns:a16="http://schemas.microsoft.com/office/drawing/2014/main" id="{A8255345-7BEB-4A0D-BC6E-3C347A04D83C}"/>
               </a:ext>
             </a:extLst>
           </p:cNvPr>
@@ -4734,7 +4734,7 @@
           <p:cNvPr id="11" name="">
             <a:extLst xmlns:a="http://schemas.openxmlformats.org/drawingml/2006/main">
               <a:ext uri="{FF2B5EF4-FFF2-40B4-BE49-F238E27FC236}">
-                <a16:creationId xmlns:a16="http://schemas.microsoft.com/office/drawing/2014/main" id="{03031FA4-0A00-4557-B6F8-D2311FA5EB04}"/>
+                <a16:creationId xmlns:a16="http://schemas.microsoft.com/office/drawing/2014/main" id="{7E66389F-2A5D-4472-AF1C-01DCC1236179}"/>
               </a:ext>
             </a:extLst>
           </p:cNvPr>
@@ -4789,7 +4789,7 @@
     </p:spTree>
     <p:extLst>
       <p:ext uri="{BB962C8B-B14F-4D97-AF65-F5344CB8AC3E}">
-        <p14:creationId xmlns:p14="http://schemas.microsoft.com/office/powerpoint/2010/main" val="2042230017"/>
+        <p14:creationId xmlns:p14="http://schemas.microsoft.com/office/powerpoint/2010/main" val="1855373990"/>
       </p:ext>
     </p:extLst>
   </p:cSld>
@@ -4820,7 +4820,7 @@
           <p:cNvPr id="7" name="">
             <a:extLst xmlns:a="http://schemas.openxmlformats.org/drawingml/2006/main">
               <a:ext uri="{FF2B5EF4-FFF2-40B4-BE49-F238E27FC236}">
-                <a16:creationId xmlns:a16="http://schemas.microsoft.com/office/drawing/2014/main" id="{4A7E2DB6-31EE-4CD6-BDC2-31237BF05E78}"/>
+                <a16:creationId xmlns:a16="http://schemas.microsoft.com/office/drawing/2014/main" id="{F7E2EFC7-E806-4C85-8320-71615BAA2DE5}"/>
               </a:ext>
             </a:extLst>
           </p:cNvPr>
@@ -4877,7 +4877,7 @@
           <p:cNvPr id="2" name="">
             <a:extLst xmlns:a="http://schemas.openxmlformats.org/drawingml/2006/main">
               <a:ext uri="{FF2B5EF4-FFF2-40B4-BE49-F238E27FC236}">
-                <a16:creationId xmlns:a16="http://schemas.microsoft.com/office/drawing/2014/main" id="{C881F7C9-26C4-4B28-8B13-5BE19A49FDC2}"/>
+                <a16:creationId xmlns:a16="http://schemas.microsoft.com/office/drawing/2014/main" id="{160D2E39-D15D-41B4-A58E-3F4D3217F720}"/>
               </a:ext>
             </a:extLst>
           </p:cNvPr>
@@ -4934,7 +4934,7 @@
           <p:cNvPr id="3" name="">
             <a:extLst xmlns:a="http://schemas.openxmlformats.org/drawingml/2006/main">
               <a:ext uri="{FF2B5EF4-FFF2-40B4-BE49-F238E27FC236}">
-                <a16:creationId xmlns:a16="http://schemas.microsoft.com/office/drawing/2014/main" id="{56B38471-2433-4DFE-97FD-61EDA3979868}"/>
+                <a16:creationId xmlns:a16="http://schemas.microsoft.com/office/drawing/2014/main" id="{FE56DEB4-CD46-4215-B39F-A97BBD3F95A0}"/>
               </a:ext>
             </a:extLst>
           </p:cNvPr>
@@ -4991,7 +4991,7 @@
           <p:cNvPr id="4" name="">
             <a:extLst xmlns:a="http://schemas.openxmlformats.org/drawingml/2006/main">
               <a:ext uri="{FF2B5EF4-FFF2-40B4-BE49-F238E27FC236}">
-                <a16:creationId xmlns:a16="http://schemas.microsoft.com/office/drawing/2014/main" id="{603E2276-A160-4D0B-82BC-570CE3C5C79E}"/>
+                <a16:creationId xmlns:a16="http://schemas.microsoft.com/office/drawing/2014/main" id="{5469D3D5-191E-4E66-9D61-078CF88F5BCB}"/>
               </a:ext>
             </a:extLst>
           </p:cNvPr>
@@ -5048,7 +5048,7 @@
           <p:cNvPr id="5" name="">
             <a:extLst xmlns:a="http://schemas.openxmlformats.org/drawingml/2006/main">
               <a:ext uri="{FF2B5EF4-FFF2-40B4-BE49-F238E27FC236}">
-                <a16:creationId xmlns:a16="http://schemas.microsoft.com/office/drawing/2014/main" id="{E56FFC58-545B-46EF-9DC9-9C445D410313}"/>
+                <a16:creationId xmlns:a16="http://schemas.microsoft.com/office/drawing/2014/main" id="{C220CB41-1555-4D51-BCB7-D70D65E75AE6}"/>
               </a:ext>
             </a:extLst>
           </p:cNvPr>
@@ -5105,7 +5105,7 @@
           <p:cNvPr id="6" name="">
             <a:extLst xmlns:a="http://schemas.openxmlformats.org/drawingml/2006/main">
               <a:ext uri="{FF2B5EF4-FFF2-40B4-BE49-F238E27FC236}">
-                <a16:creationId xmlns:a16="http://schemas.microsoft.com/office/drawing/2014/main" id="{7323C1BC-0E71-4554-98E3-0AB63E4734AE}"/>
+                <a16:creationId xmlns:a16="http://schemas.microsoft.com/office/drawing/2014/main" id="{F4C30831-75BC-4DA4-8F12-AB89FF7E9783}"/>
               </a:ext>
             </a:extLst>
           </p:cNvPr>
@@ -5183,7 +5183,7 @@
     </p:spTree>
     <p:extLst>
       <p:ext uri="{BB962C8B-B14F-4D97-AF65-F5344CB8AC3E}">
-        <p14:creationId xmlns:p14="http://schemas.microsoft.com/office/powerpoint/2010/main" val="1833625751"/>
+        <p14:creationId xmlns:p14="http://schemas.microsoft.com/office/powerpoint/2010/main" val="256017258"/>
       </p:ext>
     </p:extLst>
   </p:cSld>
@@ -5214,7 +5214,7 @@
           <p:cNvPr id="8" name="">
             <a:extLst xmlns:a="http://schemas.openxmlformats.org/drawingml/2006/main">
               <a:ext uri="{FF2B5EF4-FFF2-40B4-BE49-F238E27FC236}">
-                <a16:creationId xmlns:a16="http://schemas.microsoft.com/office/drawing/2014/main" id="{3827A1C6-BF7C-48E8-A1B4-E5848D316D92}"/>
+                <a16:creationId xmlns:a16="http://schemas.microsoft.com/office/drawing/2014/main" id="{B3F6B5F7-BB33-4DF4-B618-CF9C97ADD905}"/>
               </a:ext>
             </a:extLst>
           </p:cNvPr>
@@ -5271,7 +5271,7 @@
           <p:cNvPr id="2" name="">
             <a:extLst xmlns:a="http://schemas.openxmlformats.org/drawingml/2006/main">
               <a:ext uri="{FF2B5EF4-FFF2-40B4-BE49-F238E27FC236}">
-                <a16:creationId xmlns:a16="http://schemas.microsoft.com/office/drawing/2014/main" id="{FB96AD7C-1A30-40BC-98DA-E38553969D2F}"/>
+                <a16:creationId xmlns:a16="http://schemas.microsoft.com/office/drawing/2014/main" id="{5D0C5B68-D4C0-4BF5-B8C3-978D57AF83B6}"/>
               </a:ext>
             </a:extLst>
           </p:cNvPr>
@@ -5328,7 +5328,7 @@
           <p:cNvPr id="3" name="">
             <a:extLst xmlns:a="http://schemas.openxmlformats.org/drawingml/2006/main">
               <a:ext uri="{FF2B5EF4-FFF2-40B4-BE49-F238E27FC236}">
-                <a16:creationId xmlns:a16="http://schemas.microsoft.com/office/drawing/2014/main" id="{0A37E177-2B8E-4E7F-B7F2-EFBC1BD0CED1}"/>
+                <a16:creationId xmlns:a16="http://schemas.microsoft.com/office/drawing/2014/main" id="{BA4B1F07-6013-4E88-BA8F-DAC98AAFA0F6}"/>
               </a:ext>
             </a:extLst>
           </p:cNvPr>
@@ -5385,7 +5385,7 @@
           <p:cNvPr id="4" name="">
             <a:extLst xmlns:a="http://schemas.openxmlformats.org/drawingml/2006/main">
               <a:ext uri="{FF2B5EF4-FFF2-40B4-BE49-F238E27FC236}">
-                <a16:creationId xmlns:a16="http://schemas.microsoft.com/office/drawing/2014/main" id="{1E239B37-EB86-478A-BE9A-39B408A26957}"/>
+                <a16:creationId xmlns:a16="http://schemas.microsoft.com/office/drawing/2014/main" id="{05EEC165-F564-49B0-97BD-810BABAC7514}"/>
               </a:ext>
             </a:extLst>
           </p:cNvPr>
@@ -5442,7 +5442,7 @@
           <p:cNvPr id="5" name="">
             <a:extLst xmlns:a="http://schemas.openxmlformats.org/drawingml/2006/main">
               <a:ext uri="{FF2B5EF4-FFF2-40B4-BE49-F238E27FC236}">
-                <a16:creationId xmlns:a16="http://schemas.microsoft.com/office/drawing/2014/main" id="{62D65B91-ADF5-474C-9DD6-221D12AA17FF}"/>
+                <a16:creationId xmlns:a16="http://schemas.microsoft.com/office/drawing/2014/main" id="{C18BCFCF-250B-4EFB-8C81-6D53EAB50163}"/>
               </a:ext>
             </a:extLst>
           </p:cNvPr>
@@ -5689,7 +5689,7 @@
           <p:cNvPr id="7" name="">
             <a:extLst xmlns:a="http://schemas.openxmlformats.org/drawingml/2006/main">
               <a:ext uri="{FF2B5EF4-FFF2-40B4-BE49-F238E27FC236}">
-                <a16:creationId xmlns:a16="http://schemas.microsoft.com/office/drawing/2014/main" id="{DCDFC605-5EF9-41D5-80AB-D4D135A5200B}"/>
+                <a16:creationId xmlns:a16="http://schemas.microsoft.com/office/drawing/2014/main" id="{D8DF2DB6-1E0D-4170-AD53-A7C70CF044C7}"/>
               </a:ext>
             </a:extLst>
           </p:cNvPr>
@@ -5744,7 +5744,7 @@
     </p:spTree>
     <p:extLst>
       <p:ext uri="{BB962C8B-B14F-4D97-AF65-F5344CB8AC3E}">
-        <p14:creationId xmlns:p14="http://schemas.microsoft.com/office/powerpoint/2010/main" val="1277582039"/>
+        <p14:creationId xmlns:p14="http://schemas.microsoft.com/office/powerpoint/2010/main" val="1628544134"/>
       </p:ext>
     </p:extLst>
   </p:cSld>
@@ -5775,7 +5775,7 @@
           <p:cNvPr id="9" name="">
             <a:extLst xmlns:a="http://schemas.openxmlformats.org/drawingml/2006/main">
               <a:ext uri="{FF2B5EF4-FFF2-40B4-BE49-F238E27FC236}">
-                <a16:creationId xmlns:a16="http://schemas.microsoft.com/office/drawing/2014/main" id="{114FA131-F500-433E-B0A9-D67E664456CB}"/>
+                <a16:creationId xmlns:a16="http://schemas.microsoft.com/office/drawing/2014/main" id="{02552E46-F014-438B-8C67-D4804F9A9088}"/>
               </a:ext>
             </a:extLst>
           </p:cNvPr>
@@ -5832,7 +5832,7 @@
           <p:cNvPr id="2" name="">
             <a:extLst xmlns:a="http://schemas.openxmlformats.org/drawingml/2006/main">
               <a:ext uri="{FF2B5EF4-FFF2-40B4-BE49-F238E27FC236}">
-                <a16:creationId xmlns:a16="http://schemas.microsoft.com/office/drawing/2014/main" id="{AF5E6F82-3DFC-455F-BCF8-09A3BF318DEF}"/>
+                <a16:creationId xmlns:a16="http://schemas.microsoft.com/office/drawing/2014/main" id="{E86578FA-35D7-4197-B991-6D834D65D66F}"/>
               </a:ext>
             </a:extLst>
           </p:cNvPr>
@@ -5889,7 +5889,7 @@
           <p:cNvPr id="3" name="">
             <a:extLst xmlns:a="http://schemas.openxmlformats.org/drawingml/2006/main">
               <a:ext uri="{FF2B5EF4-FFF2-40B4-BE49-F238E27FC236}">
-                <a16:creationId xmlns:a16="http://schemas.microsoft.com/office/drawing/2014/main" id="{9F7D909C-9A7E-4F62-88A1-3617889A0BA9}"/>
+                <a16:creationId xmlns:a16="http://schemas.microsoft.com/office/drawing/2014/main" id="{D864E1D1-07E6-4A71-9B60-3529DAD276FE}"/>
               </a:ext>
             </a:extLst>
           </p:cNvPr>
@@ -5946,7 +5946,7 @@
           <p:cNvPr id="4" name="">
             <a:extLst xmlns:a="http://schemas.openxmlformats.org/drawingml/2006/main">
               <a:ext uri="{FF2B5EF4-FFF2-40B4-BE49-F238E27FC236}">
-                <a16:creationId xmlns:a16="http://schemas.microsoft.com/office/drawing/2014/main" id="{B77FB511-DC56-4071-9779-604E2C9CC6EB}"/>
+                <a16:creationId xmlns:a16="http://schemas.microsoft.com/office/drawing/2014/main" id="{2DBC5DED-C0A8-45AB-8DE7-ED227DC8BF87}"/>
               </a:ext>
             </a:extLst>
           </p:cNvPr>
@@ -6003,7 +6003,7 @@
           <p:cNvPr id="5" name="">
             <a:extLst xmlns:a="http://schemas.openxmlformats.org/drawingml/2006/main">
               <a:ext uri="{FF2B5EF4-FFF2-40B4-BE49-F238E27FC236}">
-                <a16:creationId xmlns:a16="http://schemas.microsoft.com/office/drawing/2014/main" id="{771E9243-05B8-4C17-9648-31F1FEF01CE6}"/>
+                <a16:creationId xmlns:a16="http://schemas.microsoft.com/office/drawing/2014/main" id="{A7C6757E-C2D3-4FF6-827C-51D63D0509CF}"/>
               </a:ext>
             </a:extLst>
           </p:cNvPr>
@@ -6060,7 +6060,7 @@
           <p:cNvPr id="6" name="">
             <a:extLst xmlns:a="http://schemas.openxmlformats.org/drawingml/2006/main">
               <a:ext uri="{FF2B5EF4-FFF2-40B4-BE49-F238E27FC236}">
-                <a16:creationId xmlns:a16="http://schemas.microsoft.com/office/drawing/2014/main" id="{8DBE6524-6E83-43D1-800A-A69A52E59F3F}"/>
+                <a16:creationId xmlns:a16="http://schemas.microsoft.com/office/drawing/2014/main" id="{AE705107-E7BF-428A-90AA-F96C10DF883A}"/>
               </a:ext>
             </a:extLst>
           </p:cNvPr>
@@ -6117,7 +6117,7 @@
           <p:cNvPr id="7" name="">
             <a:extLst xmlns:a="http://schemas.openxmlformats.org/drawingml/2006/main">
               <a:ext uri="{FF2B5EF4-FFF2-40B4-BE49-F238E27FC236}">
-                <a16:creationId xmlns:a16="http://schemas.microsoft.com/office/drawing/2014/main" id="{4B018587-6F07-45AD-B2DB-10AAADA0E47E}"/>
+                <a16:creationId xmlns:a16="http://schemas.microsoft.com/office/drawing/2014/main" id="{CEAEB168-D055-4C5A-B92F-EB99D3609A7E}"/>
               </a:ext>
             </a:extLst>
           </p:cNvPr>
@@ -6174,7 +6174,7 @@
           <p:cNvPr id="8" name="">
             <a:extLst xmlns:a="http://schemas.openxmlformats.org/drawingml/2006/main">
               <a:ext uri="{FF2B5EF4-FFF2-40B4-BE49-F238E27FC236}">
-                <a16:creationId xmlns:a16="http://schemas.microsoft.com/office/drawing/2014/main" id="{9B0D38BC-12DA-4155-9ABF-1275E24A2DAF}"/>
+                <a16:creationId xmlns:a16="http://schemas.microsoft.com/office/drawing/2014/main" id="{41D98FDA-64B5-4489-9C23-16A93E070E0B}"/>
               </a:ext>
             </a:extLst>
           </p:cNvPr>
@@ -6252,7 +6252,7 @@
     </p:spTree>
     <p:extLst>
       <p:ext uri="{BB962C8B-B14F-4D97-AF65-F5344CB8AC3E}">
-        <p14:creationId xmlns:p14="http://schemas.microsoft.com/office/powerpoint/2010/main" val="2014967985"/>
+        <p14:creationId xmlns:p14="http://schemas.microsoft.com/office/powerpoint/2010/main" val="1425716084"/>
       </p:ext>
     </p:extLst>
   </p:cSld>
@@ -6283,7 +6283,7 @@
           <p:cNvPr id="8" name="">
             <a:extLst xmlns:a="http://schemas.openxmlformats.org/drawingml/2006/main">
               <a:ext uri="{FF2B5EF4-FFF2-40B4-BE49-F238E27FC236}">
-                <a16:creationId xmlns:a16="http://schemas.microsoft.com/office/drawing/2014/main" id="{C9620BDF-0FB9-4B94-B4D5-E80311BEBDCC}"/>
+                <a16:creationId xmlns:a16="http://schemas.microsoft.com/office/drawing/2014/main" id="{CB4DB22E-C88B-4669-9FBE-ED67BF2B7776}"/>
               </a:ext>
             </a:extLst>
           </p:cNvPr>
@@ -6340,7 +6340,7 @@
           <p:cNvPr id="2" name="">
             <a:extLst xmlns:a="http://schemas.openxmlformats.org/drawingml/2006/main">
               <a:ext uri="{FF2B5EF4-FFF2-40B4-BE49-F238E27FC236}">
-                <a16:creationId xmlns:a16="http://schemas.microsoft.com/office/drawing/2014/main" id="{AE0F2389-077B-442D-A7C3-8704D8A7357C}"/>
+                <a16:creationId xmlns:a16="http://schemas.microsoft.com/office/drawing/2014/main" id="{EB99ECE0-34F9-4DDA-AA17-CAFE690AD23C}"/>
               </a:ext>
             </a:extLst>
           </p:cNvPr>
@@ -6397,7 +6397,7 @@
           <p:cNvPr id="3" name="">
             <a:extLst xmlns:a="http://schemas.openxmlformats.org/drawingml/2006/main">
               <a:ext uri="{FF2B5EF4-FFF2-40B4-BE49-F238E27FC236}">
-                <a16:creationId xmlns:a16="http://schemas.microsoft.com/office/drawing/2014/main" id="{1F3DC100-1FC5-49FC-AC5C-412FBB12F0CD}"/>
+                <a16:creationId xmlns:a16="http://schemas.microsoft.com/office/drawing/2014/main" id="{548BA0B0-25B2-47C1-9851-DB1D173D4C96}"/>
               </a:ext>
             </a:extLst>
           </p:cNvPr>
@@ -6454,7 +6454,7 @@
           <p:cNvPr id="4" name="">
             <a:extLst xmlns:a="http://schemas.openxmlformats.org/drawingml/2006/main">
               <a:ext uri="{FF2B5EF4-FFF2-40B4-BE49-F238E27FC236}">
-                <a16:creationId xmlns:a16="http://schemas.microsoft.com/office/drawing/2014/main" id="{AB1AAFE3-2AE7-4320-8C76-B24B105BE3F8}"/>
+                <a16:creationId xmlns:a16="http://schemas.microsoft.com/office/drawing/2014/main" id="{C4C9F387-451F-4F6A-9100-214BCC7E70E0}"/>
               </a:ext>
             </a:extLst>
           </p:cNvPr>
@@ -6511,7 +6511,7 @@
           <p:cNvPr id="5" name="">
             <a:extLst xmlns:a="http://schemas.openxmlformats.org/drawingml/2006/main">
               <a:ext uri="{FF2B5EF4-FFF2-40B4-BE49-F238E27FC236}">
-                <a16:creationId xmlns:a16="http://schemas.microsoft.com/office/drawing/2014/main" id="{E46BE2FF-532B-4FE3-B5B3-28F266A0FBD1}"/>
+                <a16:creationId xmlns:a16="http://schemas.microsoft.com/office/drawing/2014/main" id="{2485B070-E695-4859-9E84-7CB077CD884E}"/>
               </a:ext>
             </a:extLst>
           </p:cNvPr>
@@ -6840,7 +6840,7 @@
           <p:cNvPr id="7" name="">
             <a:extLst xmlns:a="http://schemas.openxmlformats.org/drawingml/2006/main">
               <a:ext uri="{FF2B5EF4-FFF2-40B4-BE49-F238E27FC236}">
-                <a16:creationId xmlns:a16="http://schemas.microsoft.com/office/drawing/2014/main" id="{3831599D-00D5-4320-9F1C-D434601A1856}"/>
+                <a16:creationId xmlns:a16="http://schemas.microsoft.com/office/drawing/2014/main" id="{38B86D11-7A0A-48ED-A443-6F5F4EFB7F29}"/>
               </a:ext>
             </a:extLst>
           </p:cNvPr>
@@ -6918,7 +6918,7 @@
     </p:spTree>
     <p:extLst>
       <p:ext uri="{BB962C8B-B14F-4D97-AF65-F5344CB8AC3E}">
-        <p14:creationId xmlns:p14="http://schemas.microsoft.com/office/powerpoint/2010/main" val="1754387128"/>
+        <p14:creationId xmlns:p14="http://schemas.microsoft.com/office/powerpoint/2010/main" val="1688830113"/>
       </p:ext>
     </p:extLst>
   </p:cSld>
@@ -6949,7 +6949,7 @@
           <p:cNvPr id="8" name="">
             <a:extLst xmlns:a="http://schemas.openxmlformats.org/drawingml/2006/main">
               <a:ext uri="{FF2B5EF4-FFF2-40B4-BE49-F238E27FC236}">
-                <a16:creationId xmlns:a16="http://schemas.microsoft.com/office/drawing/2014/main" id="{A3EF87FD-36FB-4F20-A65E-8A9B9D6C9927}"/>
+                <a16:creationId xmlns:a16="http://schemas.microsoft.com/office/drawing/2014/main" id="{4B78ADE5-DBBF-487B-87E3-25FD722311AA}"/>
               </a:ext>
             </a:extLst>
           </p:cNvPr>
@@ -7006,7 +7006,7 @@
           <p:cNvPr id="2" name="">
             <a:extLst xmlns:a="http://schemas.openxmlformats.org/drawingml/2006/main">
               <a:ext uri="{FF2B5EF4-FFF2-40B4-BE49-F238E27FC236}">
-                <a16:creationId xmlns:a16="http://schemas.microsoft.com/office/drawing/2014/main" id="{6A7EB8A3-9B38-4E43-9272-D09AAFAFA33F}"/>
+                <a16:creationId xmlns:a16="http://schemas.microsoft.com/office/drawing/2014/main" id="{94FAD884-C606-47BE-A9F2-6D9A83233F53}"/>
               </a:ext>
             </a:extLst>
           </p:cNvPr>
@@ -7063,7 +7063,7 @@
           <p:cNvPr id="3" name="">
             <a:extLst xmlns:a="http://schemas.openxmlformats.org/drawingml/2006/main">
               <a:ext uri="{FF2B5EF4-FFF2-40B4-BE49-F238E27FC236}">
-                <a16:creationId xmlns:a16="http://schemas.microsoft.com/office/drawing/2014/main" id="{17A1C1FC-E836-4FB8-84F7-EAA147275D8A}"/>
+                <a16:creationId xmlns:a16="http://schemas.microsoft.com/office/drawing/2014/main" id="{92A30062-D148-466C-848C-DE34B2576044}"/>
               </a:ext>
             </a:extLst>
           </p:cNvPr>
@@ -7120,7 +7120,7 @@
           <p:cNvPr id="4" name="">
             <a:extLst xmlns:a="http://schemas.openxmlformats.org/drawingml/2006/main">
               <a:ext uri="{FF2B5EF4-FFF2-40B4-BE49-F238E27FC236}">
-                <a16:creationId xmlns:a16="http://schemas.microsoft.com/office/drawing/2014/main" id="{774EF4D1-919F-4523-91DD-20EC4E0EE4F6}"/>
+                <a16:creationId xmlns:a16="http://schemas.microsoft.com/office/drawing/2014/main" id="{94EE08E4-AE03-402E-80D6-64463CE314F2}"/>
               </a:ext>
             </a:extLst>
           </p:cNvPr>
@@ -7184,7 +7184,7 @@
         </p:xfrm>
         <a:graphic xmlns:a="http://schemas.openxmlformats.org/drawingml/2006/main">
           <a:graphicData uri="http://schemas.openxmlformats.org/drawingml/2006/chart">
-            <c:chart xmlns:r="http://schemas.openxmlformats.org/officeDocument/2006/relationships" xmlns:c="http://schemas.openxmlformats.org/drawingml/2006/chart" r:id="Rdf260e3c03544a0d"/>
+            <c:chart xmlns:r="http://schemas.openxmlformats.org/officeDocument/2006/relationships" xmlns:c="http://schemas.openxmlformats.org/drawingml/2006/chart" r:id="Ra420aa03fa9b461e"/>
           </a:graphicData>
         </a:graphic>
       </p:graphicFrame>
@@ -7193,7 +7193,7 @@
           <p:cNvPr id="6" name="">
             <a:extLst xmlns:a="http://schemas.openxmlformats.org/drawingml/2006/main">
               <a:ext uri="{FF2B5EF4-FFF2-40B4-BE49-F238E27FC236}">
-                <a16:creationId xmlns:a16="http://schemas.microsoft.com/office/drawing/2014/main" id="{B5F8D5EE-220C-42B2-8466-2307F6DC4BD9}"/>
+                <a16:creationId xmlns:a16="http://schemas.microsoft.com/office/drawing/2014/main" id="{D924A61E-40BC-4821-91B0-F1677097C676}"/>
               </a:ext>
             </a:extLst>
           </p:cNvPr>
@@ -7250,7 +7250,7 @@
           <p:cNvPr id="7" name="">
             <a:extLst xmlns:a="http://schemas.openxmlformats.org/drawingml/2006/main">
               <a:ext uri="{FF2B5EF4-FFF2-40B4-BE49-F238E27FC236}">
-                <a16:creationId xmlns:a16="http://schemas.microsoft.com/office/drawing/2014/main" id="{ADF959E7-0FF3-4C86-A637-7550E008DD6F}"/>
+                <a16:creationId xmlns:a16="http://schemas.microsoft.com/office/drawing/2014/main" id="{F0C2EDAC-963A-444E-8A6D-12540C325F45}"/>
               </a:ext>
             </a:extLst>
           </p:cNvPr>
@@ -7305,7 +7305,7 @@
     </p:spTree>
     <p:extLst>
       <p:ext uri="{BB962C8B-B14F-4D97-AF65-F5344CB8AC3E}">
-        <p14:creationId xmlns:p14="http://schemas.microsoft.com/office/powerpoint/2010/main" val="1669234151"/>
+        <p14:creationId xmlns:p14="http://schemas.microsoft.com/office/powerpoint/2010/main" val="680102961"/>
       </p:ext>
     </p:extLst>
   </p:cSld>
@@ -7336,7 +7336,7 @@
           <p:cNvPr id="8" name="">
             <a:extLst xmlns:a="http://schemas.openxmlformats.org/drawingml/2006/main">
               <a:ext uri="{FF2B5EF4-FFF2-40B4-BE49-F238E27FC236}">
-                <a16:creationId xmlns:a16="http://schemas.microsoft.com/office/drawing/2014/main" id="{2300E0D4-D35C-4D57-BE50-714DE20AD2E3}"/>
+                <a16:creationId xmlns:a16="http://schemas.microsoft.com/office/drawing/2014/main" id="{B51DE6C3-A68E-41C4-B944-8CC76B3AD859}"/>
               </a:ext>
             </a:extLst>
           </p:cNvPr>
@@ -7393,7 +7393,7 @@
           <p:cNvPr id="2" name="">
             <a:extLst xmlns:a="http://schemas.openxmlformats.org/drawingml/2006/main">
               <a:ext uri="{FF2B5EF4-FFF2-40B4-BE49-F238E27FC236}">
-                <a16:creationId xmlns:a16="http://schemas.microsoft.com/office/drawing/2014/main" id="{747962A7-7248-4F7B-812D-090E2D992092}"/>
+                <a16:creationId xmlns:a16="http://schemas.microsoft.com/office/drawing/2014/main" id="{A75A9A5A-46D2-47EC-BE38-E4EFD70D672B}"/>
               </a:ext>
             </a:extLst>
           </p:cNvPr>
@@ -7450,7 +7450,7 @@
           <p:cNvPr id="3" name="">
             <a:extLst xmlns:a="http://schemas.openxmlformats.org/drawingml/2006/main">
               <a:ext uri="{FF2B5EF4-FFF2-40B4-BE49-F238E27FC236}">
-                <a16:creationId xmlns:a16="http://schemas.microsoft.com/office/drawing/2014/main" id="{4B8B7B2E-DC77-4327-896C-D2BC0356953B}"/>
+                <a16:creationId xmlns:a16="http://schemas.microsoft.com/office/drawing/2014/main" id="{EDC152C4-7821-47A7-A39E-9B0BA376F813}"/>
               </a:ext>
             </a:extLst>
           </p:cNvPr>
@@ -7507,7 +7507,7 @@
           <p:cNvPr id="4" name="">
             <a:extLst xmlns:a="http://schemas.openxmlformats.org/drawingml/2006/main">
               <a:ext uri="{FF2B5EF4-FFF2-40B4-BE49-F238E27FC236}">
-                <a16:creationId xmlns:a16="http://schemas.microsoft.com/office/drawing/2014/main" id="{A98DCC02-8C42-4EF5-A73B-4400C3351C2B}"/>
+                <a16:creationId xmlns:a16="http://schemas.microsoft.com/office/drawing/2014/main" id="{7B2F115D-6F57-40F5-AF9F-23C9543568E4}"/>
               </a:ext>
             </a:extLst>
           </p:cNvPr>
@@ -7564,7 +7564,7 @@
           <p:cNvPr id="5" name="">
             <a:extLst xmlns:a="http://schemas.openxmlformats.org/drawingml/2006/main">
               <a:ext uri="{FF2B5EF4-FFF2-40B4-BE49-F238E27FC236}">
-                <a16:creationId xmlns:a16="http://schemas.microsoft.com/office/drawing/2014/main" id="{32EF0442-9358-49EF-A001-0C7B0743CA32}"/>
+                <a16:creationId xmlns:a16="http://schemas.microsoft.com/office/drawing/2014/main" id="{2E9EB3D2-595E-4B2F-8AB4-4BCA02C775DB}"/>
               </a:ext>
             </a:extLst>
           </p:cNvPr>
@@ -7621,7 +7621,7 @@
           <p:cNvPr id="6" name="">
             <a:extLst xmlns:a="http://schemas.openxmlformats.org/drawingml/2006/main">
               <a:ext uri="{FF2B5EF4-FFF2-40B4-BE49-F238E27FC236}">
-                <a16:creationId xmlns:a16="http://schemas.microsoft.com/office/drawing/2014/main" id="{1603C6C6-2BAA-4082-9506-598D9BB628F3}"/>
+                <a16:creationId xmlns:a16="http://schemas.microsoft.com/office/drawing/2014/main" id="{BC0A30A7-799A-491E-8EE9-397B98A51355}"/>
               </a:ext>
             </a:extLst>
           </p:cNvPr>
@@ -7678,7 +7678,7 @@
           <p:cNvPr id="7" name="">
             <a:extLst xmlns:a="http://schemas.openxmlformats.org/drawingml/2006/main">
               <a:ext uri="{FF2B5EF4-FFF2-40B4-BE49-F238E27FC236}">
-                <a16:creationId xmlns:a16="http://schemas.microsoft.com/office/drawing/2014/main" id="{404A4BF5-2F13-4A6A-8993-DAB393FC2BBF}"/>
+                <a16:creationId xmlns:a16="http://schemas.microsoft.com/office/drawing/2014/main" id="{24DCA3B4-4C22-4CDE-819C-C93CFF858F33}"/>
               </a:ext>
             </a:extLst>
           </p:cNvPr>
@@ -7733,7 +7733,7 @@
     </p:spTree>
     <p:extLst>
       <p:ext uri="{BB962C8B-B14F-4D97-AF65-F5344CB8AC3E}">
-        <p14:creationId xmlns:p14="http://schemas.microsoft.com/office/powerpoint/2010/main" val="170179587"/>
+        <p14:creationId xmlns:p14="http://schemas.microsoft.com/office/powerpoint/2010/main" val="1479781159"/>
       </p:ext>
     </p:extLst>
   </p:cSld>
@@ -7764,7 +7764,7 @@
           <p:cNvPr id="8" name="">
             <a:extLst xmlns:a="http://schemas.openxmlformats.org/drawingml/2006/main">
               <a:ext uri="{FF2B5EF4-FFF2-40B4-BE49-F238E27FC236}">
-                <a16:creationId xmlns:a16="http://schemas.microsoft.com/office/drawing/2014/main" id="{C43A69EA-C53D-4E45-A1E0-551B063450C6}"/>
+                <a16:creationId xmlns:a16="http://schemas.microsoft.com/office/drawing/2014/main" id="{587F7B8E-8DFB-43F6-BF10-AEB4DFD5BFFB}"/>
               </a:ext>
             </a:extLst>
           </p:cNvPr>
@@ -7821,7 +7821,7 @@
           <p:cNvPr id="2" name="">
             <a:extLst xmlns:a="http://schemas.openxmlformats.org/drawingml/2006/main">
               <a:ext uri="{FF2B5EF4-FFF2-40B4-BE49-F238E27FC236}">
-                <a16:creationId xmlns:a16="http://schemas.microsoft.com/office/drawing/2014/main" id="{915F335A-D754-4A90-A486-4C611E451E46}"/>
+                <a16:creationId xmlns:a16="http://schemas.microsoft.com/office/drawing/2014/main" id="{5DCD86D2-B08E-4451-827C-140A9D224311}"/>
               </a:ext>
             </a:extLst>
           </p:cNvPr>
@@ -7878,7 +7878,7 @@
           <p:cNvPr id="3" name="">
             <a:extLst xmlns:a="http://schemas.openxmlformats.org/drawingml/2006/main">
               <a:ext uri="{FF2B5EF4-FFF2-40B4-BE49-F238E27FC236}">
-                <a16:creationId xmlns:a16="http://schemas.microsoft.com/office/drawing/2014/main" id="{8E791E69-E6C6-4F2A-BE0C-F69318E6BC64}"/>
+                <a16:creationId xmlns:a16="http://schemas.microsoft.com/office/drawing/2014/main" id="{B08AEA94-CA48-4E41-98CC-52156C036B81}"/>
               </a:ext>
             </a:extLst>
           </p:cNvPr>
@@ -7935,7 +7935,7 @@
           <p:cNvPr id="4" name="">
             <a:extLst xmlns:a="http://schemas.openxmlformats.org/drawingml/2006/main">
               <a:ext uri="{FF2B5EF4-FFF2-40B4-BE49-F238E27FC236}">
-                <a16:creationId xmlns:a16="http://schemas.microsoft.com/office/drawing/2014/main" id="{8D9EBFB3-4724-4297-A8C4-86F166FBC6FB}"/>
+                <a16:creationId xmlns:a16="http://schemas.microsoft.com/office/drawing/2014/main" id="{8D70B9CF-6E60-432C-91BA-D3BF0B818C4C}"/>
               </a:ext>
             </a:extLst>
           </p:cNvPr>
@@ -7992,7 +7992,7 @@
           <p:cNvPr id="5" name="">
             <a:extLst xmlns:a="http://schemas.openxmlformats.org/drawingml/2006/main">
               <a:ext uri="{FF2B5EF4-FFF2-40B4-BE49-F238E27FC236}">
-                <a16:creationId xmlns:a16="http://schemas.microsoft.com/office/drawing/2014/main" id="{21CA8947-9559-4CC2-9FCB-0B4FE92DB3E3}"/>
+                <a16:creationId xmlns:a16="http://schemas.microsoft.com/office/drawing/2014/main" id="{11722612-D8C2-4A22-9CB3-874BD485F86F}"/>
               </a:ext>
             </a:extLst>
           </p:cNvPr>
@@ -8295,7 +8295,7 @@
           <p:cNvPr id="7" name="">
             <a:extLst xmlns:a="http://schemas.openxmlformats.org/drawingml/2006/main">
               <a:ext uri="{FF2B5EF4-FFF2-40B4-BE49-F238E27FC236}">
-                <a16:creationId xmlns:a16="http://schemas.microsoft.com/office/drawing/2014/main" id="{6B827A3F-1121-436C-9390-8053599EC31B}"/>
+                <a16:creationId xmlns:a16="http://schemas.microsoft.com/office/drawing/2014/main" id="{50CC3E21-44A1-4B64-A2A9-8894C67FCF42}"/>
               </a:ext>
             </a:extLst>
           </p:cNvPr>
@@ -8373,7 +8373,7 @@
     </p:spTree>
     <p:extLst>
       <p:ext uri="{BB962C8B-B14F-4D97-AF65-F5344CB8AC3E}">
-        <p14:creationId xmlns:p14="http://schemas.microsoft.com/office/powerpoint/2010/main" val="2108004649"/>
+        <p14:creationId xmlns:p14="http://schemas.microsoft.com/office/powerpoint/2010/main" val="45045988"/>
       </p:ext>
     </p:extLst>
   </p:cSld>
@@ -8401,10 +8401,10 @@
       </p:grpSpPr>
       <p:sp>
         <p:nvSpPr>
-          <p:cNvPr id="8" name="">
+          <p:cNvPr id="10" name="">
             <a:extLst xmlns:a="http://schemas.openxmlformats.org/drawingml/2006/main">
               <a:ext uri="{FF2B5EF4-FFF2-40B4-BE49-F238E27FC236}">
-                <a16:creationId xmlns:a16="http://schemas.microsoft.com/office/drawing/2014/main" id="{B1B492BC-72B7-42A3-8E30-88284DD5743A}"/>
+                <a16:creationId xmlns:a16="http://schemas.microsoft.com/office/drawing/2014/main" id="{BE758969-5053-4888-87CB-043B081FD1C0}"/>
               </a:ext>
             </a:extLst>
           </p:cNvPr>
@@ -8451,7 +8451,7 @@
                 <a:ea typeface="Times New Roman"/>
                 <a:cs typeface="Times New Roman"/>
               </a:rPr>
-              <a:t>9. Model2 remains experimental</a:t>
+              <a:t>9. Model2 data and editing limits</a:t>
             </a:r>
           </a:p>
         </p:txBody>
@@ -8461,7 +8461,7 @@
           <p:cNvPr id="2" name="">
             <a:extLst xmlns:a="http://schemas.openxmlformats.org/drawingml/2006/main">
               <a:ext uri="{FF2B5EF4-FFF2-40B4-BE49-F238E27FC236}">
-                <a16:creationId xmlns:a16="http://schemas.microsoft.com/office/drawing/2014/main" id="{4796830C-E25B-4B7D-BF67-8E7E8D28CFB5}"/>
+                <a16:creationId xmlns:a16="http://schemas.microsoft.com/office/drawing/2014/main" id="{F5D09830-0A57-4101-8197-112FC59B4B7C}"/>
               </a:ext>
             </a:extLst>
           </p:cNvPr>
@@ -8518,7 +8518,7 @@
           <p:cNvPr id="3" name="">
             <a:extLst xmlns:a="http://schemas.openxmlformats.org/drawingml/2006/main">
               <a:ext uri="{FF2B5EF4-FFF2-40B4-BE49-F238E27FC236}">
-                <a16:creationId xmlns:a16="http://schemas.microsoft.com/office/drawing/2014/main" id="{79272833-CA79-4025-9EF3-9887D0A70748}"/>
+                <a16:creationId xmlns:a16="http://schemas.microsoft.com/office/drawing/2014/main" id="{E7038EF0-F0D8-4EF5-9766-95F1C798F9CC}"/>
               </a:ext>
             </a:extLst>
           </p:cNvPr>
@@ -8575,7 +8575,7 @@
           <p:cNvPr id="4" name="">
             <a:extLst xmlns:a="http://schemas.openxmlformats.org/drawingml/2006/main">
               <a:ext uri="{FF2B5EF4-FFF2-40B4-BE49-F238E27FC236}">
-                <a16:creationId xmlns:a16="http://schemas.microsoft.com/office/drawing/2014/main" id="{BA99CC43-A28C-4584-9833-529105258821}"/>
+                <a16:creationId xmlns:a16="http://schemas.microsoft.com/office/drawing/2014/main" id="{82E7F64F-BDE9-484A-9F55-80550CC5EADF}"/>
               </a:ext>
             </a:extLst>
           </p:cNvPr>
@@ -8586,8 +8586,8 @@
         </p:nvSpPr>
         <p:spPr>
           <a:xfrm xmlns:a="http://schemas.openxmlformats.org/drawingml/2006/main">
-            <a:off x="685800" y="1647825"/>
-            <a:ext cx="10820400" cy="619125"/>
+            <a:off x="685800" y="1590675"/>
+            <a:ext cx="10820400" cy="523875"/>
           </a:xfrm>
           <a:prstGeom xmlns:a="http://schemas.openxmlformats.org/drawingml/2006/main" prst="rect">
             <a:avLst/>
@@ -8604,25 +8604,25 @@
           <a:lstStyle xmlns:a="http://schemas.openxmlformats.org/drawingml/2006/main"/>
           <a:p xmlns:a="http://schemas.openxmlformats.org/drawingml/2006/main">
             <a:pPr algn="l">
-              <a:defRPr sz="2700" b="1">
-                <a:solidFill>
-                  <a:srgbClr val="000000"/>
-                </a:solidFill>
-                <a:latin typeface="Times New Roman"/>
-                <a:ea typeface="Times New Roman"/>
-                <a:cs typeface="Times New Roman"/>
-              </a:defRPr>
-            </a:pPr>
-            <a:r>
-              <a:rPr sz="2700" b="1">
-                <a:solidFill>
-                  <a:srgbClr val="000000"/>
-                </a:solidFill>
-                <a:latin typeface="Times New Roman"/>
-                <a:ea typeface="Times New Roman"/>
-                <a:cs typeface="Times New Roman"/>
-              </a:rPr>
-              <a:t>Task: locate an AI-edited region</a:t>
+              <a:defRPr sz="2550" b="1">
+                <a:solidFill>
+                  <a:srgbClr val="000000"/>
+                </a:solidFill>
+                <a:latin typeface="Times New Roman"/>
+                <a:ea typeface="Times New Roman"/>
+                <a:cs typeface="Times New Roman"/>
+              </a:defRPr>
+            </a:pPr>
+            <a:r>
+              <a:rPr sz="2550" b="1">
+                <a:solidFill>
+                  <a:srgbClr val="000000"/>
+                </a:solidFill>
+                <a:latin typeface="Times New Roman"/>
+                <a:ea typeface="Times New Roman"/>
+                <a:cs typeface="Times New Roman"/>
+              </a:rPr>
+              <a:t>Local edits also affected the background</a:t>
             </a:r>
           </a:p>
         </p:txBody>
@@ -8632,7 +8632,7 @@
           <p:cNvPr id="5" name="">
             <a:extLst xmlns:a="http://schemas.openxmlformats.org/drawingml/2006/main">
               <a:ext uri="{FF2B5EF4-FFF2-40B4-BE49-F238E27FC236}">
-                <a16:creationId xmlns:a16="http://schemas.microsoft.com/office/drawing/2014/main" id="{C7D39C35-0944-4AA8-9F8A-207F3EB0D08D}"/>
+                <a16:creationId xmlns:a16="http://schemas.microsoft.com/office/drawing/2014/main" id="{FD720D7B-B747-4FF7-B422-9F71C82814DF}"/>
               </a:ext>
             </a:extLst>
           </p:cNvPr>
@@ -8643,8 +8643,8 @@
         </p:nvSpPr>
         <p:spPr>
           <a:xfrm xmlns:a="http://schemas.openxmlformats.org/drawingml/2006/main">
-            <a:off x="685800" y="2619375"/>
-            <a:ext cx="10820400" cy="619125"/>
+            <a:off x="685800" y="2190750"/>
+            <a:ext cx="10820400" cy="762000"/>
           </a:xfrm>
           <a:prstGeom xmlns:a="http://schemas.openxmlformats.org/drawingml/2006/main" prst="rect">
             <a:avLst/>
@@ -8661,25 +8661,25 @@
           <a:lstStyle xmlns:a="http://schemas.openxmlformats.org/drawingml/2006/main"/>
           <a:p xmlns:a="http://schemas.openxmlformats.org/drawingml/2006/main">
             <a:pPr algn="l">
-              <a:defRPr sz="2400" b="0">
-                <a:solidFill>
-                  <a:srgbClr val="000000"/>
-                </a:solidFill>
-                <a:latin typeface="Times New Roman"/>
-                <a:ea typeface="Times New Roman"/>
-                <a:cs typeface="Times New Roman"/>
-              </a:defRPr>
-            </a:pPr>
-            <a:r>
-              <a:rPr sz="2400" b="0">
-                <a:solidFill>
-                  <a:srgbClr val="000000"/>
-                </a:solidFill>
-                <a:latin typeface="Times New Roman"/>
-                <a:ea typeface="Times New Roman"/>
-                <a:cs typeface="Times New Roman"/>
-              </a:rPr>
-              <a:t>Data: source overlap and unclear edit masks</a:t>
+              <a:defRPr sz="2250" b="0">
+                <a:solidFill>
+                  <a:srgbClr val="000000"/>
+                </a:solidFill>
+                <a:latin typeface="Times New Roman"/>
+                <a:ea typeface="Times New Roman"/>
+                <a:cs typeface="Times New Roman"/>
+              </a:defRPr>
+            </a:pPr>
+            <a:r>
+              <a:rPr sz="2250" b="0">
+                <a:solidFill>
+                  <a:srgbClr val="000000"/>
+                </a:solidFill>
+                <a:latin typeface="Times New Roman"/>
+                <a:ea typeface="Times New Roman"/>
+                <a:cs typeface="Times New Roman"/>
+              </a:rPr>
+              <a:t>Our Stable Diffusion pilot changed pixels outside the selected region.</a:t>
             </a:r>
           </a:p>
         </p:txBody>
@@ -8689,7 +8689,7 @@
           <p:cNvPr id="6" name="">
             <a:extLst xmlns:a="http://schemas.openxmlformats.org/drawingml/2006/main">
               <a:ext uri="{FF2B5EF4-FFF2-40B4-BE49-F238E27FC236}">
-                <a16:creationId xmlns:a16="http://schemas.microsoft.com/office/drawing/2014/main" id="{C3458452-C469-4624-BE7E-44ECD86A98B0}"/>
+                <a16:creationId xmlns:a16="http://schemas.microsoft.com/office/drawing/2014/main" id="{5E1D3B49-E603-4738-8E23-3BCCF950A4BD}"/>
               </a:ext>
             </a:extLst>
           </p:cNvPr>
@@ -8700,8 +8700,8 @@
         </p:nvSpPr>
         <p:spPr>
           <a:xfrm xmlns:a="http://schemas.openxmlformats.org/drawingml/2006/main">
-            <a:off x="685800" y="3676650"/>
-            <a:ext cx="10820400" cy="1095375"/>
+            <a:off x="685800" y="3190875"/>
+            <a:ext cx="10820400" cy="523875"/>
           </a:xfrm>
           <a:prstGeom xmlns:a="http://schemas.openxmlformats.org/drawingml/2006/main" prst="rect">
             <a:avLst/>
@@ -8718,48 +8718,25 @@
           <a:lstStyle xmlns:a="http://schemas.openxmlformats.org/drawingml/2006/main"/>
           <a:p xmlns:a="http://schemas.openxmlformats.org/drawingml/2006/main">
             <a:pPr algn="l">
-              <a:defRPr sz="2400" b="0">
-                <a:solidFill>
-                  <a:srgbClr val="000000"/>
-                </a:solidFill>
-                <a:latin typeface="Times New Roman"/>
-                <a:ea typeface="Times New Roman"/>
-                <a:cs typeface="Times New Roman"/>
-              </a:defRPr>
-            </a:pPr>
-            <a:r>
-              <a:rPr sz="2400" b="0">
-                <a:solidFill>
-                  <a:srgbClr val="000000"/>
-                </a:solidFill>
-                <a:latin typeface="Times New Roman"/>
-                <a:ea typeface="Times New Roman"/>
-                <a:cs typeface="Times New Roman"/>
-              </a:rPr>
-              <a:t>Local generation also changed background pixels.</a:t>
-            </a:r>
-          </a:p>
-          <a:p xmlns:a="http://schemas.openxmlformats.org/drawingml/2006/main">
-            <a:pPr algn="l">
-              <a:defRPr sz="2400" b="0">
-                <a:solidFill>
-                  <a:srgbClr val="000000"/>
-                </a:solidFill>
-                <a:latin typeface="Times New Roman"/>
-                <a:ea typeface="Times New Roman"/>
-                <a:cs typeface="Times New Roman"/>
-              </a:defRPr>
-            </a:pPr>
-            <a:r>
-              <a:rPr sz="2400" b="0">
-                <a:solidFill>
-                  <a:srgbClr val="000000"/>
-                </a:solidFill>
-                <a:latin typeface="Times New Roman"/>
-                <a:ea typeface="Times New Roman"/>
-                <a:cs typeface="Times New Roman"/>
-              </a:rPr>
-              <a:t>Controlled pilot: 16 reused images, one editor.</a:t>
+              <a:defRPr sz="2550" b="1">
+                <a:solidFill>
+                  <a:srgbClr val="000000"/>
+                </a:solidFill>
+                <a:latin typeface="Times New Roman"/>
+                <a:ea typeface="Times New Roman"/>
+                <a:cs typeface="Times New Roman"/>
+              </a:defRPr>
+            </a:pPr>
+            <a:r>
+              <a:rPr sz="2550" b="1">
+                <a:solidFill>
+                  <a:srgbClr val="000000"/>
+                </a:solidFill>
+                <a:latin typeface="Times New Roman"/>
+                <a:ea typeface="Times New Roman"/>
+                <a:cs typeface="Times New Roman"/>
+              </a:rPr>
+              <a:t>Available data were difficult to use for training</a:t>
             </a:r>
           </a:p>
         </p:txBody>
@@ -8769,7 +8746,7 @@
           <p:cNvPr id="7" name="">
             <a:extLst xmlns:a="http://schemas.openxmlformats.org/drawingml/2006/main">
               <a:ext uri="{FF2B5EF4-FFF2-40B4-BE49-F238E27FC236}">
-                <a16:creationId xmlns:a16="http://schemas.microsoft.com/office/drawing/2014/main" id="{B5381D4A-7408-4038-AF6C-C1CA09F56735}"/>
+                <a16:creationId xmlns:a16="http://schemas.microsoft.com/office/drawing/2014/main" id="{D78D948A-8950-40EE-AF01-7F1D313DBEEC}"/>
               </a:ext>
             </a:extLst>
           </p:cNvPr>
@@ -8780,8 +8757,8 @@
         </p:nvSpPr>
         <p:spPr>
           <a:xfrm xmlns:a="http://schemas.openxmlformats.org/drawingml/2006/main">
-            <a:off x="685800" y="5314950"/>
-            <a:ext cx="10820400" cy="619125"/>
+            <a:off x="685800" y="3790950"/>
+            <a:ext cx="10820400" cy="762000"/>
           </a:xfrm>
           <a:prstGeom xmlns:a="http://schemas.openxmlformats.org/drawingml/2006/main" prst="rect">
             <a:avLst/>
@@ -8798,6 +8775,63 @@
           <a:lstStyle xmlns:a="http://schemas.openxmlformats.org/drawingml/2006/main"/>
           <a:p xmlns:a="http://schemas.openxmlformats.org/drawingml/2006/main">
             <a:pPr algn="l">
+              <a:defRPr sz="2250" b="0">
+                <a:solidFill>
+                  <a:srgbClr val="000000"/>
+                </a:solidFill>
+                <a:latin typeface="Times New Roman"/>
+                <a:ea typeface="Times New Roman"/>
+                <a:cs typeface="Times New Roman"/>
+              </a:defRPr>
+            </a:pPr>
+            <a:r>
+              <a:rPr sz="2250" b="0">
+                <a:solidFill>
+                  <a:srgbClr val="000000"/>
+                </a:solidFill>
+                <a:latin typeface="Times New Roman"/>
+                <a:ea typeface="Times New Roman"/>
+                <a:cs typeface="Times New Roman"/>
+              </a:rPr>
+              <a:t>Shared source images and unclear edit masks limited usable data.</a:t>
+            </a:r>
+          </a:p>
+        </p:txBody>
+      </p:sp>
+      <p:sp>
+        <p:nvSpPr>
+          <p:cNvPr id="8" name="">
+            <a:extLst xmlns:a="http://schemas.openxmlformats.org/drawingml/2006/main">
+              <a:ext uri="{FF2B5EF4-FFF2-40B4-BE49-F238E27FC236}">
+                <a16:creationId xmlns:a16="http://schemas.microsoft.com/office/drawing/2014/main" id="{5152D2F8-05DD-49C1-B58C-6E3B1D5640FB}"/>
+              </a:ext>
+            </a:extLst>
+          </p:cNvPr>
+          <p:cNvSpPr>
+            <a:spLocks xmlns:a="http://schemas.openxmlformats.org/drawingml/2006/main" noGrp="1"/>
+          </p:cNvSpPr>
+          <p:nvPr/>
+        </p:nvSpPr>
+        <p:spPr>
+          <a:xfrm xmlns:a="http://schemas.openxmlformats.org/drawingml/2006/main">
+            <a:off x="685800" y="4791075"/>
+            <a:ext cx="10820400" cy="523875"/>
+          </a:xfrm>
+          <a:prstGeom xmlns:a="http://schemas.openxmlformats.org/drawingml/2006/main" prst="rect">
+            <a:avLst/>
+          </a:prstGeom>
+          <a:noFill xmlns:a="http://schemas.openxmlformats.org/drawingml/2006/main"/>
+          <a:ln xmlns:a="http://schemas.openxmlformats.org/drawingml/2006/main" w="0">
+            <a:noFill/>
+          </a:ln>
+        </p:spPr>
+        <p:txBody>
+          <a:bodyPr xmlns:a="http://schemas.openxmlformats.org/drawingml/2006/main">
+            <a:noAutofit/>
+          </a:bodyPr>
+          <a:lstStyle xmlns:a="http://schemas.openxmlformats.org/drawingml/2006/main"/>
+          <a:p xmlns:a="http://schemas.openxmlformats.org/drawingml/2006/main">
+            <a:pPr algn="l">
               <a:defRPr sz="2550" b="1">
                 <a:solidFill>
                   <a:srgbClr val="000000"/>
@@ -8816,7 +8850,64 @@
                 <a:ea typeface="Times New Roman"/>
                 <a:cs typeface="Times New Roman"/>
               </a:rPr>
-              <a:t>The candidate was rejected.</a:t>
+              <a:t>Pilot: 16 reused images, one editor</a:t>
+            </a:r>
+          </a:p>
+        </p:txBody>
+      </p:sp>
+      <p:sp>
+        <p:nvSpPr>
+          <p:cNvPr id="9" name="">
+            <a:extLst xmlns:a="http://schemas.openxmlformats.org/drawingml/2006/main">
+              <a:ext uri="{FF2B5EF4-FFF2-40B4-BE49-F238E27FC236}">
+                <a16:creationId xmlns:a16="http://schemas.microsoft.com/office/drawing/2014/main" id="{EE534577-3E31-4BD7-AA18-764EBCF98B9B}"/>
+              </a:ext>
+            </a:extLst>
+          </p:cNvPr>
+          <p:cNvSpPr>
+            <a:spLocks xmlns:a="http://schemas.openxmlformats.org/drawingml/2006/main" noGrp="1"/>
+          </p:cNvSpPr>
+          <p:nvPr/>
+        </p:nvSpPr>
+        <p:spPr>
+          <a:xfrm xmlns:a="http://schemas.openxmlformats.org/drawingml/2006/main">
+            <a:off x="685800" y="5391150"/>
+            <a:ext cx="10820400" cy="666750"/>
+          </a:xfrm>
+          <a:prstGeom xmlns:a="http://schemas.openxmlformats.org/drawingml/2006/main" prst="rect">
+            <a:avLst/>
+          </a:prstGeom>
+          <a:noFill xmlns:a="http://schemas.openxmlformats.org/drawingml/2006/main"/>
+          <a:ln xmlns:a="http://schemas.openxmlformats.org/drawingml/2006/main" w="0">
+            <a:noFill/>
+          </a:ln>
+        </p:spPr>
+        <p:txBody>
+          <a:bodyPr xmlns:a="http://schemas.openxmlformats.org/drawingml/2006/main">
+            <a:noAutofit/>
+          </a:bodyPr>
+          <a:lstStyle xmlns:a="http://schemas.openxmlformats.org/drawingml/2006/main"/>
+          <a:p xmlns:a="http://schemas.openxmlformats.org/drawingml/2006/main">
+            <a:pPr algn="l">
+              <a:defRPr sz="2250" b="0">
+                <a:solidFill>
+                  <a:srgbClr val="000000"/>
+                </a:solidFill>
+                <a:latin typeface="Times New Roman"/>
+                <a:ea typeface="Times New Roman"/>
+                <a:cs typeface="Times New Roman"/>
+              </a:defRPr>
+            </a:pPr>
+            <a:r>
+              <a:rPr sz="2250" b="0">
+                <a:solidFill>
+                  <a:srgbClr val="000000"/>
+                </a:solidFill>
+                <a:latin typeface="Times New Roman"/>
+                <a:ea typeface="Times New Roman"/>
+                <a:cs typeface="Times New Roman"/>
+              </a:rPr>
+              <a:t>Later training increased false markings on real images.</a:t>
             </a:r>
           </a:p>
         </p:txBody>
@@ -8824,7 +8915,7 @@
     </p:spTree>
     <p:extLst>
       <p:ext uri="{BB962C8B-B14F-4D97-AF65-F5344CB8AC3E}">
-        <p14:creationId xmlns:p14="http://schemas.microsoft.com/office/powerpoint/2010/main" val="1177094754"/>
+        <p14:creationId xmlns:p14="http://schemas.microsoft.com/office/powerpoint/2010/main" val="1196708667"/>
       </p:ext>
     </p:extLst>
   </p:cSld>

</xml_diff>

<commit_message>
docs: resolve submission fields with mentor role and sourced supplier
</commit_message>
<xml_diff>
--- a/rapor/final_2026/deliverables/CS395_Presentation_EfeHan_Keles_29September2026.pptx
+++ b/rapor/final_2026/deliverables/CS395_Presentation_EfeHan_Keles_29September2026.pptx
@@ -2,24 +2,24 @@
 <file path=ppt/presentation.xml><?xml version="1.0" encoding="utf-8"?>
 <p:presentation xmlns:p="http://schemas.openxmlformats.org/presentationml/2006/main">
   <p:sldMasterIdLst>
-    <p:sldMasterId xmlns:r="http://schemas.openxmlformats.org/officeDocument/2006/relationships" id="2147483648" r:id="R13b9405a838b4dfd"/>
+    <p:sldMasterId xmlns:r="http://schemas.openxmlformats.org/officeDocument/2006/relationships" id="2147483648" r:id="R24d6986769d345dd"/>
   </p:sldMasterIdLst>
   <p:notesMasterIdLst>
-    <p:notesMasterId xmlns:r="http://schemas.openxmlformats.org/officeDocument/2006/relationships" r:id="R9c342c8a258a46da"/>
+    <p:notesMasterId xmlns:r="http://schemas.openxmlformats.org/officeDocument/2006/relationships" r:id="Rf4c154f154d146f2"/>
   </p:notesMasterIdLst>
   <p:sldIdLst>
-    <p:sldId xmlns:r="http://schemas.openxmlformats.org/officeDocument/2006/relationships" id="256" r:id="R202c9283cff9488b"/>
-    <p:sldId xmlns:r="http://schemas.openxmlformats.org/officeDocument/2006/relationships" id="257" r:id="R7fddeea60f1a4827"/>
-    <p:sldId xmlns:r="http://schemas.openxmlformats.org/officeDocument/2006/relationships" id="258" r:id="R36575ff8987948fc"/>
-    <p:sldId xmlns:r="http://schemas.openxmlformats.org/officeDocument/2006/relationships" id="259" r:id="R4b47876965dd4194"/>
-    <p:sldId xmlns:r="http://schemas.openxmlformats.org/officeDocument/2006/relationships" id="260" r:id="R0d4be53dc3e04c46"/>
-    <p:sldId xmlns:r="http://schemas.openxmlformats.org/officeDocument/2006/relationships" id="261" r:id="Rdf4dafc1c6fa40ef"/>
-    <p:sldId xmlns:r="http://schemas.openxmlformats.org/officeDocument/2006/relationships" id="262" r:id="Re813d923ef4b4126"/>
-    <p:sldId xmlns:r="http://schemas.openxmlformats.org/officeDocument/2006/relationships" id="263" r:id="R3346a61718e3426c"/>
-    <p:sldId xmlns:r="http://schemas.openxmlformats.org/officeDocument/2006/relationships" id="264" r:id="R2a22c134beea415e"/>
-    <p:sldId xmlns:r="http://schemas.openxmlformats.org/officeDocument/2006/relationships" id="265" r:id="Rec2d94ebfa4749ba"/>
-    <p:sldId xmlns:r="http://schemas.openxmlformats.org/officeDocument/2006/relationships" id="266" r:id="R222dae9074a9490d"/>
-    <p:sldId xmlns:r="http://schemas.openxmlformats.org/officeDocument/2006/relationships" id="267" r:id="R3663e94c5f2a4148"/>
+    <p:sldId xmlns:r="http://schemas.openxmlformats.org/officeDocument/2006/relationships" id="256" r:id="R6f15ce6583ad4eeb"/>
+    <p:sldId xmlns:r="http://schemas.openxmlformats.org/officeDocument/2006/relationships" id="257" r:id="Rfdb39567664b4deb"/>
+    <p:sldId xmlns:r="http://schemas.openxmlformats.org/officeDocument/2006/relationships" id="258" r:id="Reddd755d6fbe4aba"/>
+    <p:sldId xmlns:r="http://schemas.openxmlformats.org/officeDocument/2006/relationships" id="259" r:id="R9e18c8911c054d07"/>
+    <p:sldId xmlns:r="http://schemas.openxmlformats.org/officeDocument/2006/relationships" id="260" r:id="Rd11a72075c224ee6"/>
+    <p:sldId xmlns:r="http://schemas.openxmlformats.org/officeDocument/2006/relationships" id="261" r:id="R7f7d802a764544fd"/>
+    <p:sldId xmlns:r="http://schemas.openxmlformats.org/officeDocument/2006/relationships" id="262" r:id="R1dd6486e117e42e8"/>
+    <p:sldId xmlns:r="http://schemas.openxmlformats.org/officeDocument/2006/relationships" id="263" r:id="R9c45393602014d55"/>
+    <p:sldId xmlns:r="http://schemas.openxmlformats.org/officeDocument/2006/relationships" id="264" r:id="R4be75494829c4253"/>
+    <p:sldId xmlns:r="http://schemas.openxmlformats.org/officeDocument/2006/relationships" id="265" r:id="R83d30aba50fc478b"/>
+    <p:sldId xmlns:r="http://schemas.openxmlformats.org/officeDocument/2006/relationships" id="266" r:id="R87521cfa24574f9e"/>
+    <p:sldId xmlns:r="http://schemas.openxmlformats.org/officeDocument/2006/relationships" id="267" r:id="R06ce25a43b604fc6"/>
   </p:sldIdLst>
   <p:sldSz cx="12192000" cy="6858000"/>
   <p:notesSz cx="6858000" cy="9144000"/>
@@ -748,7 +748,7 @@
           </a:p>
           <a:p xmlns:a="http://schemas.openxmlformats.org/drawingml/2006/main">
             <a:r>
-              <a:t>Reference appendix. The report gives fourteen full entries. These slides list the sources most relevant to the short talk.</a:t>
+              <a:t>Reference appendix. The report provides the full bibliography. These slides list the sources most relevant to the short talk.</a:t>
             </a:r>
           </a:p>
           <a:p xmlns:a="http://schemas.openxmlformats.org/drawingml/2006/main">
@@ -1561,7 +1561,7 @@
   </p:cSld>
   <p:clrMap bg1="lt1" tx1="dk1" bg2="lt2" tx2="dk2" accent1="accent1" accent2="accent2" accent3="accent3" accent4="accent4" accent5="accent5" accent6="accent6" hlink="hlink" folHlink="folHlink"/>
   <p:sldLayoutIdLst>
-    <p:sldLayoutId xmlns:r="http://schemas.openxmlformats.org/officeDocument/2006/relationships" id="2147483649" r:id="Ra02a671b09914f4b"/>
+    <p:sldLayoutId xmlns:r="http://schemas.openxmlformats.org/officeDocument/2006/relationships" id="2147483649" r:id="R4c315fefeeeb4506"/>
   </p:sldLayoutIdLst>
   <p:txStyles>
     <p:titleStyle>
@@ -2337,7 +2337,7 @@
           <p:cNvPr id="9" name="">
             <a:extLst xmlns:a="http://schemas.openxmlformats.org/drawingml/2006/main">
               <a:ext uri="{FF2B5EF4-FFF2-40B4-BE49-F238E27FC236}">
-                <a16:creationId xmlns:a16="http://schemas.microsoft.com/office/drawing/2014/main" id="{BB54A679-4E94-4CC4-9466-178758E76673}"/>
+                <a16:creationId xmlns:a16="http://schemas.microsoft.com/office/drawing/2014/main" id="{55E4A0A7-30FA-4961-9E92-CC880516DA15}"/>
               </a:ext>
             </a:extLst>
           </p:cNvPr>
@@ -2394,7 +2394,7 @@
           <p:cNvPr id="2" name="">
             <a:extLst xmlns:a="http://schemas.openxmlformats.org/drawingml/2006/main">
               <a:ext uri="{FF2B5EF4-FFF2-40B4-BE49-F238E27FC236}">
-                <a16:creationId xmlns:a16="http://schemas.microsoft.com/office/drawing/2014/main" id="{EB4D8DFD-5740-4719-A451-33D7C115F541}"/>
+                <a16:creationId xmlns:a16="http://schemas.microsoft.com/office/drawing/2014/main" id="{4B1DFE13-D573-4E6B-A70C-F4971F3A3B1A}"/>
               </a:ext>
             </a:extLst>
           </p:cNvPr>
@@ -2451,7 +2451,7 @@
           <p:cNvPr id="3" name="">
             <a:extLst xmlns:a="http://schemas.openxmlformats.org/drawingml/2006/main">
               <a:ext uri="{FF2B5EF4-FFF2-40B4-BE49-F238E27FC236}">
-                <a16:creationId xmlns:a16="http://schemas.microsoft.com/office/drawing/2014/main" id="{4D0E7338-85B4-4017-97B8-B337A41DB465}"/>
+                <a16:creationId xmlns:a16="http://schemas.microsoft.com/office/drawing/2014/main" id="{B0854C55-991F-418F-8325-3D6E60BE6CFA}"/>
               </a:ext>
             </a:extLst>
           </p:cNvPr>
@@ -2508,7 +2508,7 @@
           <p:cNvPr id="4" name="">
             <a:extLst xmlns:a="http://schemas.openxmlformats.org/drawingml/2006/main">
               <a:ext uri="{FF2B5EF4-FFF2-40B4-BE49-F238E27FC236}">
-                <a16:creationId xmlns:a16="http://schemas.microsoft.com/office/drawing/2014/main" id="{B2E16D4D-B270-4728-A95C-82879441BE8B}"/>
+                <a16:creationId xmlns:a16="http://schemas.microsoft.com/office/drawing/2014/main" id="{6A608177-6280-499E-A94B-0EE785A1CF59}"/>
               </a:ext>
             </a:extLst>
           </p:cNvPr>
@@ -2565,7 +2565,7 @@
           <p:cNvPr id="5" name="">
             <a:extLst xmlns:a="http://schemas.openxmlformats.org/drawingml/2006/main">
               <a:ext uri="{FF2B5EF4-FFF2-40B4-BE49-F238E27FC236}">
-                <a16:creationId xmlns:a16="http://schemas.microsoft.com/office/drawing/2014/main" id="{A57019B8-1CB6-4B31-93B6-4AD9460E0A60}"/>
+                <a16:creationId xmlns:a16="http://schemas.microsoft.com/office/drawing/2014/main" id="{E7DFC0E4-026B-4C9A-91AC-138C17E3B816}"/>
               </a:ext>
             </a:extLst>
           </p:cNvPr>
@@ -2645,7 +2645,7 @@
           <p:cNvPr id="6" name="">
             <a:extLst xmlns:a="http://schemas.openxmlformats.org/drawingml/2006/main">
               <a:ext uri="{FF2B5EF4-FFF2-40B4-BE49-F238E27FC236}">
-                <a16:creationId xmlns:a16="http://schemas.microsoft.com/office/drawing/2014/main" id="{09480DA8-06A1-42A4-BEB7-42E83165BFE9}"/>
+                <a16:creationId xmlns:a16="http://schemas.microsoft.com/office/drawing/2014/main" id="{191FA4EE-BE05-45C3-9B8E-1E5B112F9308}"/>
               </a:ext>
             </a:extLst>
           </p:cNvPr>
@@ -2725,7 +2725,7 @@
           <p:cNvPr id="7" name="">
             <a:extLst xmlns:a="http://schemas.openxmlformats.org/drawingml/2006/main">
               <a:ext uri="{FF2B5EF4-FFF2-40B4-BE49-F238E27FC236}">
-                <a16:creationId xmlns:a16="http://schemas.microsoft.com/office/drawing/2014/main" id="{BB86DE99-CCEC-41C6-A75D-C5329F632E37}"/>
+                <a16:creationId xmlns:a16="http://schemas.microsoft.com/office/drawing/2014/main" id="{BC9CA118-0129-43DE-A6D1-A9591D03233B}"/>
               </a:ext>
             </a:extLst>
           </p:cNvPr>
@@ -2805,7 +2805,7 @@
           <p:cNvPr id="8" name="">
             <a:extLst xmlns:a="http://schemas.openxmlformats.org/drawingml/2006/main">
               <a:ext uri="{FF2B5EF4-FFF2-40B4-BE49-F238E27FC236}">
-                <a16:creationId xmlns:a16="http://schemas.microsoft.com/office/drawing/2014/main" id="{F88DC6BA-5BD4-4489-B74E-2732AD6CDDEC}"/>
+                <a16:creationId xmlns:a16="http://schemas.microsoft.com/office/drawing/2014/main" id="{CA6F5A97-E8C2-4A91-B255-FE0C30A21D1E}"/>
               </a:ext>
             </a:extLst>
           </p:cNvPr>
@@ -2860,7 +2860,7 @@
     </p:spTree>
     <p:extLst>
       <p:ext uri="{BB962C8B-B14F-4D97-AF65-F5344CB8AC3E}">
-        <p14:creationId xmlns:p14="http://schemas.microsoft.com/office/powerpoint/2010/main" val="770658924"/>
+        <p14:creationId xmlns:p14="http://schemas.microsoft.com/office/powerpoint/2010/main" val="138415384"/>
       </p:ext>
     </p:extLst>
   </p:cSld>
@@ -2891,7 +2891,7 @@
           <p:cNvPr id="8" name="">
             <a:extLst xmlns:a="http://schemas.openxmlformats.org/drawingml/2006/main">
               <a:ext uri="{FF2B5EF4-FFF2-40B4-BE49-F238E27FC236}">
-                <a16:creationId xmlns:a16="http://schemas.microsoft.com/office/drawing/2014/main" id="{93FEBFD9-6C68-411A-B48E-3B20E129A832}"/>
+                <a16:creationId xmlns:a16="http://schemas.microsoft.com/office/drawing/2014/main" id="{DC6AD894-8A8E-47AC-BFFB-D0C3B05B1052}"/>
               </a:ext>
             </a:extLst>
           </p:cNvPr>
@@ -2948,7 +2948,7 @@
           <p:cNvPr id="2" name="">
             <a:extLst xmlns:a="http://schemas.openxmlformats.org/drawingml/2006/main">
               <a:ext uri="{FF2B5EF4-FFF2-40B4-BE49-F238E27FC236}">
-                <a16:creationId xmlns:a16="http://schemas.microsoft.com/office/drawing/2014/main" id="{98A6E1C6-0534-4B2F-AA2C-03537FA4CF88}"/>
+                <a16:creationId xmlns:a16="http://schemas.microsoft.com/office/drawing/2014/main" id="{C4D19076-4BEF-429A-8589-7D6743860BD6}"/>
               </a:ext>
             </a:extLst>
           </p:cNvPr>
@@ -3005,7 +3005,7 @@
           <p:cNvPr id="3" name="">
             <a:extLst xmlns:a="http://schemas.openxmlformats.org/drawingml/2006/main">
               <a:ext uri="{FF2B5EF4-FFF2-40B4-BE49-F238E27FC236}">
-                <a16:creationId xmlns:a16="http://schemas.microsoft.com/office/drawing/2014/main" id="{0CFEF41B-2460-49DD-84CE-F775091DB08F}"/>
+                <a16:creationId xmlns:a16="http://schemas.microsoft.com/office/drawing/2014/main" id="{D9039DD4-12CE-4A9C-AEEA-CF6B99DA1A58}"/>
               </a:ext>
             </a:extLst>
           </p:cNvPr>
@@ -3062,7 +3062,7 @@
           <p:cNvPr id="4" name="">
             <a:extLst xmlns:a="http://schemas.openxmlformats.org/drawingml/2006/main">
               <a:ext uri="{FF2B5EF4-FFF2-40B4-BE49-F238E27FC236}">
-                <a16:creationId xmlns:a16="http://schemas.microsoft.com/office/drawing/2014/main" id="{2BB4D44B-32B4-41BA-BADD-DB1D1917FF96}"/>
+                <a16:creationId xmlns:a16="http://schemas.microsoft.com/office/drawing/2014/main" id="{F6AEC8C7-A9A1-4116-869B-1BC7A4DF4701}"/>
               </a:ext>
             </a:extLst>
           </p:cNvPr>
@@ -3119,7 +3119,7 @@
           <p:cNvPr id="5" name="">
             <a:extLst xmlns:a="http://schemas.openxmlformats.org/drawingml/2006/main">
               <a:ext uri="{FF2B5EF4-FFF2-40B4-BE49-F238E27FC236}">
-                <a16:creationId xmlns:a16="http://schemas.microsoft.com/office/drawing/2014/main" id="{3A76B7FA-B3A4-49C2-9FB5-E111A3D8F7E8}"/>
+                <a16:creationId xmlns:a16="http://schemas.microsoft.com/office/drawing/2014/main" id="{48D0C6DB-91B8-4805-91F7-8DEDE3E7348F}"/>
               </a:ext>
             </a:extLst>
           </p:cNvPr>
@@ -3422,7 +3422,7 @@
           <p:cNvPr id="7" name="">
             <a:extLst xmlns:a="http://schemas.openxmlformats.org/drawingml/2006/main">
               <a:ext uri="{FF2B5EF4-FFF2-40B4-BE49-F238E27FC236}">
-                <a16:creationId xmlns:a16="http://schemas.microsoft.com/office/drawing/2014/main" id="{0B3C4AD8-1E9D-4C4A-9FA5-0E96D73B69BD}"/>
+                <a16:creationId xmlns:a16="http://schemas.microsoft.com/office/drawing/2014/main" id="{0C913E16-FD0F-43EE-87D2-8D12922E14E1}"/>
               </a:ext>
             </a:extLst>
           </p:cNvPr>
@@ -3477,7 +3477,7 @@
     </p:spTree>
     <p:extLst>
       <p:ext uri="{BB962C8B-B14F-4D97-AF65-F5344CB8AC3E}">
-        <p14:creationId xmlns:p14="http://schemas.microsoft.com/office/powerpoint/2010/main" val="386778533"/>
+        <p14:creationId xmlns:p14="http://schemas.microsoft.com/office/powerpoint/2010/main" val="520763140"/>
       </p:ext>
     </p:extLst>
   </p:cSld>
@@ -3508,7 +3508,7 @@
           <p:cNvPr id="12" name="">
             <a:extLst xmlns:a="http://schemas.openxmlformats.org/drawingml/2006/main">
               <a:ext uri="{FF2B5EF4-FFF2-40B4-BE49-F238E27FC236}">
-                <a16:creationId xmlns:a16="http://schemas.microsoft.com/office/drawing/2014/main" id="{2A686336-CF75-4517-8D6D-020FE9DAD112}"/>
+                <a16:creationId xmlns:a16="http://schemas.microsoft.com/office/drawing/2014/main" id="{BACB7DBE-1608-45B8-83B3-AE54C750D539}"/>
               </a:ext>
             </a:extLst>
           </p:cNvPr>
@@ -3565,7 +3565,7 @@
           <p:cNvPr id="2" name="">
             <a:extLst xmlns:a="http://schemas.openxmlformats.org/drawingml/2006/main">
               <a:ext uri="{FF2B5EF4-FFF2-40B4-BE49-F238E27FC236}">
-                <a16:creationId xmlns:a16="http://schemas.microsoft.com/office/drawing/2014/main" id="{473F3B77-4ED6-4E53-B79D-31EA528B1855}"/>
+                <a16:creationId xmlns:a16="http://schemas.microsoft.com/office/drawing/2014/main" id="{69765FC6-0FCE-407E-A1C1-6A4FC7AAD881}"/>
               </a:ext>
             </a:extLst>
           </p:cNvPr>
@@ -3622,7 +3622,7 @@
           <p:cNvPr id="3" name="">
             <a:extLst xmlns:a="http://schemas.openxmlformats.org/drawingml/2006/main">
               <a:ext uri="{FF2B5EF4-FFF2-40B4-BE49-F238E27FC236}">
-                <a16:creationId xmlns:a16="http://schemas.microsoft.com/office/drawing/2014/main" id="{8795D55E-ED93-4504-B2D3-DE45B09A197B}"/>
+                <a16:creationId xmlns:a16="http://schemas.microsoft.com/office/drawing/2014/main" id="{0C25ADB1-D649-46C3-82CE-832EF814F0E6}"/>
               </a:ext>
             </a:extLst>
           </p:cNvPr>
@@ -3679,7 +3679,7 @@
           <p:cNvPr id="4" name="">
             <a:extLst xmlns:a="http://schemas.openxmlformats.org/drawingml/2006/main">
               <a:ext uri="{FF2B5EF4-FFF2-40B4-BE49-F238E27FC236}">
-                <a16:creationId xmlns:a16="http://schemas.microsoft.com/office/drawing/2014/main" id="{A03F2CD0-2031-43F6-A56C-9D1CF55F29FC}"/>
+                <a16:creationId xmlns:a16="http://schemas.microsoft.com/office/drawing/2014/main" id="{6EBCAE3D-5183-4A6B-A964-32FDEF671AF0}"/>
               </a:ext>
             </a:extLst>
           </p:cNvPr>
@@ -3736,7 +3736,7 @@
           <p:cNvPr id="5" name="">
             <a:extLst xmlns:a="http://schemas.openxmlformats.org/drawingml/2006/main">
               <a:ext uri="{FF2B5EF4-FFF2-40B4-BE49-F238E27FC236}">
-                <a16:creationId xmlns:a16="http://schemas.microsoft.com/office/drawing/2014/main" id="{0D69F571-F3BB-4448-8E03-99BC1B99B40D}"/>
+                <a16:creationId xmlns:a16="http://schemas.microsoft.com/office/drawing/2014/main" id="{522A892F-BBA9-4E06-A6A2-1F8837F881BB}"/>
               </a:ext>
             </a:extLst>
           </p:cNvPr>
@@ -3793,7 +3793,7 @@
           <p:cNvPr id="6" name="">
             <a:extLst xmlns:a="http://schemas.openxmlformats.org/drawingml/2006/main">
               <a:ext uri="{FF2B5EF4-FFF2-40B4-BE49-F238E27FC236}">
-                <a16:creationId xmlns:a16="http://schemas.microsoft.com/office/drawing/2014/main" id="{051AC4B1-0957-429A-A6F0-1D3610C819EC}"/>
+                <a16:creationId xmlns:a16="http://schemas.microsoft.com/office/drawing/2014/main" id="{1F3AE0B8-B8B3-4AA0-BA7C-EEACEDE45185}"/>
               </a:ext>
             </a:extLst>
           </p:cNvPr>
@@ -3850,7 +3850,7 @@
           <p:cNvPr id="7" name="">
             <a:extLst xmlns:a="http://schemas.openxmlformats.org/drawingml/2006/main">
               <a:ext uri="{FF2B5EF4-FFF2-40B4-BE49-F238E27FC236}">
-                <a16:creationId xmlns:a16="http://schemas.microsoft.com/office/drawing/2014/main" id="{17EE9159-72C7-45D8-925D-F4B24DCB8EAD}"/>
+                <a16:creationId xmlns:a16="http://schemas.microsoft.com/office/drawing/2014/main" id="{FD302E16-AC36-4957-8B94-EA15EFC7DC18}"/>
               </a:ext>
             </a:extLst>
           </p:cNvPr>
@@ -3907,7 +3907,7 @@
           <p:cNvPr id="8" name="">
             <a:extLst xmlns:a="http://schemas.openxmlformats.org/drawingml/2006/main">
               <a:ext uri="{FF2B5EF4-FFF2-40B4-BE49-F238E27FC236}">
-                <a16:creationId xmlns:a16="http://schemas.microsoft.com/office/drawing/2014/main" id="{DC920208-D1A0-4908-A3A0-41F566D5B89A}"/>
+                <a16:creationId xmlns:a16="http://schemas.microsoft.com/office/drawing/2014/main" id="{FA3A397D-84B3-4416-B361-B55F021E414E}"/>
               </a:ext>
             </a:extLst>
           </p:cNvPr>
@@ -3964,7 +3964,7 @@
           <p:cNvPr id="9" name="">
             <a:extLst xmlns:a="http://schemas.openxmlformats.org/drawingml/2006/main">
               <a:ext uri="{FF2B5EF4-FFF2-40B4-BE49-F238E27FC236}">
-                <a16:creationId xmlns:a16="http://schemas.microsoft.com/office/drawing/2014/main" id="{B7AC333C-96BD-457E-91F8-F8EE4459A60C}"/>
+                <a16:creationId xmlns:a16="http://schemas.microsoft.com/office/drawing/2014/main" id="{97B5CEFB-CEAB-4C61-A1A4-4EA8F69BE678}"/>
               </a:ext>
             </a:extLst>
           </p:cNvPr>
@@ -4021,7 +4021,7 @@
           <p:cNvPr id="10" name="">
             <a:extLst xmlns:a="http://schemas.openxmlformats.org/drawingml/2006/main">
               <a:ext uri="{FF2B5EF4-FFF2-40B4-BE49-F238E27FC236}">
-                <a16:creationId xmlns:a16="http://schemas.microsoft.com/office/drawing/2014/main" id="{C21E6F83-C3FB-4DC1-A84C-5B2F23A62464}"/>
+                <a16:creationId xmlns:a16="http://schemas.microsoft.com/office/drawing/2014/main" id="{DBB93508-2206-4A00-B40B-4C658DCFDC9F}"/>
               </a:ext>
             </a:extLst>
           </p:cNvPr>
@@ -4078,7 +4078,7 @@
           <p:cNvPr id="11" name="">
             <a:extLst xmlns:a="http://schemas.openxmlformats.org/drawingml/2006/main">
               <a:ext uri="{FF2B5EF4-FFF2-40B4-BE49-F238E27FC236}">
-                <a16:creationId xmlns:a16="http://schemas.microsoft.com/office/drawing/2014/main" id="{30913D16-C884-45B2-A957-E6FDC82AF117}"/>
+                <a16:creationId xmlns:a16="http://schemas.microsoft.com/office/drawing/2014/main" id="{E96DD6FA-76DE-4105-A5D1-B63E643305B6}"/>
               </a:ext>
             </a:extLst>
           </p:cNvPr>
@@ -4133,7 +4133,7 @@
     </p:spTree>
     <p:extLst>
       <p:ext uri="{BB962C8B-B14F-4D97-AF65-F5344CB8AC3E}">
-        <p14:creationId xmlns:p14="http://schemas.microsoft.com/office/powerpoint/2010/main" val="705555188"/>
+        <p14:creationId xmlns:p14="http://schemas.microsoft.com/office/powerpoint/2010/main" val="1804338835"/>
       </p:ext>
     </p:extLst>
   </p:cSld>
@@ -4164,7 +4164,7 @@
           <p:cNvPr id="12" name="">
             <a:extLst xmlns:a="http://schemas.openxmlformats.org/drawingml/2006/main">
               <a:ext uri="{FF2B5EF4-FFF2-40B4-BE49-F238E27FC236}">
-                <a16:creationId xmlns:a16="http://schemas.microsoft.com/office/drawing/2014/main" id="{FFA7344B-00AB-407D-9F08-2147550FEC63}"/>
+                <a16:creationId xmlns:a16="http://schemas.microsoft.com/office/drawing/2014/main" id="{D24F6865-1D0D-4310-81FF-124F7343A39C}"/>
               </a:ext>
             </a:extLst>
           </p:cNvPr>
@@ -4221,7 +4221,7 @@
           <p:cNvPr id="2" name="">
             <a:extLst xmlns:a="http://schemas.openxmlformats.org/drawingml/2006/main">
               <a:ext uri="{FF2B5EF4-FFF2-40B4-BE49-F238E27FC236}">
-                <a16:creationId xmlns:a16="http://schemas.microsoft.com/office/drawing/2014/main" id="{EB13E689-6C79-4FB4-B1BA-B579E5A7C88B}"/>
+                <a16:creationId xmlns:a16="http://schemas.microsoft.com/office/drawing/2014/main" id="{D71F60AC-45DE-4DBC-A504-99D6BC8A60D5}"/>
               </a:ext>
             </a:extLst>
           </p:cNvPr>
@@ -4278,7 +4278,7 @@
           <p:cNvPr id="3" name="">
             <a:extLst xmlns:a="http://schemas.openxmlformats.org/drawingml/2006/main">
               <a:ext uri="{FF2B5EF4-FFF2-40B4-BE49-F238E27FC236}">
-                <a16:creationId xmlns:a16="http://schemas.microsoft.com/office/drawing/2014/main" id="{45496AB7-E76E-4DFF-847A-07435A699099}"/>
+                <a16:creationId xmlns:a16="http://schemas.microsoft.com/office/drawing/2014/main" id="{E99A59CF-C3AB-4AB1-B32F-92539CB84859}"/>
               </a:ext>
             </a:extLst>
           </p:cNvPr>
@@ -4335,7 +4335,7 @@
           <p:cNvPr id="4" name="">
             <a:extLst xmlns:a="http://schemas.openxmlformats.org/drawingml/2006/main">
               <a:ext uri="{FF2B5EF4-FFF2-40B4-BE49-F238E27FC236}">
-                <a16:creationId xmlns:a16="http://schemas.microsoft.com/office/drawing/2014/main" id="{3C3D9F0B-C701-4F14-9CA6-FD6148CE9A0C}"/>
+                <a16:creationId xmlns:a16="http://schemas.microsoft.com/office/drawing/2014/main" id="{19FE9A57-86A8-46AD-9ACF-5CB8FF8DEFCA}"/>
               </a:ext>
             </a:extLst>
           </p:cNvPr>
@@ -4392,7 +4392,7 @@
           <p:cNvPr id="5" name="">
             <a:extLst xmlns:a="http://schemas.openxmlformats.org/drawingml/2006/main">
               <a:ext uri="{FF2B5EF4-FFF2-40B4-BE49-F238E27FC236}">
-                <a16:creationId xmlns:a16="http://schemas.microsoft.com/office/drawing/2014/main" id="{931B92C6-BD88-4946-81C2-E64F22826D23}"/>
+                <a16:creationId xmlns:a16="http://schemas.microsoft.com/office/drawing/2014/main" id="{003F0C8F-38D6-4464-81A0-3A9AB2DBAE1E}"/>
               </a:ext>
             </a:extLst>
           </p:cNvPr>
@@ -4449,7 +4449,7 @@
           <p:cNvPr id="6" name="">
             <a:extLst xmlns:a="http://schemas.openxmlformats.org/drawingml/2006/main">
               <a:ext uri="{FF2B5EF4-FFF2-40B4-BE49-F238E27FC236}">
-                <a16:creationId xmlns:a16="http://schemas.microsoft.com/office/drawing/2014/main" id="{B7E97F28-BEE5-477A-BAA7-A529B889BD05}"/>
+                <a16:creationId xmlns:a16="http://schemas.microsoft.com/office/drawing/2014/main" id="{C9A4E280-ECBD-4E96-BDD5-D6CD34EC356C}"/>
               </a:ext>
             </a:extLst>
           </p:cNvPr>
@@ -4506,7 +4506,7 @@
           <p:cNvPr id="7" name="">
             <a:extLst xmlns:a="http://schemas.openxmlformats.org/drawingml/2006/main">
               <a:ext uri="{FF2B5EF4-FFF2-40B4-BE49-F238E27FC236}">
-                <a16:creationId xmlns:a16="http://schemas.microsoft.com/office/drawing/2014/main" id="{CCDB8A4D-40BD-4E0D-B5E4-92B08F888206}"/>
+                <a16:creationId xmlns:a16="http://schemas.microsoft.com/office/drawing/2014/main" id="{88A696E2-871B-428D-9A5C-48A1E0858C89}"/>
               </a:ext>
             </a:extLst>
           </p:cNvPr>
@@ -4563,7 +4563,7 @@
           <p:cNvPr id="8" name="">
             <a:extLst xmlns:a="http://schemas.openxmlformats.org/drawingml/2006/main">
               <a:ext uri="{FF2B5EF4-FFF2-40B4-BE49-F238E27FC236}">
-                <a16:creationId xmlns:a16="http://schemas.microsoft.com/office/drawing/2014/main" id="{64A019D4-30BF-456A-BC50-E5EFB615E8E4}"/>
+                <a16:creationId xmlns:a16="http://schemas.microsoft.com/office/drawing/2014/main" id="{40A0023F-1826-4808-9253-D5E9BE5466BC}"/>
               </a:ext>
             </a:extLst>
           </p:cNvPr>
@@ -4620,7 +4620,7 @@
           <p:cNvPr id="9" name="">
             <a:extLst xmlns:a="http://schemas.openxmlformats.org/drawingml/2006/main">
               <a:ext uri="{FF2B5EF4-FFF2-40B4-BE49-F238E27FC236}">
-                <a16:creationId xmlns:a16="http://schemas.microsoft.com/office/drawing/2014/main" id="{1F88BCEB-6BCD-479E-A594-BD098ED4B693}"/>
+                <a16:creationId xmlns:a16="http://schemas.microsoft.com/office/drawing/2014/main" id="{848CD21D-827B-4223-9EBE-B72EE8B3B82B}"/>
               </a:ext>
             </a:extLst>
           </p:cNvPr>
@@ -4677,7 +4677,7 @@
           <p:cNvPr id="10" name="">
             <a:extLst xmlns:a="http://schemas.openxmlformats.org/drawingml/2006/main">
               <a:ext uri="{FF2B5EF4-FFF2-40B4-BE49-F238E27FC236}">
-                <a16:creationId xmlns:a16="http://schemas.microsoft.com/office/drawing/2014/main" id="{A8255345-7BEB-4A0D-BC6E-3C347A04D83C}"/>
+                <a16:creationId xmlns:a16="http://schemas.microsoft.com/office/drawing/2014/main" id="{6C312EDF-0DED-4810-A55A-DB7669CF49D9}"/>
               </a:ext>
             </a:extLst>
           </p:cNvPr>
@@ -4734,7 +4734,7 @@
           <p:cNvPr id="11" name="">
             <a:extLst xmlns:a="http://schemas.openxmlformats.org/drawingml/2006/main">
               <a:ext uri="{FF2B5EF4-FFF2-40B4-BE49-F238E27FC236}">
-                <a16:creationId xmlns:a16="http://schemas.microsoft.com/office/drawing/2014/main" id="{7E66389F-2A5D-4472-AF1C-01DCC1236179}"/>
+                <a16:creationId xmlns:a16="http://schemas.microsoft.com/office/drawing/2014/main" id="{BDFC550C-60F1-401D-A40C-283F5CC9AE3F}"/>
               </a:ext>
             </a:extLst>
           </p:cNvPr>
@@ -4789,7 +4789,7 @@
     </p:spTree>
     <p:extLst>
       <p:ext uri="{BB962C8B-B14F-4D97-AF65-F5344CB8AC3E}">
-        <p14:creationId xmlns:p14="http://schemas.microsoft.com/office/powerpoint/2010/main" val="1855373990"/>
+        <p14:creationId xmlns:p14="http://schemas.microsoft.com/office/powerpoint/2010/main" val="2105661201"/>
       </p:ext>
     </p:extLst>
   </p:cSld>
@@ -4820,7 +4820,7 @@
           <p:cNvPr id="7" name="">
             <a:extLst xmlns:a="http://schemas.openxmlformats.org/drawingml/2006/main">
               <a:ext uri="{FF2B5EF4-FFF2-40B4-BE49-F238E27FC236}">
-                <a16:creationId xmlns:a16="http://schemas.microsoft.com/office/drawing/2014/main" id="{F7E2EFC7-E806-4C85-8320-71615BAA2DE5}"/>
+                <a16:creationId xmlns:a16="http://schemas.microsoft.com/office/drawing/2014/main" id="{641464AF-A74D-4811-BDA6-E5D4FDA9F85F}"/>
               </a:ext>
             </a:extLst>
           </p:cNvPr>
@@ -4877,7 +4877,7 @@
           <p:cNvPr id="2" name="">
             <a:extLst xmlns:a="http://schemas.openxmlformats.org/drawingml/2006/main">
               <a:ext uri="{FF2B5EF4-FFF2-40B4-BE49-F238E27FC236}">
-                <a16:creationId xmlns:a16="http://schemas.microsoft.com/office/drawing/2014/main" id="{160D2E39-D15D-41B4-A58E-3F4D3217F720}"/>
+                <a16:creationId xmlns:a16="http://schemas.microsoft.com/office/drawing/2014/main" id="{BC0297D3-0590-4145-B10E-219C7154D413}"/>
               </a:ext>
             </a:extLst>
           </p:cNvPr>
@@ -4934,7 +4934,7 @@
           <p:cNvPr id="3" name="">
             <a:extLst xmlns:a="http://schemas.openxmlformats.org/drawingml/2006/main">
               <a:ext uri="{FF2B5EF4-FFF2-40B4-BE49-F238E27FC236}">
-                <a16:creationId xmlns:a16="http://schemas.microsoft.com/office/drawing/2014/main" id="{FE56DEB4-CD46-4215-B39F-A97BBD3F95A0}"/>
+                <a16:creationId xmlns:a16="http://schemas.microsoft.com/office/drawing/2014/main" id="{7FA0F374-F3F0-46E0-8362-DD246E08E501}"/>
               </a:ext>
             </a:extLst>
           </p:cNvPr>
@@ -4991,7 +4991,7 @@
           <p:cNvPr id="4" name="">
             <a:extLst xmlns:a="http://schemas.openxmlformats.org/drawingml/2006/main">
               <a:ext uri="{FF2B5EF4-FFF2-40B4-BE49-F238E27FC236}">
-                <a16:creationId xmlns:a16="http://schemas.microsoft.com/office/drawing/2014/main" id="{5469D3D5-191E-4E66-9D61-078CF88F5BCB}"/>
+                <a16:creationId xmlns:a16="http://schemas.microsoft.com/office/drawing/2014/main" id="{9FE3EDE9-1EE1-44BD-BC6C-6C4AF8A78122}"/>
               </a:ext>
             </a:extLst>
           </p:cNvPr>
@@ -5048,7 +5048,7 @@
           <p:cNvPr id="5" name="">
             <a:extLst xmlns:a="http://schemas.openxmlformats.org/drawingml/2006/main">
               <a:ext uri="{FF2B5EF4-FFF2-40B4-BE49-F238E27FC236}">
-                <a16:creationId xmlns:a16="http://schemas.microsoft.com/office/drawing/2014/main" id="{C220CB41-1555-4D51-BCB7-D70D65E75AE6}"/>
+                <a16:creationId xmlns:a16="http://schemas.microsoft.com/office/drawing/2014/main" id="{019CB262-6F4A-40C5-81E7-940C915235D4}"/>
               </a:ext>
             </a:extLst>
           </p:cNvPr>
@@ -5105,7 +5105,7 @@
           <p:cNvPr id="6" name="">
             <a:extLst xmlns:a="http://schemas.openxmlformats.org/drawingml/2006/main">
               <a:ext uri="{FF2B5EF4-FFF2-40B4-BE49-F238E27FC236}">
-                <a16:creationId xmlns:a16="http://schemas.microsoft.com/office/drawing/2014/main" id="{F4C30831-75BC-4DA4-8F12-AB89FF7E9783}"/>
+                <a16:creationId xmlns:a16="http://schemas.microsoft.com/office/drawing/2014/main" id="{0C535414-20E4-4AB6-981C-8E4DB6DA2F22}"/>
               </a:ext>
             </a:extLst>
           </p:cNvPr>
@@ -5183,7 +5183,7 @@
     </p:spTree>
     <p:extLst>
       <p:ext uri="{BB962C8B-B14F-4D97-AF65-F5344CB8AC3E}">
-        <p14:creationId xmlns:p14="http://schemas.microsoft.com/office/powerpoint/2010/main" val="256017258"/>
+        <p14:creationId xmlns:p14="http://schemas.microsoft.com/office/powerpoint/2010/main" val="1136850025"/>
       </p:ext>
     </p:extLst>
   </p:cSld>
@@ -5214,7 +5214,7 @@
           <p:cNvPr id="8" name="">
             <a:extLst xmlns:a="http://schemas.openxmlformats.org/drawingml/2006/main">
               <a:ext uri="{FF2B5EF4-FFF2-40B4-BE49-F238E27FC236}">
-                <a16:creationId xmlns:a16="http://schemas.microsoft.com/office/drawing/2014/main" id="{B3F6B5F7-BB33-4DF4-B618-CF9C97ADD905}"/>
+                <a16:creationId xmlns:a16="http://schemas.microsoft.com/office/drawing/2014/main" id="{347FC393-DF4E-419C-9D48-F3EDFF09488D}"/>
               </a:ext>
             </a:extLst>
           </p:cNvPr>
@@ -5271,7 +5271,7 @@
           <p:cNvPr id="2" name="">
             <a:extLst xmlns:a="http://schemas.openxmlformats.org/drawingml/2006/main">
               <a:ext uri="{FF2B5EF4-FFF2-40B4-BE49-F238E27FC236}">
-                <a16:creationId xmlns:a16="http://schemas.microsoft.com/office/drawing/2014/main" id="{5D0C5B68-D4C0-4BF5-B8C3-978D57AF83B6}"/>
+                <a16:creationId xmlns:a16="http://schemas.microsoft.com/office/drawing/2014/main" id="{B5C1B34A-53CC-4164-A32A-79AAEEF02EA9}"/>
               </a:ext>
             </a:extLst>
           </p:cNvPr>
@@ -5328,7 +5328,7 @@
           <p:cNvPr id="3" name="">
             <a:extLst xmlns:a="http://schemas.openxmlformats.org/drawingml/2006/main">
               <a:ext uri="{FF2B5EF4-FFF2-40B4-BE49-F238E27FC236}">
-                <a16:creationId xmlns:a16="http://schemas.microsoft.com/office/drawing/2014/main" id="{BA4B1F07-6013-4E88-BA8F-DAC98AAFA0F6}"/>
+                <a16:creationId xmlns:a16="http://schemas.microsoft.com/office/drawing/2014/main" id="{8BA94629-8BFD-4BC8-A61C-3FDF594AF486}"/>
               </a:ext>
             </a:extLst>
           </p:cNvPr>
@@ -5385,7 +5385,7 @@
           <p:cNvPr id="4" name="">
             <a:extLst xmlns:a="http://schemas.openxmlformats.org/drawingml/2006/main">
               <a:ext uri="{FF2B5EF4-FFF2-40B4-BE49-F238E27FC236}">
-                <a16:creationId xmlns:a16="http://schemas.microsoft.com/office/drawing/2014/main" id="{05EEC165-F564-49B0-97BD-810BABAC7514}"/>
+                <a16:creationId xmlns:a16="http://schemas.microsoft.com/office/drawing/2014/main" id="{BFDCD6F3-71BE-4FD8-BFE2-16DC4044E7DB}"/>
               </a:ext>
             </a:extLst>
           </p:cNvPr>
@@ -5442,7 +5442,7 @@
           <p:cNvPr id="5" name="">
             <a:extLst xmlns:a="http://schemas.openxmlformats.org/drawingml/2006/main">
               <a:ext uri="{FF2B5EF4-FFF2-40B4-BE49-F238E27FC236}">
-                <a16:creationId xmlns:a16="http://schemas.microsoft.com/office/drawing/2014/main" id="{C18BCFCF-250B-4EFB-8C81-6D53EAB50163}"/>
+                <a16:creationId xmlns:a16="http://schemas.microsoft.com/office/drawing/2014/main" id="{D25B1116-A921-4515-85B4-895CE22DE03B}"/>
               </a:ext>
             </a:extLst>
           </p:cNvPr>
@@ -5689,7 +5689,7 @@
           <p:cNvPr id="7" name="">
             <a:extLst xmlns:a="http://schemas.openxmlformats.org/drawingml/2006/main">
               <a:ext uri="{FF2B5EF4-FFF2-40B4-BE49-F238E27FC236}">
-                <a16:creationId xmlns:a16="http://schemas.microsoft.com/office/drawing/2014/main" id="{D8DF2DB6-1E0D-4170-AD53-A7C70CF044C7}"/>
+                <a16:creationId xmlns:a16="http://schemas.microsoft.com/office/drawing/2014/main" id="{96967E57-465A-48D8-BAFB-B5A497DEDF28}"/>
               </a:ext>
             </a:extLst>
           </p:cNvPr>
@@ -5744,7 +5744,7 @@
     </p:spTree>
     <p:extLst>
       <p:ext uri="{BB962C8B-B14F-4D97-AF65-F5344CB8AC3E}">
-        <p14:creationId xmlns:p14="http://schemas.microsoft.com/office/powerpoint/2010/main" val="1628544134"/>
+        <p14:creationId xmlns:p14="http://schemas.microsoft.com/office/powerpoint/2010/main" val="564737492"/>
       </p:ext>
     </p:extLst>
   </p:cSld>
@@ -5775,7 +5775,7 @@
           <p:cNvPr id="9" name="">
             <a:extLst xmlns:a="http://schemas.openxmlformats.org/drawingml/2006/main">
               <a:ext uri="{FF2B5EF4-FFF2-40B4-BE49-F238E27FC236}">
-                <a16:creationId xmlns:a16="http://schemas.microsoft.com/office/drawing/2014/main" id="{02552E46-F014-438B-8C67-D4804F9A9088}"/>
+                <a16:creationId xmlns:a16="http://schemas.microsoft.com/office/drawing/2014/main" id="{993FB096-D90C-4A83-B80F-A31621C8A0D4}"/>
               </a:ext>
             </a:extLst>
           </p:cNvPr>
@@ -5832,7 +5832,7 @@
           <p:cNvPr id="2" name="">
             <a:extLst xmlns:a="http://schemas.openxmlformats.org/drawingml/2006/main">
               <a:ext uri="{FF2B5EF4-FFF2-40B4-BE49-F238E27FC236}">
-                <a16:creationId xmlns:a16="http://schemas.microsoft.com/office/drawing/2014/main" id="{E86578FA-35D7-4197-B991-6D834D65D66F}"/>
+                <a16:creationId xmlns:a16="http://schemas.microsoft.com/office/drawing/2014/main" id="{251BB49F-B107-48FE-8AF0-80A2B812F38F}"/>
               </a:ext>
             </a:extLst>
           </p:cNvPr>
@@ -5889,7 +5889,7 @@
           <p:cNvPr id="3" name="">
             <a:extLst xmlns:a="http://schemas.openxmlformats.org/drawingml/2006/main">
               <a:ext uri="{FF2B5EF4-FFF2-40B4-BE49-F238E27FC236}">
-                <a16:creationId xmlns:a16="http://schemas.microsoft.com/office/drawing/2014/main" id="{D864E1D1-07E6-4A71-9B60-3529DAD276FE}"/>
+                <a16:creationId xmlns:a16="http://schemas.microsoft.com/office/drawing/2014/main" id="{4E086627-880B-483E-AB3A-CF01B91315E3}"/>
               </a:ext>
             </a:extLst>
           </p:cNvPr>
@@ -5946,7 +5946,7 @@
           <p:cNvPr id="4" name="">
             <a:extLst xmlns:a="http://schemas.openxmlformats.org/drawingml/2006/main">
               <a:ext uri="{FF2B5EF4-FFF2-40B4-BE49-F238E27FC236}">
-                <a16:creationId xmlns:a16="http://schemas.microsoft.com/office/drawing/2014/main" id="{2DBC5DED-C0A8-45AB-8DE7-ED227DC8BF87}"/>
+                <a16:creationId xmlns:a16="http://schemas.microsoft.com/office/drawing/2014/main" id="{15FB303D-FE8C-4844-A75E-94A57B014AA7}"/>
               </a:ext>
             </a:extLst>
           </p:cNvPr>
@@ -6003,7 +6003,7 @@
           <p:cNvPr id="5" name="">
             <a:extLst xmlns:a="http://schemas.openxmlformats.org/drawingml/2006/main">
               <a:ext uri="{FF2B5EF4-FFF2-40B4-BE49-F238E27FC236}">
-                <a16:creationId xmlns:a16="http://schemas.microsoft.com/office/drawing/2014/main" id="{A7C6757E-C2D3-4FF6-827C-51D63D0509CF}"/>
+                <a16:creationId xmlns:a16="http://schemas.microsoft.com/office/drawing/2014/main" id="{37A95889-8CEE-41FE-8181-76E527EE00B2}"/>
               </a:ext>
             </a:extLst>
           </p:cNvPr>
@@ -6060,7 +6060,7 @@
           <p:cNvPr id="6" name="">
             <a:extLst xmlns:a="http://schemas.openxmlformats.org/drawingml/2006/main">
               <a:ext uri="{FF2B5EF4-FFF2-40B4-BE49-F238E27FC236}">
-                <a16:creationId xmlns:a16="http://schemas.microsoft.com/office/drawing/2014/main" id="{AE705107-E7BF-428A-90AA-F96C10DF883A}"/>
+                <a16:creationId xmlns:a16="http://schemas.microsoft.com/office/drawing/2014/main" id="{3693345B-2AB2-4650-8CC4-A8C67E843422}"/>
               </a:ext>
             </a:extLst>
           </p:cNvPr>
@@ -6117,7 +6117,7 @@
           <p:cNvPr id="7" name="">
             <a:extLst xmlns:a="http://schemas.openxmlformats.org/drawingml/2006/main">
               <a:ext uri="{FF2B5EF4-FFF2-40B4-BE49-F238E27FC236}">
-                <a16:creationId xmlns:a16="http://schemas.microsoft.com/office/drawing/2014/main" id="{CEAEB168-D055-4C5A-B92F-EB99D3609A7E}"/>
+                <a16:creationId xmlns:a16="http://schemas.microsoft.com/office/drawing/2014/main" id="{3B26D9EA-BBFB-43DD-BD06-1C38257AAB0D}"/>
               </a:ext>
             </a:extLst>
           </p:cNvPr>
@@ -6174,7 +6174,7 @@
           <p:cNvPr id="8" name="">
             <a:extLst xmlns:a="http://schemas.openxmlformats.org/drawingml/2006/main">
               <a:ext uri="{FF2B5EF4-FFF2-40B4-BE49-F238E27FC236}">
-                <a16:creationId xmlns:a16="http://schemas.microsoft.com/office/drawing/2014/main" id="{41D98FDA-64B5-4489-9C23-16A93E070E0B}"/>
+                <a16:creationId xmlns:a16="http://schemas.microsoft.com/office/drawing/2014/main" id="{027A85A6-B5D0-4758-9157-71A1389E8671}"/>
               </a:ext>
             </a:extLst>
           </p:cNvPr>
@@ -6252,7 +6252,7 @@
     </p:spTree>
     <p:extLst>
       <p:ext uri="{BB962C8B-B14F-4D97-AF65-F5344CB8AC3E}">
-        <p14:creationId xmlns:p14="http://schemas.microsoft.com/office/powerpoint/2010/main" val="1425716084"/>
+        <p14:creationId xmlns:p14="http://schemas.microsoft.com/office/powerpoint/2010/main" val="599906435"/>
       </p:ext>
     </p:extLst>
   </p:cSld>
@@ -6283,7 +6283,7 @@
           <p:cNvPr id="8" name="">
             <a:extLst xmlns:a="http://schemas.openxmlformats.org/drawingml/2006/main">
               <a:ext uri="{FF2B5EF4-FFF2-40B4-BE49-F238E27FC236}">
-                <a16:creationId xmlns:a16="http://schemas.microsoft.com/office/drawing/2014/main" id="{CB4DB22E-C88B-4669-9FBE-ED67BF2B7776}"/>
+                <a16:creationId xmlns:a16="http://schemas.microsoft.com/office/drawing/2014/main" id="{168FE299-1820-4FF4-B7E7-B251837C7A68}"/>
               </a:ext>
             </a:extLst>
           </p:cNvPr>
@@ -6340,7 +6340,7 @@
           <p:cNvPr id="2" name="">
             <a:extLst xmlns:a="http://schemas.openxmlformats.org/drawingml/2006/main">
               <a:ext uri="{FF2B5EF4-FFF2-40B4-BE49-F238E27FC236}">
-                <a16:creationId xmlns:a16="http://schemas.microsoft.com/office/drawing/2014/main" id="{EB99ECE0-34F9-4DDA-AA17-CAFE690AD23C}"/>
+                <a16:creationId xmlns:a16="http://schemas.microsoft.com/office/drawing/2014/main" id="{3C2DF795-6297-4A53-83AD-FF3C5E460270}"/>
               </a:ext>
             </a:extLst>
           </p:cNvPr>
@@ -6397,7 +6397,7 @@
           <p:cNvPr id="3" name="">
             <a:extLst xmlns:a="http://schemas.openxmlformats.org/drawingml/2006/main">
               <a:ext uri="{FF2B5EF4-FFF2-40B4-BE49-F238E27FC236}">
-                <a16:creationId xmlns:a16="http://schemas.microsoft.com/office/drawing/2014/main" id="{548BA0B0-25B2-47C1-9851-DB1D173D4C96}"/>
+                <a16:creationId xmlns:a16="http://schemas.microsoft.com/office/drawing/2014/main" id="{6BDBEF28-52A3-48B8-AD97-6B850ECFE308}"/>
               </a:ext>
             </a:extLst>
           </p:cNvPr>
@@ -6454,7 +6454,7 @@
           <p:cNvPr id="4" name="">
             <a:extLst xmlns:a="http://schemas.openxmlformats.org/drawingml/2006/main">
               <a:ext uri="{FF2B5EF4-FFF2-40B4-BE49-F238E27FC236}">
-                <a16:creationId xmlns:a16="http://schemas.microsoft.com/office/drawing/2014/main" id="{C4C9F387-451F-4F6A-9100-214BCC7E70E0}"/>
+                <a16:creationId xmlns:a16="http://schemas.microsoft.com/office/drawing/2014/main" id="{D432C00B-0001-450C-AF77-904F186D5D6F}"/>
               </a:ext>
             </a:extLst>
           </p:cNvPr>
@@ -6511,7 +6511,7 @@
           <p:cNvPr id="5" name="">
             <a:extLst xmlns:a="http://schemas.openxmlformats.org/drawingml/2006/main">
               <a:ext uri="{FF2B5EF4-FFF2-40B4-BE49-F238E27FC236}">
-                <a16:creationId xmlns:a16="http://schemas.microsoft.com/office/drawing/2014/main" id="{2485B070-E695-4859-9E84-7CB077CD884E}"/>
+                <a16:creationId xmlns:a16="http://schemas.microsoft.com/office/drawing/2014/main" id="{B3303C08-3E2C-4969-92BD-8C8F45B3FFF1}"/>
               </a:ext>
             </a:extLst>
           </p:cNvPr>
@@ -6840,7 +6840,7 @@
           <p:cNvPr id="7" name="">
             <a:extLst xmlns:a="http://schemas.openxmlformats.org/drawingml/2006/main">
               <a:ext uri="{FF2B5EF4-FFF2-40B4-BE49-F238E27FC236}">
-                <a16:creationId xmlns:a16="http://schemas.microsoft.com/office/drawing/2014/main" id="{38B86D11-7A0A-48ED-A443-6F5F4EFB7F29}"/>
+                <a16:creationId xmlns:a16="http://schemas.microsoft.com/office/drawing/2014/main" id="{A741EC2C-37B8-4DBC-B615-C272238ED8F8}"/>
               </a:ext>
             </a:extLst>
           </p:cNvPr>
@@ -6918,7 +6918,7 @@
     </p:spTree>
     <p:extLst>
       <p:ext uri="{BB962C8B-B14F-4D97-AF65-F5344CB8AC3E}">
-        <p14:creationId xmlns:p14="http://schemas.microsoft.com/office/powerpoint/2010/main" val="1688830113"/>
+        <p14:creationId xmlns:p14="http://schemas.microsoft.com/office/powerpoint/2010/main" val="1957571820"/>
       </p:ext>
     </p:extLst>
   </p:cSld>
@@ -6949,7 +6949,7 @@
           <p:cNvPr id="8" name="">
             <a:extLst xmlns:a="http://schemas.openxmlformats.org/drawingml/2006/main">
               <a:ext uri="{FF2B5EF4-FFF2-40B4-BE49-F238E27FC236}">
-                <a16:creationId xmlns:a16="http://schemas.microsoft.com/office/drawing/2014/main" id="{4B78ADE5-DBBF-487B-87E3-25FD722311AA}"/>
+                <a16:creationId xmlns:a16="http://schemas.microsoft.com/office/drawing/2014/main" id="{0AD9902D-FB36-4132-A9E8-202A02CC51D6}"/>
               </a:ext>
             </a:extLst>
           </p:cNvPr>
@@ -7006,7 +7006,7 @@
           <p:cNvPr id="2" name="">
             <a:extLst xmlns:a="http://schemas.openxmlformats.org/drawingml/2006/main">
               <a:ext uri="{FF2B5EF4-FFF2-40B4-BE49-F238E27FC236}">
-                <a16:creationId xmlns:a16="http://schemas.microsoft.com/office/drawing/2014/main" id="{94FAD884-C606-47BE-A9F2-6D9A83233F53}"/>
+                <a16:creationId xmlns:a16="http://schemas.microsoft.com/office/drawing/2014/main" id="{14B1C12C-ECF0-4DF7-9218-AF69C6DAB933}"/>
               </a:ext>
             </a:extLst>
           </p:cNvPr>
@@ -7063,7 +7063,7 @@
           <p:cNvPr id="3" name="">
             <a:extLst xmlns:a="http://schemas.openxmlformats.org/drawingml/2006/main">
               <a:ext uri="{FF2B5EF4-FFF2-40B4-BE49-F238E27FC236}">
-                <a16:creationId xmlns:a16="http://schemas.microsoft.com/office/drawing/2014/main" id="{92A30062-D148-466C-848C-DE34B2576044}"/>
+                <a16:creationId xmlns:a16="http://schemas.microsoft.com/office/drawing/2014/main" id="{64C9E724-60FC-423C-85B4-A3B0889BEE89}"/>
               </a:ext>
             </a:extLst>
           </p:cNvPr>
@@ -7120,7 +7120,7 @@
           <p:cNvPr id="4" name="">
             <a:extLst xmlns:a="http://schemas.openxmlformats.org/drawingml/2006/main">
               <a:ext uri="{FF2B5EF4-FFF2-40B4-BE49-F238E27FC236}">
-                <a16:creationId xmlns:a16="http://schemas.microsoft.com/office/drawing/2014/main" id="{94EE08E4-AE03-402E-80D6-64463CE314F2}"/>
+                <a16:creationId xmlns:a16="http://schemas.microsoft.com/office/drawing/2014/main" id="{A53DE48C-8CF7-40AA-9233-175E3718E2F3}"/>
               </a:ext>
             </a:extLst>
           </p:cNvPr>
@@ -7184,7 +7184,7 @@
         </p:xfrm>
         <a:graphic xmlns:a="http://schemas.openxmlformats.org/drawingml/2006/main">
           <a:graphicData uri="http://schemas.openxmlformats.org/drawingml/2006/chart">
-            <c:chart xmlns:r="http://schemas.openxmlformats.org/officeDocument/2006/relationships" xmlns:c="http://schemas.openxmlformats.org/drawingml/2006/chart" r:id="Ra420aa03fa9b461e"/>
+            <c:chart xmlns:r="http://schemas.openxmlformats.org/officeDocument/2006/relationships" xmlns:c="http://schemas.openxmlformats.org/drawingml/2006/chart" r:id="R8c25d8859f744496"/>
           </a:graphicData>
         </a:graphic>
       </p:graphicFrame>
@@ -7193,7 +7193,7 @@
           <p:cNvPr id="6" name="">
             <a:extLst xmlns:a="http://schemas.openxmlformats.org/drawingml/2006/main">
               <a:ext uri="{FF2B5EF4-FFF2-40B4-BE49-F238E27FC236}">
-                <a16:creationId xmlns:a16="http://schemas.microsoft.com/office/drawing/2014/main" id="{D924A61E-40BC-4821-91B0-F1677097C676}"/>
+                <a16:creationId xmlns:a16="http://schemas.microsoft.com/office/drawing/2014/main" id="{FE9F781D-9F37-4F8F-8BAE-4370A53D8E19}"/>
               </a:ext>
             </a:extLst>
           </p:cNvPr>
@@ -7250,7 +7250,7 @@
           <p:cNvPr id="7" name="">
             <a:extLst xmlns:a="http://schemas.openxmlformats.org/drawingml/2006/main">
               <a:ext uri="{FF2B5EF4-FFF2-40B4-BE49-F238E27FC236}">
-                <a16:creationId xmlns:a16="http://schemas.microsoft.com/office/drawing/2014/main" id="{F0C2EDAC-963A-444E-8A6D-12540C325F45}"/>
+                <a16:creationId xmlns:a16="http://schemas.microsoft.com/office/drawing/2014/main" id="{41A1465F-5490-4AE7-81F2-97A5E01E4BAF}"/>
               </a:ext>
             </a:extLst>
           </p:cNvPr>
@@ -7305,7 +7305,7 @@
     </p:spTree>
     <p:extLst>
       <p:ext uri="{BB962C8B-B14F-4D97-AF65-F5344CB8AC3E}">
-        <p14:creationId xmlns:p14="http://schemas.microsoft.com/office/powerpoint/2010/main" val="680102961"/>
+        <p14:creationId xmlns:p14="http://schemas.microsoft.com/office/powerpoint/2010/main" val="983139291"/>
       </p:ext>
     </p:extLst>
   </p:cSld>
@@ -7336,7 +7336,7 @@
           <p:cNvPr id="8" name="">
             <a:extLst xmlns:a="http://schemas.openxmlformats.org/drawingml/2006/main">
               <a:ext uri="{FF2B5EF4-FFF2-40B4-BE49-F238E27FC236}">
-                <a16:creationId xmlns:a16="http://schemas.microsoft.com/office/drawing/2014/main" id="{B51DE6C3-A68E-41C4-B944-8CC76B3AD859}"/>
+                <a16:creationId xmlns:a16="http://schemas.microsoft.com/office/drawing/2014/main" id="{BE178317-EFFD-45E3-B8F9-1437F2EB02D3}"/>
               </a:ext>
             </a:extLst>
           </p:cNvPr>
@@ -7393,7 +7393,7 @@
           <p:cNvPr id="2" name="">
             <a:extLst xmlns:a="http://schemas.openxmlformats.org/drawingml/2006/main">
               <a:ext uri="{FF2B5EF4-FFF2-40B4-BE49-F238E27FC236}">
-                <a16:creationId xmlns:a16="http://schemas.microsoft.com/office/drawing/2014/main" id="{A75A9A5A-46D2-47EC-BE38-E4EFD70D672B}"/>
+                <a16:creationId xmlns:a16="http://schemas.microsoft.com/office/drawing/2014/main" id="{B92DEAB9-4492-48E1-B43E-DA4ED4358023}"/>
               </a:ext>
             </a:extLst>
           </p:cNvPr>
@@ -7450,7 +7450,7 @@
           <p:cNvPr id="3" name="">
             <a:extLst xmlns:a="http://schemas.openxmlformats.org/drawingml/2006/main">
               <a:ext uri="{FF2B5EF4-FFF2-40B4-BE49-F238E27FC236}">
-                <a16:creationId xmlns:a16="http://schemas.microsoft.com/office/drawing/2014/main" id="{EDC152C4-7821-47A7-A39E-9B0BA376F813}"/>
+                <a16:creationId xmlns:a16="http://schemas.microsoft.com/office/drawing/2014/main" id="{C3AEB976-3BA8-4ECF-88D5-84E35559E250}"/>
               </a:ext>
             </a:extLst>
           </p:cNvPr>
@@ -7507,7 +7507,7 @@
           <p:cNvPr id="4" name="">
             <a:extLst xmlns:a="http://schemas.openxmlformats.org/drawingml/2006/main">
               <a:ext uri="{FF2B5EF4-FFF2-40B4-BE49-F238E27FC236}">
-                <a16:creationId xmlns:a16="http://schemas.microsoft.com/office/drawing/2014/main" id="{7B2F115D-6F57-40F5-AF9F-23C9543568E4}"/>
+                <a16:creationId xmlns:a16="http://schemas.microsoft.com/office/drawing/2014/main" id="{042C0417-4A9F-4749-9272-6C2EFBC86205}"/>
               </a:ext>
             </a:extLst>
           </p:cNvPr>
@@ -7564,7 +7564,7 @@
           <p:cNvPr id="5" name="">
             <a:extLst xmlns:a="http://schemas.openxmlformats.org/drawingml/2006/main">
               <a:ext uri="{FF2B5EF4-FFF2-40B4-BE49-F238E27FC236}">
-                <a16:creationId xmlns:a16="http://schemas.microsoft.com/office/drawing/2014/main" id="{2E9EB3D2-595E-4B2F-8AB4-4BCA02C775DB}"/>
+                <a16:creationId xmlns:a16="http://schemas.microsoft.com/office/drawing/2014/main" id="{D6D72ACC-BABF-4B48-9C24-0D8FC67815D8}"/>
               </a:ext>
             </a:extLst>
           </p:cNvPr>
@@ -7621,7 +7621,7 @@
           <p:cNvPr id="6" name="">
             <a:extLst xmlns:a="http://schemas.openxmlformats.org/drawingml/2006/main">
               <a:ext uri="{FF2B5EF4-FFF2-40B4-BE49-F238E27FC236}">
-                <a16:creationId xmlns:a16="http://schemas.microsoft.com/office/drawing/2014/main" id="{BC0A30A7-799A-491E-8EE9-397B98A51355}"/>
+                <a16:creationId xmlns:a16="http://schemas.microsoft.com/office/drawing/2014/main" id="{2A7D851F-A7CB-4673-AEC3-2919B704DB1E}"/>
               </a:ext>
             </a:extLst>
           </p:cNvPr>
@@ -7678,7 +7678,7 @@
           <p:cNvPr id="7" name="">
             <a:extLst xmlns:a="http://schemas.openxmlformats.org/drawingml/2006/main">
               <a:ext uri="{FF2B5EF4-FFF2-40B4-BE49-F238E27FC236}">
-                <a16:creationId xmlns:a16="http://schemas.microsoft.com/office/drawing/2014/main" id="{24DCA3B4-4C22-4CDE-819C-C93CFF858F33}"/>
+                <a16:creationId xmlns:a16="http://schemas.microsoft.com/office/drawing/2014/main" id="{F0FECD86-17BA-42B5-854C-2F9FF66E580E}"/>
               </a:ext>
             </a:extLst>
           </p:cNvPr>
@@ -7733,7 +7733,7 @@
     </p:spTree>
     <p:extLst>
       <p:ext uri="{BB962C8B-B14F-4D97-AF65-F5344CB8AC3E}">
-        <p14:creationId xmlns:p14="http://schemas.microsoft.com/office/powerpoint/2010/main" val="1479781159"/>
+        <p14:creationId xmlns:p14="http://schemas.microsoft.com/office/powerpoint/2010/main" val="1318931456"/>
       </p:ext>
     </p:extLst>
   </p:cSld>
@@ -7764,7 +7764,7 @@
           <p:cNvPr id="8" name="">
             <a:extLst xmlns:a="http://schemas.openxmlformats.org/drawingml/2006/main">
               <a:ext uri="{FF2B5EF4-FFF2-40B4-BE49-F238E27FC236}">
-                <a16:creationId xmlns:a16="http://schemas.microsoft.com/office/drawing/2014/main" id="{587F7B8E-8DFB-43F6-BF10-AEB4DFD5BFFB}"/>
+                <a16:creationId xmlns:a16="http://schemas.microsoft.com/office/drawing/2014/main" id="{E533B426-43FD-4F50-940A-97494BBBEAB5}"/>
               </a:ext>
             </a:extLst>
           </p:cNvPr>
@@ -7821,7 +7821,7 @@
           <p:cNvPr id="2" name="">
             <a:extLst xmlns:a="http://schemas.openxmlformats.org/drawingml/2006/main">
               <a:ext uri="{FF2B5EF4-FFF2-40B4-BE49-F238E27FC236}">
-                <a16:creationId xmlns:a16="http://schemas.microsoft.com/office/drawing/2014/main" id="{5DCD86D2-B08E-4451-827C-140A9D224311}"/>
+                <a16:creationId xmlns:a16="http://schemas.microsoft.com/office/drawing/2014/main" id="{8F6BD969-0FCE-4762-8768-D0E9BF3A2A1D}"/>
               </a:ext>
             </a:extLst>
           </p:cNvPr>
@@ -7878,7 +7878,7 @@
           <p:cNvPr id="3" name="">
             <a:extLst xmlns:a="http://schemas.openxmlformats.org/drawingml/2006/main">
               <a:ext uri="{FF2B5EF4-FFF2-40B4-BE49-F238E27FC236}">
-                <a16:creationId xmlns:a16="http://schemas.microsoft.com/office/drawing/2014/main" id="{B08AEA94-CA48-4E41-98CC-52156C036B81}"/>
+                <a16:creationId xmlns:a16="http://schemas.microsoft.com/office/drawing/2014/main" id="{0B70762D-BF28-4C47-AD33-3EFCF3960F20}"/>
               </a:ext>
             </a:extLst>
           </p:cNvPr>
@@ -7935,7 +7935,7 @@
           <p:cNvPr id="4" name="">
             <a:extLst xmlns:a="http://schemas.openxmlformats.org/drawingml/2006/main">
               <a:ext uri="{FF2B5EF4-FFF2-40B4-BE49-F238E27FC236}">
-                <a16:creationId xmlns:a16="http://schemas.microsoft.com/office/drawing/2014/main" id="{8D70B9CF-6E60-432C-91BA-D3BF0B818C4C}"/>
+                <a16:creationId xmlns:a16="http://schemas.microsoft.com/office/drawing/2014/main" id="{961F6038-1EE7-4A10-A7CC-1A43EB3CD7E0}"/>
               </a:ext>
             </a:extLst>
           </p:cNvPr>
@@ -7992,7 +7992,7 @@
           <p:cNvPr id="5" name="">
             <a:extLst xmlns:a="http://schemas.openxmlformats.org/drawingml/2006/main">
               <a:ext uri="{FF2B5EF4-FFF2-40B4-BE49-F238E27FC236}">
-                <a16:creationId xmlns:a16="http://schemas.microsoft.com/office/drawing/2014/main" id="{11722612-D8C2-4A22-9CB3-874BD485F86F}"/>
+                <a16:creationId xmlns:a16="http://schemas.microsoft.com/office/drawing/2014/main" id="{57102AEA-9F46-4AE6-B1B2-3663323AC7D1}"/>
               </a:ext>
             </a:extLst>
           </p:cNvPr>
@@ -8295,7 +8295,7 @@
           <p:cNvPr id="7" name="">
             <a:extLst xmlns:a="http://schemas.openxmlformats.org/drawingml/2006/main">
               <a:ext uri="{FF2B5EF4-FFF2-40B4-BE49-F238E27FC236}">
-                <a16:creationId xmlns:a16="http://schemas.microsoft.com/office/drawing/2014/main" id="{50CC3E21-44A1-4B64-A2A9-8894C67FCF42}"/>
+                <a16:creationId xmlns:a16="http://schemas.microsoft.com/office/drawing/2014/main" id="{53D1CE32-77B9-45D8-8EB9-7F313EA5F884}"/>
               </a:ext>
             </a:extLst>
           </p:cNvPr>
@@ -8373,7 +8373,7 @@
     </p:spTree>
     <p:extLst>
       <p:ext uri="{BB962C8B-B14F-4D97-AF65-F5344CB8AC3E}">
-        <p14:creationId xmlns:p14="http://schemas.microsoft.com/office/powerpoint/2010/main" val="45045988"/>
+        <p14:creationId xmlns:p14="http://schemas.microsoft.com/office/powerpoint/2010/main" val="601937583"/>
       </p:ext>
     </p:extLst>
   </p:cSld>
@@ -8404,7 +8404,7 @@
           <p:cNvPr id="10" name="">
             <a:extLst xmlns:a="http://schemas.openxmlformats.org/drawingml/2006/main">
               <a:ext uri="{FF2B5EF4-FFF2-40B4-BE49-F238E27FC236}">
-                <a16:creationId xmlns:a16="http://schemas.microsoft.com/office/drawing/2014/main" id="{BE758969-5053-4888-87CB-043B081FD1C0}"/>
+                <a16:creationId xmlns:a16="http://schemas.microsoft.com/office/drawing/2014/main" id="{A576850C-2974-4F3E-8687-0CFBA51F721E}"/>
               </a:ext>
             </a:extLst>
           </p:cNvPr>
@@ -8461,7 +8461,7 @@
           <p:cNvPr id="2" name="">
             <a:extLst xmlns:a="http://schemas.openxmlformats.org/drawingml/2006/main">
               <a:ext uri="{FF2B5EF4-FFF2-40B4-BE49-F238E27FC236}">
-                <a16:creationId xmlns:a16="http://schemas.microsoft.com/office/drawing/2014/main" id="{F5D09830-0A57-4101-8197-112FC59B4B7C}"/>
+                <a16:creationId xmlns:a16="http://schemas.microsoft.com/office/drawing/2014/main" id="{2EA5C1DC-02DC-4D4F-B8A4-0CB9FA38C9EF}"/>
               </a:ext>
             </a:extLst>
           </p:cNvPr>
@@ -8518,7 +8518,7 @@
           <p:cNvPr id="3" name="">
             <a:extLst xmlns:a="http://schemas.openxmlformats.org/drawingml/2006/main">
               <a:ext uri="{FF2B5EF4-FFF2-40B4-BE49-F238E27FC236}">
-                <a16:creationId xmlns:a16="http://schemas.microsoft.com/office/drawing/2014/main" id="{E7038EF0-F0D8-4EF5-9766-95F1C798F9CC}"/>
+                <a16:creationId xmlns:a16="http://schemas.microsoft.com/office/drawing/2014/main" id="{5077322F-D265-4691-BCD2-D689BD1A9405}"/>
               </a:ext>
             </a:extLst>
           </p:cNvPr>
@@ -8575,7 +8575,7 @@
           <p:cNvPr id="4" name="">
             <a:extLst xmlns:a="http://schemas.openxmlformats.org/drawingml/2006/main">
               <a:ext uri="{FF2B5EF4-FFF2-40B4-BE49-F238E27FC236}">
-                <a16:creationId xmlns:a16="http://schemas.microsoft.com/office/drawing/2014/main" id="{82E7F64F-BDE9-484A-9F55-80550CC5EADF}"/>
+                <a16:creationId xmlns:a16="http://schemas.microsoft.com/office/drawing/2014/main" id="{A17A7F72-84F3-4A58-BDB0-1800A26BD763}"/>
               </a:ext>
             </a:extLst>
           </p:cNvPr>
@@ -8632,7 +8632,7 @@
           <p:cNvPr id="5" name="">
             <a:extLst xmlns:a="http://schemas.openxmlformats.org/drawingml/2006/main">
               <a:ext uri="{FF2B5EF4-FFF2-40B4-BE49-F238E27FC236}">
-                <a16:creationId xmlns:a16="http://schemas.microsoft.com/office/drawing/2014/main" id="{FD720D7B-B747-4FF7-B422-9F71C82814DF}"/>
+                <a16:creationId xmlns:a16="http://schemas.microsoft.com/office/drawing/2014/main" id="{1E2CB681-778B-4BFD-B289-54B892A56975}"/>
               </a:ext>
             </a:extLst>
           </p:cNvPr>
@@ -8689,7 +8689,7 @@
           <p:cNvPr id="6" name="">
             <a:extLst xmlns:a="http://schemas.openxmlformats.org/drawingml/2006/main">
               <a:ext uri="{FF2B5EF4-FFF2-40B4-BE49-F238E27FC236}">
-                <a16:creationId xmlns:a16="http://schemas.microsoft.com/office/drawing/2014/main" id="{5E1D3B49-E603-4738-8E23-3BCCF950A4BD}"/>
+                <a16:creationId xmlns:a16="http://schemas.microsoft.com/office/drawing/2014/main" id="{34AB7611-E044-443D-B70E-4C8D2A413F6E}"/>
               </a:ext>
             </a:extLst>
           </p:cNvPr>
@@ -8746,7 +8746,7 @@
           <p:cNvPr id="7" name="">
             <a:extLst xmlns:a="http://schemas.openxmlformats.org/drawingml/2006/main">
               <a:ext uri="{FF2B5EF4-FFF2-40B4-BE49-F238E27FC236}">
-                <a16:creationId xmlns:a16="http://schemas.microsoft.com/office/drawing/2014/main" id="{D78D948A-8950-40EE-AF01-7F1D313DBEEC}"/>
+                <a16:creationId xmlns:a16="http://schemas.microsoft.com/office/drawing/2014/main" id="{C4904875-CABE-4FA2-BF84-979B07734DBB}"/>
               </a:ext>
             </a:extLst>
           </p:cNvPr>
@@ -8803,7 +8803,7 @@
           <p:cNvPr id="8" name="">
             <a:extLst xmlns:a="http://schemas.openxmlformats.org/drawingml/2006/main">
               <a:ext uri="{FF2B5EF4-FFF2-40B4-BE49-F238E27FC236}">
-                <a16:creationId xmlns:a16="http://schemas.microsoft.com/office/drawing/2014/main" id="{5152D2F8-05DD-49C1-B58C-6E3B1D5640FB}"/>
+                <a16:creationId xmlns:a16="http://schemas.microsoft.com/office/drawing/2014/main" id="{D6C9696A-E435-40AD-97CA-0F3BBB3E3FAA}"/>
               </a:ext>
             </a:extLst>
           </p:cNvPr>
@@ -8860,7 +8860,7 @@
           <p:cNvPr id="9" name="">
             <a:extLst xmlns:a="http://schemas.openxmlformats.org/drawingml/2006/main">
               <a:ext uri="{FF2B5EF4-FFF2-40B4-BE49-F238E27FC236}">
-                <a16:creationId xmlns:a16="http://schemas.microsoft.com/office/drawing/2014/main" id="{EE534577-3E31-4BD7-AA18-764EBCF98B9B}"/>
+                <a16:creationId xmlns:a16="http://schemas.microsoft.com/office/drawing/2014/main" id="{D16874AD-5238-46C7-8341-1C46980A6F98}"/>
               </a:ext>
             </a:extLst>
           </p:cNvPr>
@@ -8915,7 +8915,7 @@
     </p:spTree>
     <p:extLst>
       <p:ext uri="{BB962C8B-B14F-4D97-AF65-F5344CB8AC3E}">
-        <p14:creationId xmlns:p14="http://schemas.microsoft.com/office/powerpoint/2010/main" val="1196708667"/>
+        <p14:creationId xmlns:p14="http://schemas.microsoft.com/office/powerpoint/2010/main" val="1054554022"/>
       </p:ext>
     </p:extLst>
   </p:cSld>

</xml_diff>